<commit_message>
Add Tsubota origin story to webinar and sales
</commit_message>
<xml_diff>
--- a/tsubota-21day-funnel-materials/assets/坪田_無料オンラインセミナー_47枚_ミーティング反映_20261026.pptx
+++ b/tsubota-21day-funnel-materials/assets/坪田_無料オンラインセミナー_47枚_ミーティング反映_20261026.pptx
@@ -2,59 +2,59 @@
 <file path=ppt/presentation.xml><?xml version="1.0" encoding="utf-8"?>
 <p:presentation xmlns:p="http://schemas.openxmlformats.org/presentationml/2006/main">
   <p:sldMasterIdLst>
-    <p:sldMasterId xmlns:r="http://schemas.openxmlformats.org/officeDocument/2006/relationships" id="2147483648" r:id="R3b94a84523cc4fb7"/>
+    <p:sldMasterId xmlns:r="http://schemas.openxmlformats.org/officeDocument/2006/relationships" id="2147483648" r:id="R718e9cbb003f4401"/>
   </p:sldMasterIdLst>
   <p:notesMasterIdLst>
-    <p:notesMasterId xmlns:r="http://schemas.openxmlformats.org/officeDocument/2006/relationships" r:id="Rec54fc7fcfeb409e"/>
+    <p:notesMasterId xmlns:r="http://schemas.openxmlformats.org/officeDocument/2006/relationships" r:id="Rb0485c4c66d44d0e"/>
   </p:notesMasterIdLst>
   <p:sldIdLst>
-    <p:sldId xmlns:r="http://schemas.openxmlformats.org/officeDocument/2006/relationships" id="256" r:id="Re1a6fb6c27e4495f"/>
-    <p:sldId xmlns:r="http://schemas.openxmlformats.org/officeDocument/2006/relationships" id="257" r:id="R4aaeb775c22e40f5"/>
-    <p:sldId xmlns:r="http://schemas.openxmlformats.org/officeDocument/2006/relationships" id="258" r:id="R528a354f7b8441a0"/>
-    <p:sldId xmlns:r="http://schemas.openxmlformats.org/officeDocument/2006/relationships" id="259" r:id="R20e1526b63354e42"/>
-    <p:sldId xmlns:r="http://schemas.openxmlformats.org/officeDocument/2006/relationships" id="260" r:id="R7ff15db3fddd4c19"/>
-    <p:sldId xmlns:r="http://schemas.openxmlformats.org/officeDocument/2006/relationships" id="261" r:id="Ra180577d79ce4593"/>
-    <p:sldId xmlns:r="http://schemas.openxmlformats.org/officeDocument/2006/relationships" id="262" r:id="Rd67ce62007804649"/>
-    <p:sldId xmlns:r="http://schemas.openxmlformats.org/officeDocument/2006/relationships" id="263" r:id="R83cd4e13346b4228"/>
-    <p:sldId xmlns:r="http://schemas.openxmlformats.org/officeDocument/2006/relationships" id="264" r:id="Rc74e687660244c31"/>
-    <p:sldId xmlns:r="http://schemas.openxmlformats.org/officeDocument/2006/relationships" id="265" r:id="Reb3569212bd24a4c"/>
-    <p:sldId xmlns:r="http://schemas.openxmlformats.org/officeDocument/2006/relationships" id="266" r:id="Rcf16b20f5e094a54"/>
-    <p:sldId xmlns:r="http://schemas.openxmlformats.org/officeDocument/2006/relationships" id="267" r:id="R35e8cd44e9fe42b7"/>
-    <p:sldId xmlns:r="http://schemas.openxmlformats.org/officeDocument/2006/relationships" id="268" r:id="R5f1913d820d44a8e"/>
-    <p:sldId xmlns:r="http://schemas.openxmlformats.org/officeDocument/2006/relationships" id="269" r:id="Rf3b9593fc70e4954"/>
-    <p:sldId xmlns:r="http://schemas.openxmlformats.org/officeDocument/2006/relationships" id="270" r:id="R84cc3fd1a26c4b96"/>
-    <p:sldId xmlns:r="http://schemas.openxmlformats.org/officeDocument/2006/relationships" id="271" r:id="Re5ae199663064da3"/>
-    <p:sldId xmlns:r="http://schemas.openxmlformats.org/officeDocument/2006/relationships" id="272" r:id="Rfb24409cbce949cc"/>
-    <p:sldId xmlns:r="http://schemas.openxmlformats.org/officeDocument/2006/relationships" id="273" r:id="Rd1b8a10352544d1d"/>
-    <p:sldId xmlns:r="http://schemas.openxmlformats.org/officeDocument/2006/relationships" id="274" r:id="Rd9d870fa6c14481f"/>
-    <p:sldId xmlns:r="http://schemas.openxmlformats.org/officeDocument/2006/relationships" id="275" r:id="Ra7d1469d27ba43c9"/>
-    <p:sldId xmlns:r="http://schemas.openxmlformats.org/officeDocument/2006/relationships" id="276" r:id="Rda1204183ca04206"/>
-    <p:sldId xmlns:r="http://schemas.openxmlformats.org/officeDocument/2006/relationships" id="277" r:id="R3ca4962ea65a4b48"/>
-    <p:sldId xmlns:r="http://schemas.openxmlformats.org/officeDocument/2006/relationships" id="278" r:id="Raabd27f580a44aa3"/>
-    <p:sldId xmlns:r="http://schemas.openxmlformats.org/officeDocument/2006/relationships" id="279" r:id="Rcbfbd5f2f49d4499"/>
-    <p:sldId xmlns:r="http://schemas.openxmlformats.org/officeDocument/2006/relationships" id="280" r:id="R0f32c7b3c70d46e7"/>
-    <p:sldId xmlns:r="http://schemas.openxmlformats.org/officeDocument/2006/relationships" id="281" r:id="Reee296ebb846472c"/>
-    <p:sldId xmlns:r="http://schemas.openxmlformats.org/officeDocument/2006/relationships" id="282" r:id="Rffd63ff8d40542eb"/>
-    <p:sldId xmlns:r="http://schemas.openxmlformats.org/officeDocument/2006/relationships" id="283" r:id="R918f388754364b2e"/>
-    <p:sldId xmlns:r="http://schemas.openxmlformats.org/officeDocument/2006/relationships" id="284" r:id="R4eb268e4b2464a2f"/>
-    <p:sldId xmlns:r="http://schemas.openxmlformats.org/officeDocument/2006/relationships" id="285" r:id="R6f85a906cd034561"/>
-    <p:sldId xmlns:r="http://schemas.openxmlformats.org/officeDocument/2006/relationships" id="286" r:id="R53f3762fc0a94ff6"/>
-    <p:sldId xmlns:r="http://schemas.openxmlformats.org/officeDocument/2006/relationships" id="287" r:id="R30384690122e4287"/>
-    <p:sldId xmlns:r="http://schemas.openxmlformats.org/officeDocument/2006/relationships" id="288" r:id="R8462eeb39a8e457e"/>
-    <p:sldId xmlns:r="http://schemas.openxmlformats.org/officeDocument/2006/relationships" id="289" r:id="R70b920a9ce474755"/>
-    <p:sldId xmlns:r="http://schemas.openxmlformats.org/officeDocument/2006/relationships" id="290" r:id="R3fb7430b82d447e8"/>
-    <p:sldId xmlns:r="http://schemas.openxmlformats.org/officeDocument/2006/relationships" id="291" r:id="R7af1c99bb0ec4203"/>
-    <p:sldId xmlns:r="http://schemas.openxmlformats.org/officeDocument/2006/relationships" id="292" r:id="R6bffa97f3b4e4dfb"/>
-    <p:sldId xmlns:r="http://schemas.openxmlformats.org/officeDocument/2006/relationships" id="293" r:id="Re273512b2719459a"/>
-    <p:sldId xmlns:r="http://schemas.openxmlformats.org/officeDocument/2006/relationships" id="294" r:id="R3d3dd274a9b74c8d"/>
-    <p:sldId xmlns:r="http://schemas.openxmlformats.org/officeDocument/2006/relationships" id="295" r:id="Re391b5bc7d204fce"/>
-    <p:sldId xmlns:r="http://schemas.openxmlformats.org/officeDocument/2006/relationships" id="296" r:id="Rdc2eaa84748147ae"/>
-    <p:sldId xmlns:r="http://schemas.openxmlformats.org/officeDocument/2006/relationships" id="297" r:id="Re44edcfa91d5430d"/>
-    <p:sldId xmlns:r="http://schemas.openxmlformats.org/officeDocument/2006/relationships" id="298" r:id="R6321ed201943470f"/>
-    <p:sldId xmlns:r="http://schemas.openxmlformats.org/officeDocument/2006/relationships" id="299" r:id="Rc62996ee1c7e4218"/>
-    <p:sldId xmlns:r="http://schemas.openxmlformats.org/officeDocument/2006/relationships" id="300" r:id="R84e5369775634072"/>
-    <p:sldId xmlns:r="http://schemas.openxmlformats.org/officeDocument/2006/relationships" id="301" r:id="Rb82bb8746f37472b"/>
-    <p:sldId xmlns:r="http://schemas.openxmlformats.org/officeDocument/2006/relationships" id="302" r:id="Rb997f6cc3b534e9f"/>
+    <p:sldId xmlns:r="http://schemas.openxmlformats.org/officeDocument/2006/relationships" id="256" r:id="Ra34c1e347f92475c"/>
+    <p:sldId xmlns:r="http://schemas.openxmlformats.org/officeDocument/2006/relationships" id="257" r:id="R05443ca004fa4e71"/>
+    <p:sldId xmlns:r="http://schemas.openxmlformats.org/officeDocument/2006/relationships" id="258" r:id="Ra88ee006c3824d70"/>
+    <p:sldId xmlns:r="http://schemas.openxmlformats.org/officeDocument/2006/relationships" id="259" r:id="R910bc9ba9d66403b"/>
+    <p:sldId xmlns:r="http://schemas.openxmlformats.org/officeDocument/2006/relationships" id="260" r:id="Rb308d4bae3524bd9"/>
+    <p:sldId xmlns:r="http://schemas.openxmlformats.org/officeDocument/2006/relationships" id="261" r:id="R74c9b069ad924e4d"/>
+    <p:sldId xmlns:r="http://schemas.openxmlformats.org/officeDocument/2006/relationships" id="262" r:id="R4ca6d41edcd24021"/>
+    <p:sldId xmlns:r="http://schemas.openxmlformats.org/officeDocument/2006/relationships" id="263" r:id="R0dc2c2ed96904da4"/>
+    <p:sldId xmlns:r="http://schemas.openxmlformats.org/officeDocument/2006/relationships" id="264" r:id="R519ebd43d4894a40"/>
+    <p:sldId xmlns:r="http://schemas.openxmlformats.org/officeDocument/2006/relationships" id="265" r:id="R08223551914841c3"/>
+    <p:sldId xmlns:r="http://schemas.openxmlformats.org/officeDocument/2006/relationships" id="266" r:id="Rfe588ade8c654c68"/>
+    <p:sldId xmlns:r="http://schemas.openxmlformats.org/officeDocument/2006/relationships" id="267" r:id="Rf78557a70474462f"/>
+    <p:sldId xmlns:r="http://schemas.openxmlformats.org/officeDocument/2006/relationships" id="268" r:id="Rba5b4e14da1e4919"/>
+    <p:sldId xmlns:r="http://schemas.openxmlformats.org/officeDocument/2006/relationships" id="269" r:id="R9ec7fb22a79a4048"/>
+    <p:sldId xmlns:r="http://schemas.openxmlformats.org/officeDocument/2006/relationships" id="270" r:id="R8f9fa737191a4c7e"/>
+    <p:sldId xmlns:r="http://schemas.openxmlformats.org/officeDocument/2006/relationships" id="271" r:id="Rc5306026743f48d8"/>
+    <p:sldId xmlns:r="http://schemas.openxmlformats.org/officeDocument/2006/relationships" id="272" r:id="R37eb26f753154d18"/>
+    <p:sldId xmlns:r="http://schemas.openxmlformats.org/officeDocument/2006/relationships" id="273" r:id="R925d56e47e234215"/>
+    <p:sldId xmlns:r="http://schemas.openxmlformats.org/officeDocument/2006/relationships" id="274" r:id="R2ad6329c05df4644"/>
+    <p:sldId xmlns:r="http://schemas.openxmlformats.org/officeDocument/2006/relationships" id="275" r:id="Ra1664cde50bf4c21"/>
+    <p:sldId xmlns:r="http://schemas.openxmlformats.org/officeDocument/2006/relationships" id="276" r:id="Raeb6701dd5bd400b"/>
+    <p:sldId xmlns:r="http://schemas.openxmlformats.org/officeDocument/2006/relationships" id="277" r:id="R4745a6473a7f4a6a"/>
+    <p:sldId xmlns:r="http://schemas.openxmlformats.org/officeDocument/2006/relationships" id="278" r:id="R6d172d4d609f4414"/>
+    <p:sldId xmlns:r="http://schemas.openxmlformats.org/officeDocument/2006/relationships" id="279" r:id="R119be67bf0724840"/>
+    <p:sldId xmlns:r="http://schemas.openxmlformats.org/officeDocument/2006/relationships" id="280" r:id="Rd4705da0627e4c87"/>
+    <p:sldId xmlns:r="http://schemas.openxmlformats.org/officeDocument/2006/relationships" id="281" r:id="Rb7e35366b2e948e5"/>
+    <p:sldId xmlns:r="http://schemas.openxmlformats.org/officeDocument/2006/relationships" id="282" r:id="R4a636865aaad469d"/>
+    <p:sldId xmlns:r="http://schemas.openxmlformats.org/officeDocument/2006/relationships" id="283" r:id="R90f33caa4a5f4bb4"/>
+    <p:sldId xmlns:r="http://schemas.openxmlformats.org/officeDocument/2006/relationships" id="284" r:id="Re86c5c61a0bf4711"/>
+    <p:sldId xmlns:r="http://schemas.openxmlformats.org/officeDocument/2006/relationships" id="285" r:id="R790c6daf4f4f41d9"/>
+    <p:sldId xmlns:r="http://schemas.openxmlformats.org/officeDocument/2006/relationships" id="286" r:id="Rd4f905cbe54e4b8c"/>
+    <p:sldId xmlns:r="http://schemas.openxmlformats.org/officeDocument/2006/relationships" id="287" r:id="R6bf6ae9df8a14e43"/>
+    <p:sldId xmlns:r="http://schemas.openxmlformats.org/officeDocument/2006/relationships" id="288" r:id="Rd0f067e11d804fe8"/>
+    <p:sldId xmlns:r="http://schemas.openxmlformats.org/officeDocument/2006/relationships" id="289" r:id="R262ec8dc01744137"/>
+    <p:sldId xmlns:r="http://schemas.openxmlformats.org/officeDocument/2006/relationships" id="290" r:id="Rd282f92725644aee"/>
+    <p:sldId xmlns:r="http://schemas.openxmlformats.org/officeDocument/2006/relationships" id="291" r:id="R3686752fafac4bf8"/>
+    <p:sldId xmlns:r="http://schemas.openxmlformats.org/officeDocument/2006/relationships" id="292" r:id="R551636e5324e471a"/>
+    <p:sldId xmlns:r="http://schemas.openxmlformats.org/officeDocument/2006/relationships" id="293" r:id="Rb8af5fc8913543d7"/>
+    <p:sldId xmlns:r="http://schemas.openxmlformats.org/officeDocument/2006/relationships" id="294" r:id="R1f4c9fd0af814a1a"/>
+    <p:sldId xmlns:r="http://schemas.openxmlformats.org/officeDocument/2006/relationships" id="295" r:id="Rb36ad334d72d4254"/>
+    <p:sldId xmlns:r="http://schemas.openxmlformats.org/officeDocument/2006/relationships" id="296" r:id="R194318fc48164118"/>
+    <p:sldId xmlns:r="http://schemas.openxmlformats.org/officeDocument/2006/relationships" id="297" r:id="R83f1d837929f4aa8"/>
+    <p:sldId xmlns:r="http://schemas.openxmlformats.org/officeDocument/2006/relationships" id="298" r:id="Ra8951d17ffc847db"/>
+    <p:sldId xmlns:r="http://schemas.openxmlformats.org/officeDocument/2006/relationships" id="299" r:id="R71ae3487bc0442fe"/>
+    <p:sldId xmlns:r="http://schemas.openxmlformats.org/officeDocument/2006/relationships" id="300" r:id="R08bcd4e4bd104180"/>
+    <p:sldId xmlns:r="http://schemas.openxmlformats.org/officeDocument/2006/relationships" id="301" r:id="Raf944e0c61114932"/>
+    <p:sldId xmlns:r="http://schemas.openxmlformats.org/officeDocument/2006/relationships" id="302" r:id="Rac799cafbeb34f8f"/>
   </p:sldIdLst>
   <p:sldSz cx="12192000" cy="6858000"/>
   <p:notesSz cx="6858000" cy="9144000"/>
@@ -3638,7 +3638,7 @@
           <a:lstStyle xmlns:a="http://schemas.openxmlformats.org/drawingml/2006/main"/>
           <a:p xmlns:a="http://schemas.openxmlformats.org/drawingml/2006/main">
             <a:r>
-              <a:t>大手企業での研修、英語コーチング、講師育成の経験を話す。実績は講座成果の保証として使わない。</a:t>
+              <a:t>2026-10-26の坪田さん本人のミーティング談。girlの細かな音の再現は本人の収録で決める。企業研修・コーチング・講師指導の実績は前後の発話で話す。</a:t>
             </a:r>
           </a:p>
           <a:p xmlns:a="http://schemas.openxmlformats.org/drawingml/2006/main">
@@ -3990,7 +3990,7 @@
           <p:cNvPr id="3" name="Title">
             <a:extLst xmlns:a="http://schemas.openxmlformats.org/drawingml/2006/main">
               <a:ext uri="{FF2B5EF4-FFF2-40B4-BE49-F238E27FC236}">
-                <a16:creationId xmlns:a16="http://schemas.microsoft.com/office/drawing/2014/main" id="{FF40C8CB-1612-44EA-9FB7-F6784133582C}"/>
+                <a16:creationId xmlns:a16="http://schemas.microsoft.com/office/drawing/2014/main" id="{0964527F-1DC5-4FE4-8B2F-0450D2F319D9}"/>
               </a:ext>
             </a:extLst>
           </p:cNvPr>
@@ -4219,7 +4219,7 @@
           <p:cNvPr id="2" name="Subtitle">
             <a:extLst xmlns:a="http://schemas.openxmlformats.org/drawingml/2006/main">
               <a:ext uri="{FF2B5EF4-FFF2-40B4-BE49-F238E27FC236}">
-                <a16:creationId xmlns:a16="http://schemas.microsoft.com/office/drawing/2014/main" id="{C1B02889-74BA-4455-B2EB-6D48C686E30D}"/>
+                <a16:creationId xmlns:a16="http://schemas.microsoft.com/office/drawing/2014/main" id="{ABEF3691-CE02-4295-9E99-F6487EE785AD}"/>
               </a:ext>
             </a:extLst>
           </p:cNvPr>
@@ -4465,7 +4465,7 @@
           <p:cNvPr id="2" name="Section title">
             <a:extLst xmlns:a="http://schemas.openxmlformats.org/drawingml/2006/main">
               <a:ext uri="{FF2B5EF4-FFF2-40B4-BE49-F238E27FC236}">
-                <a16:creationId xmlns:a16="http://schemas.microsoft.com/office/drawing/2014/main" id="{DEB084F1-13A9-4741-AA5B-EA5ADC8B693C}"/>
+                <a16:creationId xmlns:a16="http://schemas.microsoft.com/office/drawing/2014/main" id="{8509D655-5E13-48A4-A83B-B917CC2B34ED}"/>
               </a:ext>
             </a:extLst>
           </p:cNvPr>
@@ -4711,7 +4711,7 @@
           <p:cNvPr id="3" name="Title">
             <a:extLst xmlns:a="http://schemas.openxmlformats.org/drawingml/2006/main">
               <a:ext uri="{FF2B5EF4-FFF2-40B4-BE49-F238E27FC236}">
-                <a16:creationId xmlns:a16="http://schemas.microsoft.com/office/drawing/2014/main" id="{BAE9B9F2-DDE0-4941-9054-6D2462A3D508}"/>
+                <a16:creationId xmlns:a16="http://schemas.microsoft.com/office/drawing/2014/main" id="{C4BA4C67-FADA-4FFC-82E7-50BDA02CCF58}"/>
               </a:ext>
             </a:extLst>
           </p:cNvPr>
@@ -4940,7 +4940,7 @@
           <p:cNvPr id="2" name="Body">
             <a:extLst xmlns:a="http://schemas.openxmlformats.org/drawingml/2006/main">
               <a:ext uri="{FF2B5EF4-FFF2-40B4-BE49-F238E27FC236}">
-                <a16:creationId xmlns:a16="http://schemas.microsoft.com/office/drawing/2014/main" id="{876AC499-167A-4F8F-870B-4A2BFF9B09DC}"/>
+                <a16:creationId xmlns:a16="http://schemas.microsoft.com/office/drawing/2014/main" id="{8B26D5EF-EDB8-4C4D-AB4D-ECB4F99F2B1D}"/>
               </a:ext>
             </a:extLst>
           </p:cNvPr>
@@ -5186,7 +5186,7 @@
           <p:cNvPr id="4" name="Title">
             <a:extLst xmlns:a="http://schemas.openxmlformats.org/drawingml/2006/main">
               <a:ext uri="{FF2B5EF4-FFF2-40B4-BE49-F238E27FC236}">
-                <a16:creationId xmlns:a16="http://schemas.microsoft.com/office/drawing/2014/main" id="{F2AB59BE-E9B0-48C8-813A-842CB5F7CD3C}"/>
+                <a16:creationId xmlns:a16="http://schemas.microsoft.com/office/drawing/2014/main" id="{119F81D9-CCB1-4EAA-9679-A04BD90352AB}"/>
               </a:ext>
             </a:extLst>
           </p:cNvPr>
@@ -5415,7 +5415,7 @@
           <p:cNvPr id="2" name="Left column">
             <a:extLst xmlns:a="http://schemas.openxmlformats.org/drawingml/2006/main">
               <a:ext uri="{FF2B5EF4-FFF2-40B4-BE49-F238E27FC236}">
-                <a16:creationId xmlns:a16="http://schemas.microsoft.com/office/drawing/2014/main" id="{0A7BAFBA-ACE4-4FC5-BAD6-200AB9D30CCF}"/>
+                <a16:creationId xmlns:a16="http://schemas.microsoft.com/office/drawing/2014/main" id="{9968763D-DC6F-4A75-AFD2-C6F377F8AD3A}"/>
               </a:ext>
             </a:extLst>
           </p:cNvPr>
@@ -5644,7 +5644,7 @@
           <p:cNvPr id="3" name="Right column">
             <a:extLst xmlns:a="http://schemas.openxmlformats.org/drawingml/2006/main">
               <a:ext uri="{FF2B5EF4-FFF2-40B4-BE49-F238E27FC236}">
-                <a16:creationId xmlns:a16="http://schemas.microsoft.com/office/drawing/2014/main" id="{3FEF7B0B-ADF5-4884-BBFA-CAF32943321A}"/>
+                <a16:creationId xmlns:a16="http://schemas.microsoft.com/office/drawing/2014/main" id="{02B388BD-FBD3-46D0-A16A-7F06A5096C17}"/>
               </a:ext>
             </a:extLst>
           </p:cNvPr>
@@ -5890,7 +5890,7 @@
           <p:cNvPr id="3" name="Title">
             <a:extLst xmlns:a="http://schemas.openxmlformats.org/drawingml/2006/main">
               <a:ext uri="{FF2B5EF4-FFF2-40B4-BE49-F238E27FC236}">
-                <a16:creationId xmlns:a16="http://schemas.microsoft.com/office/drawing/2014/main" id="{74EE2E3A-9537-4E4D-8CD1-CADC0CAEF19A}"/>
+                <a16:creationId xmlns:a16="http://schemas.microsoft.com/office/drawing/2014/main" id="{B088E9F1-E65D-4570-BD25-000A7C7AB115}"/>
               </a:ext>
             </a:extLst>
           </p:cNvPr>
@@ -6119,7 +6119,7 @@
           <p:cNvPr id="2" name="Left column">
             <a:extLst xmlns:a="http://schemas.openxmlformats.org/drawingml/2006/main">
               <a:ext uri="{FF2B5EF4-FFF2-40B4-BE49-F238E27FC236}">
-                <a16:creationId xmlns:a16="http://schemas.microsoft.com/office/drawing/2014/main" id="{F63EAE7F-36D4-4B95-8F81-5F9FCA274269}"/>
+                <a16:creationId xmlns:a16="http://schemas.microsoft.com/office/drawing/2014/main" id="{CC072DF5-CAD6-4098-A2C7-18D2049C725D}"/>
               </a:ext>
             </a:extLst>
           </p:cNvPr>
@@ -6386,12 +6386,12 @@
   </p:cSld>
   <p:clrMap bg1="lt1" tx1="dk1" bg2="lt2" tx2="dk2" accent1="accent1" accent2="accent2" accent3="accent3" accent4="accent4" accent5="accent5" accent6="accent6" hlink="hlink" folHlink="folHlink"/>
   <p:sldLayoutIdLst>
-    <p:sldLayoutId xmlns:r="http://schemas.openxmlformats.org/officeDocument/2006/relationships" id="2147483649" r:id="R6801d6bde4b74c6d"/>
-    <p:sldLayoutId xmlns:r="http://schemas.openxmlformats.org/officeDocument/2006/relationships" id="2147483650" r:id="Rf3c966deee7b452c"/>
-    <p:sldLayoutId xmlns:r="http://schemas.openxmlformats.org/officeDocument/2006/relationships" id="2147483651" r:id="Rce2cac9736fc4bdd"/>
-    <p:sldLayoutId xmlns:r="http://schemas.openxmlformats.org/officeDocument/2006/relationships" id="2147483652" r:id="Rdfbf0724fb244928"/>
-    <p:sldLayoutId xmlns:r="http://schemas.openxmlformats.org/officeDocument/2006/relationships" id="2147483653" r:id="Rf4e9fea8fd334fa3"/>
-    <p:sldLayoutId xmlns:r="http://schemas.openxmlformats.org/officeDocument/2006/relationships" id="2147483654" r:id="Rea8d03204e2144fc"/>
+    <p:sldLayoutId xmlns:r="http://schemas.openxmlformats.org/officeDocument/2006/relationships" id="2147483649" r:id="R7a85354eea07466a"/>
+    <p:sldLayoutId xmlns:r="http://schemas.openxmlformats.org/officeDocument/2006/relationships" id="2147483650" r:id="R448d1c7351044bb5"/>
+    <p:sldLayoutId xmlns:r="http://schemas.openxmlformats.org/officeDocument/2006/relationships" id="2147483651" r:id="R5882f67304244cda"/>
+    <p:sldLayoutId xmlns:r="http://schemas.openxmlformats.org/officeDocument/2006/relationships" id="2147483652" r:id="R888eaf1421454f86"/>
+    <p:sldLayoutId xmlns:r="http://schemas.openxmlformats.org/officeDocument/2006/relationships" id="2147483653" r:id="R34521c4cce0d474c"/>
+    <p:sldLayoutId xmlns:r="http://schemas.openxmlformats.org/officeDocument/2006/relationships" id="2147483654" r:id="Re5759258e8f44308"/>
   </p:sldLayoutIdLst>
   <p:txStyles>
     <p:titleStyle>
@@ -6942,7 +6942,7 @@
           <p:cNvPr id="8" name="">
             <a:extLst xmlns:a="http://schemas.openxmlformats.org/drawingml/2006/main">
               <a:ext uri="{FF2B5EF4-FFF2-40B4-BE49-F238E27FC236}">
-                <a16:creationId xmlns:a16="http://schemas.microsoft.com/office/drawing/2014/main" id="{4032353F-2AC5-441C-A178-A47F45FADB7A}"/>
+                <a16:creationId xmlns:a16="http://schemas.microsoft.com/office/drawing/2014/main" id="{04D3CD7A-01C4-4FD7-8A2C-726DE0664401}"/>
               </a:ext>
             </a:extLst>
           </p:cNvPr>
@@ -6973,7 +6973,7 @@
           <p:cNvPr id="2" name="">
             <a:extLst xmlns:a="http://schemas.openxmlformats.org/drawingml/2006/main">
               <a:ext uri="{FF2B5EF4-FFF2-40B4-BE49-F238E27FC236}">
-                <a16:creationId xmlns:a16="http://schemas.microsoft.com/office/drawing/2014/main" id="{C8E069E4-96F1-440E-BB8F-F7360542BD96}"/>
+                <a16:creationId xmlns:a16="http://schemas.microsoft.com/office/drawing/2014/main" id="{E54D2095-76B3-4AB8-B2BA-1B8180ACB164}"/>
               </a:ext>
             </a:extLst>
           </p:cNvPr>
@@ -7004,7 +7004,7 @@
           <p:cNvPr id="3" name="">
             <a:extLst xmlns:a="http://schemas.openxmlformats.org/drawingml/2006/main">
               <a:ext uri="{FF2B5EF4-FFF2-40B4-BE49-F238E27FC236}">
-                <a16:creationId xmlns:a16="http://schemas.microsoft.com/office/drawing/2014/main" id="{6A74B61F-D4D2-4545-BF90-27A46AC4041C}"/>
+                <a16:creationId xmlns:a16="http://schemas.microsoft.com/office/drawing/2014/main" id="{FAB98CC3-6D19-41A2-AFCD-106642A6F190}"/>
               </a:ext>
             </a:extLst>
           </p:cNvPr>
@@ -7161,7 +7161,7 @@
           <p:cNvPr id="4" name="">
             <a:extLst xmlns:a="http://schemas.openxmlformats.org/drawingml/2006/main">
               <a:ext uri="{FF2B5EF4-FFF2-40B4-BE49-F238E27FC236}">
-                <a16:creationId xmlns:a16="http://schemas.microsoft.com/office/drawing/2014/main" id="{EE76EED2-E9D0-4035-BAD7-9D0BE95EA7AB}"/>
+                <a16:creationId xmlns:a16="http://schemas.microsoft.com/office/drawing/2014/main" id="{3E6B8339-7E5D-466A-B62F-0061BEEE9235}"/>
               </a:ext>
             </a:extLst>
           </p:cNvPr>
@@ -7341,7 +7341,7 @@
           <p:cNvPr id="5" name="">
             <a:extLst xmlns:a="http://schemas.openxmlformats.org/drawingml/2006/main">
               <a:ext uri="{FF2B5EF4-FFF2-40B4-BE49-F238E27FC236}">
-                <a16:creationId xmlns:a16="http://schemas.microsoft.com/office/drawing/2014/main" id="{888ED444-6CEC-43B8-B434-E93E3776B163}"/>
+                <a16:creationId xmlns:a16="http://schemas.microsoft.com/office/drawing/2014/main" id="{074071E9-B909-452C-BA70-FDFBDE7AC6F4}"/>
               </a:ext>
             </a:extLst>
           </p:cNvPr>
@@ -7372,7 +7372,7 @@
           <p:cNvPr id="6" name="">
             <a:extLst xmlns:a="http://schemas.openxmlformats.org/drawingml/2006/main">
               <a:ext uri="{FF2B5EF4-FFF2-40B4-BE49-F238E27FC236}">
-                <a16:creationId xmlns:a16="http://schemas.microsoft.com/office/drawing/2014/main" id="{039D1CCE-84E3-4941-8A64-2021541814FA}"/>
+                <a16:creationId xmlns:a16="http://schemas.microsoft.com/office/drawing/2014/main" id="{418C2A12-0FC8-4564-8C2C-7FC46C063F70}"/>
               </a:ext>
             </a:extLst>
           </p:cNvPr>
@@ -7552,7 +7552,7 @@
           <p:cNvPr id="7" name="">
             <a:extLst xmlns:a="http://schemas.openxmlformats.org/drawingml/2006/main">
               <a:ext uri="{FF2B5EF4-FFF2-40B4-BE49-F238E27FC236}">
-                <a16:creationId xmlns:a16="http://schemas.microsoft.com/office/drawing/2014/main" id="{200B7140-7A65-4C2A-9ECE-F55295D746C4}"/>
+                <a16:creationId xmlns:a16="http://schemas.microsoft.com/office/drawing/2014/main" id="{AB9EA5E3-5C53-44C5-B1E8-8F666082D4B0}"/>
               </a:ext>
             </a:extLst>
           </p:cNvPr>
@@ -7707,7 +7707,7 @@
     </p:spTree>
     <p:extLst>
       <p:ext uri="{BB962C8B-B14F-4D97-AF65-F5344CB8AC3E}">
-        <p14:creationId xmlns:p14="http://schemas.microsoft.com/office/powerpoint/2010/main" val="670130720"/>
+        <p14:creationId xmlns:p14="http://schemas.microsoft.com/office/powerpoint/2010/main" val="1429610614"/>
       </p:ext>
     </p:extLst>
   </p:cSld>
@@ -7738,7 +7738,7 @@
           <p:cNvPr id="7" name="">
             <a:extLst xmlns:a="http://schemas.openxmlformats.org/drawingml/2006/main">
               <a:ext uri="{FF2B5EF4-FFF2-40B4-BE49-F238E27FC236}">
-                <a16:creationId xmlns:a16="http://schemas.microsoft.com/office/drawing/2014/main" id="{186CFA1F-79AA-410C-9BF1-CBC4DE3D9458}"/>
+                <a16:creationId xmlns:a16="http://schemas.microsoft.com/office/drawing/2014/main" id="{26769F10-E561-4978-8E8D-A30B69714FE0}"/>
               </a:ext>
             </a:extLst>
           </p:cNvPr>
@@ -7769,7 +7769,7 @@
           <p:cNvPr id="2" name="">
             <a:extLst xmlns:a="http://schemas.openxmlformats.org/drawingml/2006/main">
               <a:ext uri="{FF2B5EF4-FFF2-40B4-BE49-F238E27FC236}">
-                <a16:creationId xmlns:a16="http://schemas.microsoft.com/office/drawing/2014/main" id="{AB10C6AD-1255-4C81-9074-9D011EAB9294}"/>
+                <a16:creationId xmlns:a16="http://schemas.microsoft.com/office/drawing/2014/main" id="{BE2F7D3C-8A1B-4497-8CCE-A9B8196A4DB6}"/>
               </a:ext>
             </a:extLst>
           </p:cNvPr>
@@ -7800,7 +7800,7 @@
           <p:cNvPr id="3" name="">
             <a:extLst xmlns:a="http://schemas.openxmlformats.org/drawingml/2006/main">
               <a:ext uri="{FF2B5EF4-FFF2-40B4-BE49-F238E27FC236}">
-                <a16:creationId xmlns:a16="http://schemas.microsoft.com/office/drawing/2014/main" id="{DD2AB6DA-B88D-4EE4-A388-7280C4A727C9}"/>
+                <a16:creationId xmlns:a16="http://schemas.microsoft.com/office/drawing/2014/main" id="{9916CB3B-3DA9-4B60-B3C4-8145D4FADF29}"/>
               </a:ext>
             </a:extLst>
           </p:cNvPr>
@@ -7980,7 +7980,7 @@
           <p:cNvPr id="4" name="">
             <a:extLst xmlns:a="http://schemas.openxmlformats.org/drawingml/2006/main">
               <a:ext uri="{FF2B5EF4-FFF2-40B4-BE49-F238E27FC236}">
-                <a16:creationId xmlns:a16="http://schemas.microsoft.com/office/drawing/2014/main" id="{A4D3A783-03EC-4647-8C67-3A064E12BFF4}"/>
+                <a16:creationId xmlns:a16="http://schemas.microsoft.com/office/drawing/2014/main" id="{A1099381-F0CC-4706-8199-DB3ECB9DF9F4}"/>
               </a:ext>
             </a:extLst>
           </p:cNvPr>
@@ -8011,7 +8011,7 @@
           <p:cNvPr id="5" name="">
             <a:extLst xmlns:a="http://schemas.openxmlformats.org/drawingml/2006/main">
               <a:ext uri="{FF2B5EF4-FFF2-40B4-BE49-F238E27FC236}">
-                <a16:creationId xmlns:a16="http://schemas.microsoft.com/office/drawing/2014/main" id="{B592E1EF-260E-49CF-AAD8-5EF6BC0B6A5A}"/>
+                <a16:creationId xmlns:a16="http://schemas.microsoft.com/office/drawing/2014/main" id="{3A023D4D-3323-4257-B26E-F79886166B6A}"/>
               </a:ext>
             </a:extLst>
           </p:cNvPr>
@@ -8168,7 +8168,7 @@
           <p:cNvPr id="6" name="">
             <a:extLst xmlns:a="http://schemas.openxmlformats.org/drawingml/2006/main">
               <a:ext uri="{FF2B5EF4-FFF2-40B4-BE49-F238E27FC236}">
-                <a16:creationId xmlns:a16="http://schemas.microsoft.com/office/drawing/2014/main" id="{A5741214-17E1-42D7-8C48-3D52E3DEB893}"/>
+                <a16:creationId xmlns:a16="http://schemas.microsoft.com/office/drawing/2014/main" id="{A8766AFE-8817-48A1-BA9E-C8A619A329F6}"/>
               </a:ext>
             </a:extLst>
           </p:cNvPr>
@@ -8323,7 +8323,7 @@
     </p:spTree>
     <p:extLst>
       <p:ext uri="{BB962C8B-B14F-4D97-AF65-F5344CB8AC3E}">
-        <p14:creationId xmlns:p14="http://schemas.microsoft.com/office/powerpoint/2010/main" val="2147051660"/>
+        <p14:creationId xmlns:p14="http://schemas.microsoft.com/office/powerpoint/2010/main" val="745474559"/>
       </p:ext>
     </p:extLst>
   </p:cSld>
@@ -8354,7 +8354,7 @@
           <p:cNvPr id="7" name="">
             <a:extLst xmlns:a="http://schemas.openxmlformats.org/drawingml/2006/main">
               <a:ext uri="{FF2B5EF4-FFF2-40B4-BE49-F238E27FC236}">
-                <a16:creationId xmlns:a16="http://schemas.microsoft.com/office/drawing/2014/main" id="{0BF5CF70-E9D6-4404-9317-FFCFE857C601}"/>
+                <a16:creationId xmlns:a16="http://schemas.microsoft.com/office/drawing/2014/main" id="{E63E9C3D-50FC-4964-919A-0E509B78F5E8}"/>
               </a:ext>
             </a:extLst>
           </p:cNvPr>
@@ -8385,7 +8385,7 @@
           <p:cNvPr id="2" name="">
             <a:extLst xmlns:a="http://schemas.openxmlformats.org/drawingml/2006/main">
               <a:ext uri="{FF2B5EF4-FFF2-40B4-BE49-F238E27FC236}">
-                <a16:creationId xmlns:a16="http://schemas.microsoft.com/office/drawing/2014/main" id="{AACFCE15-84B9-4623-A3B2-D9E3EECFEC1A}"/>
+                <a16:creationId xmlns:a16="http://schemas.microsoft.com/office/drawing/2014/main" id="{7B104C8C-F4A6-46BE-A618-C01620B8DC40}"/>
               </a:ext>
             </a:extLst>
           </p:cNvPr>
@@ -8416,7 +8416,7 @@
           <p:cNvPr id="3" name="">
             <a:extLst xmlns:a="http://schemas.openxmlformats.org/drawingml/2006/main">
               <a:ext uri="{FF2B5EF4-FFF2-40B4-BE49-F238E27FC236}">
-                <a16:creationId xmlns:a16="http://schemas.microsoft.com/office/drawing/2014/main" id="{79BC5582-15BA-473C-A40C-D920C3EA96A1}"/>
+                <a16:creationId xmlns:a16="http://schemas.microsoft.com/office/drawing/2014/main" id="{37B8BB0B-D416-4B3B-ACF4-C3EA50E75D41}"/>
               </a:ext>
             </a:extLst>
           </p:cNvPr>
@@ -8596,7 +8596,7 @@
           <p:cNvPr id="4" name="">
             <a:extLst xmlns:a="http://schemas.openxmlformats.org/drawingml/2006/main">
               <a:ext uri="{FF2B5EF4-FFF2-40B4-BE49-F238E27FC236}">
-                <a16:creationId xmlns:a16="http://schemas.microsoft.com/office/drawing/2014/main" id="{8F3B7FFA-E0B7-42ED-B1C3-651351EA4611}"/>
+                <a16:creationId xmlns:a16="http://schemas.microsoft.com/office/drawing/2014/main" id="{026E9DC4-FEDF-4789-91B9-4F72B9A8A6D7}"/>
               </a:ext>
             </a:extLst>
           </p:cNvPr>
@@ -8627,7 +8627,7 @@
           <p:cNvPr id="5" name="">
             <a:extLst xmlns:a="http://schemas.openxmlformats.org/drawingml/2006/main">
               <a:ext uri="{FF2B5EF4-FFF2-40B4-BE49-F238E27FC236}">
-                <a16:creationId xmlns:a16="http://schemas.microsoft.com/office/drawing/2014/main" id="{A497E5FE-4057-475C-A683-C897517B202A}"/>
+                <a16:creationId xmlns:a16="http://schemas.microsoft.com/office/drawing/2014/main" id="{40E6874D-E134-4C3D-82A1-E4A91CD987A3}"/>
               </a:ext>
             </a:extLst>
           </p:cNvPr>
@@ -8784,7 +8784,7 @@
           <p:cNvPr id="6" name="">
             <a:extLst xmlns:a="http://schemas.openxmlformats.org/drawingml/2006/main">
               <a:ext uri="{FF2B5EF4-FFF2-40B4-BE49-F238E27FC236}">
-                <a16:creationId xmlns:a16="http://schemas.microsoft.com/office/drawing/2014/main" id="{61567178-BFBC-467E-8B56-122B9ED6164A}"/>
+                <a16:creationId xmlns:a16="http://schemas.microsoft.com/office/drawing/2014/main" id="{05A6DF01-313F-4469-AA0B-FFF3EFFF4C7E}"/>
               </a:ext>
             </a:extLst>
           </p:cNvPr>
@@ -8939,7 +8939,7 @@
     </p:spTree>
     <p:extLst>
       <p:ext uri="{BB962C8B-B14F-4D97-AF65-F5344CB8AC3E}">
-        <p14:creationId xmlns:p14="http://schemas.microsoft.com/office/powerpoint/2010/main" val="1849271269"/>
+        <p14:creationId xmlns:p14="http://schemas.microsoft.com/office/powerpoint/2010/main" val="481482301"/>
       </p:ext>
     </p:extLst>
   </p:cSld>
@@ -8970,7 +8970,7 @@
           <p:cNvPr id="13" name="">
             <a:extLst xmlns:a="http://schemas.openxmlformats.org/drawingml/2006/main">
               <a:ext uri="{FF2B5EF4-FFF2-40B4-BE49-F238E27FC236}">
-                <a16:creationId xmlns:a16="http://schemas.microsoft.com/office/drawing/2014/main" id="{15581AEE-4830-40A3-980F-E32E4F4A8BA4}"/>
+                <a16:creationId xmlns:a16="http://schemas.microsoft.com/office/drawing/2014/main" id="{30537E55-7719-4B0A-9C37-453821546F53}"/>
               </a:ext>
             </a:extLst>
           </p:cNvPr>
@@ -9001,7 +9001,7 @@
           <p:cNvPr id="2" name="">
             <a:extLst xmlns:a="http://schemas.openxmlformats.org/drawingml/2006/main">
               <a:ext uri="{FF2B5EF4-FFF2-40B4-BE49-F238E27FC236}">
-                <a16:creationId xmlns:a16="http://schemas.microsoft.com/office/drawing/2014/main" id="{122D360C-0B8C-40AC-8D78-096874377028}"/>
+                <a16:creationId xmlns:a16="http://schemas.microsoft.com/office/drawing/2014/main" id="{421D5DE2-30C4-4DD9-B031-B8AF57BBB409}"/>
               </a:ext>
             </a:extLst>
           </p:cNvPr>
@@ -9032,7 +9032,7 @@
           <p:cNvPr id="3" name="">
             <a:extLst xmlns:a="http://schemas.openxmlformats.org/drawingml/2006/main">
               <a:ext uri="{FF2B5EF4-FFF2-40B4-BE49-F238E27FC236}">
-                <a16:creationId xmlns:a16="http://schemas.microsoft.com/office/drawing/2014/main" id="{1B77CF6E-1D7A-4B24-B906-1589CEEB054D}"/>
+                <a16:creationId xmlns:a16="http://schemas.microsoft.com/office/drawing/2014/main" id="{3CB0D633-FE3C-4528-804D-AC29E344ADD3}"/>
               </a:ext>
             </a:extLst>
           </p:cNvPr>
@@ -9189,7 +9189,7 @@
           <p:cNvPr id="4" name="">
             <a:extLst xmlns:a="http://schemas.openxmlformats.org/drawingml/2006/main">
               <a:ext uri="{FF2B5EF4-FFF2-40B4-BE49-F238E27FC236}">
-                <a16:creationId xmlns:a16="http://schemas.microsoft.com/office/drawing/2014/main" id="{19E54DD4-CC00-44C5-9C86-208AC5202C0C}"/>
+                <a16:creationId xmlns:a16="http://schemas.microsoft.com/office/drawing/2014/main" id="{2467D154-8347-4829-86CE-DC0337CFA128}"/>
               </a:ext>
             </a:extLst>
           </p:cNvPr>
@@ -9220,7 +9220,7 @@
           <p:cNvPr id="5" name="">
             <a:extLst xmlns:a="http://schemas.openxmlformats.org/drawingml/2006/main">
               <a:ext uri="{FF2B5EF4-FFF2-40B4-BE49-F238E27FC236}">
-                <a16:creationId xmlns:a16="http://schemas.microsoft.com/office/drawing/2014/main" id="{C25918D9-27CF-4675-AD2C-35F519713300}"/>
+                <a16:creationId xmlns:a16="http://schemas.microsoft.com/office/drawing/2014/main" id="{08F0218C-2833-4EDB-9786-E2856CEE88C3}"/>
               </a:ext>
             </a:extLst>
           </p:cNvPr>
@@ -9377,7 +9377,7 @@
           <p:cNvPr id="6" name="">
             <a:extLst xmlns:a="http://schemas.openxmlformats.org/drawingml/2006/main">
               <a:ext uri="{FF2B5EF4-FFF2-40B4-BE49-F238E27FC236}">
-                <a16:creationId xmlns:a16="http://schemas.microsoft.com/office/drawing/2014/main" id="{1610DF72-5B36-495B-BA38-B147347C5006}"/>
+                <a16:creationId xmlns:a16="http://schemas.microsoft.com/office/drawing/2014/main" id="{BCDD0732-0120-4877-AA5C-1E4A25D0608A}"/>
               </a:ext>
             </a:extLst>
           </p:cNvPr>
@@ -9408,7 +9408,7 @@
           <p:cNvPr id="7" name="">
             <a:extLst xmlns:a="http://schemas.openxmlformats.org/drawingml/2006/main">
               <a:ext uri="{FF2B5EF4-FFF2-40B4-BE49-F238E27FC236}">
-                <a16:creationId xmlns:a16="http://schemas.microsoft.com/office/drawing/2014/main" id="{D5AF8E33-EC02-4438-97EC-2250BD90BCCE}"/>
+                <a16:creationId xmlns:a16="http://schemas.microsoft.com/office/drawing/2014/main" id="{785F14AE-2458-4C32-9F27-B2B005B99279}"/>
               </a:ext>
             </a:extLst>
           </p:cNvPr>
@@ -9565,7 +9565,7 @@
           <p:cNvPr id="8" name="">
             <a:extLst xmlns:a="http://schemas.openxmlformats.org/drawingml/2006/main">
               <a:ext uri="{FF2B5EF4-FFF2-40B4-BE49-F238E27FC236}">
-                <a16:creationId xmlns:a16="http://schemas.microsoft.com/office/drawing/2014/main" id="{5F4F146F-162C-4E62-A754-6CBAB4FC2028}"/>
+                <a16:creationId xmlns:a16="http://schemas.microsoft.com/office/drawing/2014/main" id="{DDF8FE99-37A5-4BA5-B643-AC71234A0684}"/>
               </a:ext>
             </a:extLst>
           </p:cNvPr>
@@ -9596,7 +9596,7 @@
           <p:cNvPr id="9" name="">
             <a:extLst xmlns:a="http://schemas.openxmlformats.org/drawingml/2006/main">
               <a:ext uri="{FF2B5EF4-FFF2-40B4-BE49-F238E27FC236}">
-                <a16:creationId xmlns:a16="http://schemas.microsoft.com/office/drawing/2014/main" id="{226CA2F2-7123-41AF-A36C-CE109ACD889D}"/>
+                <a16:creationId xmlns:a16="http://schemas.microsoft.com/office/drawing/2014/main" id="{984835CC-2E35-481B-AE3D-E31E731A7F7E}"/>
               </a:ext>
             </a:extLst>
           </p:cNvPr>
@@ -9753,7 +9753,7 @@
           <p:cNvPr id="10" name="">
             <a:extLst xmlns:a="http://schemas.openxmlformats.org/drawingml/2006/main">
               <a:ext uri="{FF2B5EF4-FFF2-40B4-BE49-F238E27FC236}">
-                <a16:creationId xmlns:a16="http://schemas.microsoft.com/office/drawing/2014/main" id="{073DAF93-770C-42DE-AB36-313901655095}"/>
+                <a16:creationId xmlns:a16="http://schemas.microsoft.com/office/drawing/2014/main" id="{8F24BC33-825B-400C-9F0F-52945F53BE78}"/>
               </a:ext>
             </a:extLst>
           </p:cNvPr>
@@ -9784,7 +9784,7 @@
           <p:cNvPr id="11" name="">
             <a:extLst xmlns:a="http://schemas.openxmlformats.org/drawingml/2006/main">
               <a:ext uri="{FF2B5EF4-FFF2-40B4-BE49-F238E27FC236}">
-                <a16:creationId xmlns:a16="http://schemas.microsoft.com/office/drawing/2014/main" id="{9D76F5BA-FFC5-4F8B-A836-63709622323D}"/>
+                <a16:creationId xmlns:a16="http://schemas.microsoft.com/office/drawing/2014/main" id="{0C1AB2CE-995E-4DB1-82E8-26C9D4C7B30F}"/>
               </a:ext>
             </a:extLst>
           </p:cNvPr>
@@ -9941,7 +9941,7 @@
           <p:cNvPr id="12" name="">
             <a:extLst xmlns:a="http://schemas.openxmlformats.org/drawingml/2006/main">
               <a:ext uri="{FF2B5EF4-FFF2-40B4-BE49-F238E27FC236}">
-                <a16:creationId xmlns:a16="http://schemas.microsoft.com/office/drawing/2014/main" id="{C17E9CFB-2379-49D3-80C5-169CCCE01A6F}"/>
+                <a16:creationId xmlns:a16="http://schemas.microsoft.com/office/drawing/2014/main" id="{56B621B1-7CB1-4076-8FC1-EFA64503E636}"/>
               </a:ext>
             </a:extLst>
           </p:cNvPr>
@@ -10096,7 +10096,7 @@
     </p:spTree>
     <p:extLst>
       <p:ext uri="{BB962C8B-B14F-4D97-AF65-F5344CB8AC3E}">
-        <p14:creationId xmlns:p14="http://schemas.microsoft.com/office/powerpoint/2010/main" val="835092287"/>
+        <p14:creationId xmlns:p14="http://schemas.microsoft.com/office/powerpoint/2010/main" val="361651274"/>
       </p:ext>
     </p:extLst>
   </p:cSld>
@@ -10127,7 +10127,7 @@
           <p:cNvPr id="7" name="">
             <a:extLst xmlns:a="http://schemas.openxmlformats.org/drawingml/2006/main">
               <a:ext uri="{FF2B5EF4-FFF2-40B4-BE49-F238E27FC236}">
-                <a16:creationId xmlns:a16="http://schemas.microsoft.com/office/drawing/2014/main" id="{C298401B-D170-4379-9822-CC5C79C77DBB}"/>
+                <a16:creationId xmlns:a16="http://schemas.microsoft.com/office/drawing/2014/main" id="{BC65F9BE-624A-4F63-B971-85E671B6A7FB}"/>
               </a:ext>
             </a:extLst>
           </p:cNvPr>
@@ -10158,7 +10158,7 @@
           <p:cNvPr id="2" name="">
             <a:extLst xmlns:a="http://schemas.openxmlformats.org/drawingml/2006/main">
               <a:ext uri="{FF2B5EF4-FFF2-40B4-BE49-F238E27FC236}">
-                <a16:creationId xmlns:a16="http://schemas.microsoft.com/office/drawing/2014/main" id="{0F2FCABA-E085-4911-837F-9D97B7007B8C}"/>
+                <a16:creationId xmlns:a16="http://schemas.microsoft.com/office/drawing/2014/main" id="{299DCD02-D9AD-4EFA-965F-CF4B8B42D7F4}"/>
               </a:ext>
             </a:extLst>
           </p:cNvPr>
@@ -10189,7 +10189,7 @@
           <p:cNvPr id="3" name="">
             <a:extLst xmlns:a="http://schemas.openxmlformats.org/drawingml/2006/main">
               <a:ext uri="{FF2B5EF4-FFF2-40B4-BE49-F238E27FC236}">
-                <a16:creationId xmlns:a16="http://schemas.microsoft.com/office/drawing/2014/main" id="{F963053D-2651-4C77-AECC-AFFDFFEF7E3C}"/>
+                <a16:creationId xmlns:a16="http://schemas.microsoft.com/office/drawing/2014/main" id="{F2A007D3-323D-449F-AF80-B289F1528DFC}"/>
               </a:ext>
             </a:extLst>
           </p:cNvPr>
@@ -10346,7 +10346,7 @@
           <p:cNvPr id="4" name="">
             <a:extLst xmlns:a="http://schemas.openxmlformats.org/drawingml/2006/main">
               <a:ext uri="{FF2B5EF4-FFF2-40B4-BE49-F238E27FC236}">
-                <a16:creationId xmlns:a16="http://schemas.microsoft.com/office/drawing/2014/main" id="{8AE19951-0612-47D7-A65A-8CEB5DE77918}"/>
+                <a16:creationId xmlns:a16="http://schemas.microsoft.com/office/drawing/2014/main" id="{A14B927D-5C4C-450E-AFFF-385643D2C02F}"/>
               </a:ext>
             </a:extLst>
           </p:cNvPr>
@@ -10377,7 +10377,7 @@
           <p:cNvPr id="5" name="">
             <a:extLst xmlns:a="http://schemas.openxmlformats.org/drawingml/2006/main">
               <a:ext uri="{FF2B5EF4-FFF2-40B4-BE49-F238E27FC236}">
-                <a16:creationId xmlns:a16="http://schemas.microsoft.com/office/drawing/2014/main" id="{DBCF1E57-EED9-45AD-8929-4A01AE5F25C3}"/>
+                <a16:creationId xmlns:a16="http://schemas.microsoft.com/office/drawing/2014/main" id="{6E213CA4-D0F8-43A4-898D-B16DBC3B3398}"/>
               </a:ext>
             </a:extLst>
           </p:cNvPr>
@@ -10534,7 +10534,7 @@
           <p:cNvPr id="6" name="">
             <a:extLst xmlns:a="http://schemas.openxmlformats.org/drawingml/2006/main">
               <a:ext uri="{FF2B5EF4-FFF2-40B4-BE49-F238E27FC236}">
-                <a16:creationId xmlns:a16="http://schemas.microsoft.com/office/drawing/2014/main" id="{2D0AE524-4425-45D0-B70C-5CFEE187177E}"/>
+                <a16:creationId xmlns:a16="http://schemas.microsoft.com/office/drawing/2014/main" id="{C876788A-FA71-4C5F-A10A-9025932C4667}"/>
               </a:ext>
             </a:extLst>
           </p:cNvPr>
@@ -10689,7 +10689,7 @@
     </p:spTree>
     <p:extLst>
       <p:ext uri="{BB962C8B-B14F-4D97-AF65-F5344CB8AC3E}">
-        <p14:creationId xmlns:p14="http://schemas.microsoft.com/office/powerpoint/2010/main" val="1499119884"/>
+        <p14:creationId xmlns:p14="http://schemas.microsoft.com/office/powerpoint/2010/main" val="1296384392"/>
       </p:ext>
     </p:extLst>
   </p:cSld>
@@ -10720,7 +10720,7 @@
           <p:cNvPr id="7" name="">
             <a:extLst xmlns:a="http://schemas.openxmlformats.org/drawingml/2006/main">
               <a:ext uri="{FF2B5EF4-FFF2-40B4-BE49-F238E27FC236}">
-                <a16:creationId xmlns:a16="http://schemas.microsoft.com/office/drawing/2014/main" id="{8D59FF65-610E-4EEC-8ABC-5D04DD2672EC}"/>
+                <a16:creationId xmlns:a16="http://schemas.microsoft.com/office/drawing/2014/main" id="{6F652400-5522-4900-8461-32DD5AA2E948}"/>
               </a:ext>
             </a:extLst>
           </p:cNvPr>
@@ -10751,7 +10751,7 @@
           <p:cNvPr id="2" name="">
             <a:extLst xmlns:a="http://schemas.openxmlformats.org/drawingml/2006/main">
               <a:ext uri="{FF2B5EF4-FFF2-40B4-BE49-F238E27FC236}">
-                <a16:creationId xmlns:a16="http://schemas.microsoft.com/office/drawing/2014/main" id="{BC5ADE3D-A891-4917-B7D5-F4C32DBF4A74}"/>
+                <a16:creationId xmlns:a16="http://schemas.microsoft.com/office/drawing/2014/main" id="{9716DC9F-422C-4543-8AD1-049CF9895AD7}"/>
               </a:ext>
             </a:extLst>
           </p:cNvPr>
@@ -10782,7 +10782,7 @@
           <p:cNvPr id="3" name="">
             <a:extLst xmlns:a="http://schemas.openxmlformats.org/drawingml/2006/main">
               <a:ext uri="{FF2B5EF4-FFF2-40B4-BE49-F238E27FC236}">
-                <a16:creationId xmlns:a16="http://schemas.microsoft.com/office/drawing/2014/main" id="{A5621F60-8CC6-4A6A-983C-36F84D73AE3C}"/>
+                <a16:creationId xmlns:a16="http://schemas.microsoft.com/office/drawing/2014/main" id="{44C35322-0A76-49DA-8100-E39062FCF879}"/>
               </a:ext>
             </a:extLst>
           </p:cNvPr>
@@ -10939,7 +10939,7 @@
           <p:cNvPr id="4" name="">
             <a:extLst xmlns:a="http://schemas.openxmlformats.org/drawingml/2006/main">
               <a:ext uri="{FF2B5EF4-FFF2-40B4-BE49-F238E27FC236}">
-                <a16:creationId xmlns:a16="http://schemas.microsoft.com/office/drawing/2014/main" id="{75445616-429E-4382-B995-EACE8A4F9835}"/>
+                <a16:creationId xmlns:a16="http://schemas.microsoft.com/office/drawing/2014/main" id="{FB9349F7-8F3F-48F8-B46A-C1A09F33EDC3}"/>
               </a:ext>
             </a:extLst>
           </p:cNvPr>
@@ -10970,7 +10970,7 @@
           <p:cNvPr id="5" name="">
             <a:extLst xmlns:a="http://schemas.openxmlformats.org/drawingml/2006/main">
               <a:ext uri="{FF2B5EF4-FFF2-40B4-BE49-F238E27FC236}">
-                <a16:creationId xmlns:a16="http://schemas.microsoft.com/office/drawing/2014/main" id="{B36FCDBE-3433-44CB-A5CD-A441B9FEA8C5}"/>
+                <a16:creationId xmlns:a16="http://schemas.microsoft.com/office/drawing/2014/main" id="{E691E896-F705-409D-ACD0-83383B87AF21}"/>
               </a:ext>
             </a:extLst>
           </p:cNvPr>
@@ -11127,7 +11127,7 @@
           <p:cNvPr id="6" name="">
             <a:extLst xmlns:a="http://schemas.openxmlformats.org/drawingml/2006/main">
               <a:ext uri="{FF2B5EF4-FFF2-40B4-BE49-F238E27FC236}">
-                <a16:creationId xmlns:a16="http://schemas.microsoft.com/office/drawing/2014/main" id="{34420BBA-DF43-4453-8468-44EA3D913D72}"/>
+                <a16:creationId xmlns:a16="http://schemas.microsoft.com/office/drawing/2014/main" id="{1E94190C-5B80-46B3-B3E3-A89B9F718EE6}"/>
               </a:ext>
             </a:extLst>
           </p:cNvPr>
@@ -11282,7 +11282,7 @@
     </p:spTree>
     <p:extLst>
       <p:ext uri="{BB962C8B-B14F-4D97-AF65-F5344CB8AC3E}">
-        <p14:creationId xmlns:p14="http://schemas.microsoft.com/office/powerpoint/2010/main" val="470915560"/>
+        <p14:creationId xmlns:p14="http://schemas.microsoft.com/office/powerpoint/2010/main" val="1263927334"/>
       </p:ext>
     </p:extLst>
   </p:cSld>
@@ -11313,7 +11313,7 @@
           <p:cNvPr id="7" name="">
             <a:extLst xmlns:a="http://schemas.openxmlformats.org/drawingml/2006/main">
               <a:ext uri="{FF2B5EF4-FFF2-40B4-BE49-F238E27FC236}">
-                <a16:creationId xmlns:a16="http://schemas.microsoft.com/office/drawing/2014/main" id="{35A3287C-79A5-4ED9-BF82-B9ACFE34904F}"/>
+                <a16:creationId xmlns:a16="http://schemas.microsoft.com/office/drawing/2014/main" id="{97107718-4B31-4BDC-A6F1-78F41C64C8C1}"/>
               </a:ext>
             </a:extLst>
           </p:cNvPr>
@@ -11344,7 +11344,7 @@
           <p:cNvPr id="2" name="">
             <a:extLst xmlns:a="http://schemas.openxmlformats.org/drawingml/2006/main">
               <a:ext uri="{FF2B5EF4-FFF2-40B4-BE49-F238E27FC236}">
-                <a16:creationId xmlns:a16="http://schemas.microsoft.com/office/drawing/2014/main" id="{17C6D835-E444-4BC4-B9F6-265CF0046F11}"/>
+                <a16:creationId xmlns:a16="http://schemas.microsoft.com/office/drawing/2014/main" id="{1C6CA134-7657-4C1E-9A5C-91C2FEB09451}"/>
               </a:ext>
             </a:extLst>
           </p:cNvPr>
@@ -11375,7 +11375,7 @@
           <p:cNvPr id="3" name="">
             <a:extLst xmlns:a="http://schemas.openxmlformats.org/drawingml/2006/main">
               <a:ext uri="{FF2B5EF4-FFF2-40B4-BE49-F238E27FC236}">
-                <a16:creationId xmlns:a16="http://schemas.microsoft.com/office/drawing/2014/main" id="{5F1AEA8E-0065-4B70-89C9-54EE43A1FE02}"/>
+                <a16:creationId xmlns:a16="http://schemas.microsoft.com/office/drawing/2014/main" id="{3FD98C32-42DC-4828-AEE7-9575143B7EB7}"/>
               </a:ext>
             </a:extLst>
           </p:cNvPr>
@@ -11532,7 +11532,7 @@
           <p:cNvPr id="4" name="">
             <a:extLst xmlns:a="http://schemas.openxmlformats.org/drawingml/2006/main">
               <a:ext uri="{FF2B5EF4-FFF2-40B4-BE49-F238E27FC236}">
-                <a16:creationId xmlns:a16="http://schemas.microsoft.com/office/drawing/2014/main" id="{0F399EFC-C33D-4BAE-8FAA-EEB8E5C2373C}"/>
+                <a16:creationId xmlns:a16="http://schemas.microsoft.com/office/drawing/2014/main" id="{DA94A6D9-430E-4026-B246-DEDB51669EED}"/>
               </a:ext>
             </a:extLst>
           </p:cNvPr>
@@ -11563,7 +11563,7 @@
           <p:cNvPr id="5" name="">
             <a:extLst xmlns:a="http://schemas.openxmlformats.org/drawingml/2006/main">
               <a:ext uri="{FF2B5EF4-FFF2-40B4-BE49-F238E27FC236}">
-                <a16:creationId xmlns:a16="http://schemas.microsoft.com/office/drawing/2014/main" id="{92CA8CF5-871A-43B9-B532-6923036AA63F}"/>
+                <a16:creationId xmlns:a16="http://schemas.microsoft.com/office/drawing/2014/main" id="{E4B78367-3314-462C-ACA2-082FCDB3A7EF}"/>
               </a:ext>
             </a:extLst>
           </p:cNvPr>
@@ -11720,7 +11720,7 @@
           <p:cNvPr id="6" name="">
             <a:extLst xmlns:a="http://schemas.openxmlformats.org/drawingml/2006/main">
               <a:ext uri="{FF2B5EF4-FFF2-40B4-BE49-F238E27FC236}">
-                <a16:creationId xmlns:a16="http://schemas.microsoft.com/office/drawing/2014/main" id="{69CA9D8C-8567-413F-8A64-DD2C0CD62837}"/>
+                <a16:creationId xmlns:a16="http://schemas.microsoft.com/office/drawing/2014/main" id="{EA1AAE08-6632-46F1-A15F-EA1BD32C8A90}"/>
               </a:ext>
             </a:extLst>
           </p:cNvPr>
@@ -11875,7 +11875,7 @@
     </p:spTree>
     <p:extLst>
       <p:ext uri="{BB962C8B-B14F-4D97-AF65-F5344CB8AC3E}">
-        <p14:creationId xmlns:p14="http://schemas.microsoft.com/office/powerpoint/2010/main" val="2006382948"/>
+        <p14:creationId xmlns:p14="http://schemas.microsoft.com/office/powerpoint/2010/main" val="841503080"/>
       </p:ext>
     </p:extLst>
   </p:cSld>
@@ -11906,7 +11906,7 @@
           <p:cNvPr id="7" name="">
             <a:extLst xmlns:a="http://schemas.openxmlformats.org/drawingml/2006/main">
               <a:ext uri="{FF2B5EF4-FFF2-40B4-BE49-F238E27FC236}">
-                <a16:creationId xmlns:a16="http://schemas.microsoft.com/office/drawing/2014/main" id="{2F0B371B-2B5C-4E81-A6D7-3BDD259C9A01}"/>
+                <a16:creationId xmlns:a16="http://schemas.microsoft.com/office/drawing/2014/main" id="{54614413-3739-4EF1-A2C4-95D474B36E1F}"/>
               </a:ext>
             </a:extLst>
           </p:cNvPr>
@@ -11937,7 +11937,7 @@
           <p:cNvPr id="2" name="">
             <a:extLst xmlns:a="http://schemas.openxmlformats.org/drawingml/2006/main">
               <a:ext uri="{FF2B5EF4-FFF2-40B4-BE49-F238E27FC236}">
-                <a16:creationId xmlns:a16="http://schemas.microsoft.com/office/drawing/2014/main" id="{D9DB27A6-BF10-4FB9-B805-2D234BF16A8F}"/>
+                <a16:creationId xmlns:a16="http://schemas.microsoft.com/office/drawing/2014/main" id="{D5775D00-1C40-424F-A201-739685E8F00B}"/>
               </a:ext>
             </a:extLst>
           </p:cNvPr>
@@ -11968,7 +11968,7 @@
           <p:cNvPr id="3" name="">
             <a:extLst xmlns:a="http://schemas.openxmlformats.org/drawingml/2006/main">
               <a:ext uri="{FF2B5EF4-FFF2-40B4-BE49-F238E27FC236}">
-                <a16:creationId xmlns:a16="http://schemas.microsoft.com/office/drawing/2014/main" id="{8F8BE2C0-22A6-4007-B381-98706C239F17}"/>
+                <a16:creationId xmlns:a16="http://schemas.microsoft.com/office/drawing/2014/main" id="{CDEE83D0-95D0-4667-8C98-514873913887}"/>
               </a:ext>
             </a:extLst>
           </p:cNvPr>
@@ -12125,7 +12125,7 @@
           <p:cNvPr id="4" name="">
             <a:extLst xmlns:a="http://schemas.openxmlformats.org/drawingml/2006/main">
               <a:ext uri="{FF2B5EF4-FFF2-40B4-BE49-F238E27FC236}">
-                <a16:creationId xmlns:a16="http://schemas.microsoft.com/office/drawing/2014/main" id="{7ECDB819-97C7-40FC-82E8-4DDF162CB917}"/>
+                <a16:creationId xmlns:a16="http://schemas.microsoft.com/office/drawing/2014/main" id="{3EE6ED92-765E-46E3-AFFA-415B41F4161B}"/>
               </a:ext>
             </a:extLst>
           </p:cNvPr>
@@ -12156,7 +12156,7 @@
           <p:cNvPr id="5" name="">
             <a:extLst xmlns:a="http://schemas.openxmlformats.org/drawingml/2006/main">
               <a:ext uri="{FF2B5EF4-FFF2-40B4-BE49-F238E27FC236}">
-                <a16:creationId xmlns:a16="http://schemas.microsoft.com/office/drawing/2014/main" id="{AF00E095-96A0-4D40-A242-591A03D9EEE2}"/>
+                <a16:creationId xmlns:a16="http://schemas.microsoft.com/office/drawing/2014/main" id="{F4A9F163-AEE4-401B-842E-F315A4A301F6}"/>
               </a:ext>
             </a:extLst>
           </p:cNvPr>
@@ -12313,7 +12313,7 @@
           <p:cNvPr id="6" name="">
             <a:extLst xmlns:a="http://schemas.openxmlformats.org/drawingml/2006/main">
               <a:ext uri="{FF2B5EF4-FFF2-40B4-BE49-F238E27FC236}">
-                <a16:creationId xmlns:a16="http://schemas.microsoft.com/office/drawing/2014/main" id="{13914987-CBF4-4548-89F6-EA21DC4A9759}"/>
+                <a16:creationId xmlns:a16="http://schemas.microsoft.com/office/drawing/2014/main" id="{F934888A-1E3E-4C18-B9E4-1A0EB8B6870E}"/>
               </a:ext>
             </a:extLst>
           </p:cNvPr>
@@ -12468,7 +12468,7 @@
     </p:spTree>
     <p:extLst>
       <p:ext uri="{BB962C8B-B14F-4D97-AF65-F5344CB8AC3E}">
-        <p14:creationId xmlns:p14="http://schemas.microsoft.com/office/powerpoint/2010/main" val="1383014958"/>
+        <p14:creationId xmlns:p14="http://schemas.microsoft.com/office/powerpoint/2010/main" val="1183557364"/>
       </p:ext>
     </p:extLst>
   </p:cSld>
@@ -12499,7 +12499,7 @@
           <p:cNvPr id="7" name="">
             <a:extLst xmlns:a="http://schemas.openxmlformats.org/drawingml/2006/main">
               <a:ext uri="{FF2B5EF4-FFF2-40B4-BE49-F238E27FC236}">
-                <a16:creationId xmlns:a16="http://schemas.microsoft.com/office/drawing/2014/main" id="{3FA49BC1-1CA6-4EC3-8F7A-F2309A129F54}"/>
+                <a16:creationId xmlns:a16="http://schemas.microsoft.com/office/drawing/2014/main" id="{26A3B55B-C66E-4D16-8AB0-21AFCC49282D}"/>
               </a:ext>
             </a:extLst>
           </p:cNvPr>
@@ -12530,7 +12530,7 @@
           <p:cNvPr id="2" name="">
             <a:extLst xmlns:a="http://schemas.openxmlformats.org/drawingml/2006/main">
               <a:ext uri="{FF2B5EF4-FFF2-40B4-BE49-F238E27FC236}">
-                <a16:creationId xmlns:a16="http://schemas.microsoft.com/office/drawing/2014/main" id="{0A47FC29-C5D2-4030-8A51-3C2C5F66B3BA}"/>
+                <a16:creationId xmlns:a16="http://schemas.microsoft.com/office/drawing/2014/main" id="{DD3FAE52-9CDD-4283-A82F-641A6D584933}"/>
               </a:ext>
             </a:extLst>
           </p:cNvPr>
@@ -12561,7 +12561,7 @@
           <p:cNvPr id="3" name="">
             <a:extLst xmlns:a="http://schemas.openxmlformats.org/drawingml/2006/main">
               <a:ext uri="{FF2B5EF4-FFF2-40B4-BE49-F238E27FC236}">
-                <a16:creationId xmlns:a16="http://schemas.microsoft.com/office/drawing/2014/main" id="{0F8B42C7-14E3-4C92-8A98-93316B6A6BAA}"/>
+                <a16:creationId xmlns:a16="http://schemas.microsoft.com/office/drawing/2014/main" id="{E14923A9-EE93-4BC8-BB83-DB43986539B7}"/>
               </a:ext>
             </a:extLst>
           </p:cNvPr>
@@ -12718,7 +12718,7 @@
           <p:cNvPr id="4" name="">
             <a:extLst xmlns:a="http://schemas.openxmlformats.org/drawingml/2006/main">
               <a:ext uri="{FF2B5EF4-FFF2-40B4-BE49-F238E27FC236}">
-                <a16:creationId xmlns:a16="http://schemas.microsoft.com/office/drawing/2014/main" id="{A0764EC6-C381-4E1D-9832-6F5CACC0F874}"/>
+                <a16:creationId xmlns:a16="http://schemas.microsoft.com/office/drawing/2014/main" id="{5337A86B-8EE2-4289-BF30-25BCD1035645}"/>
               </a:ext>
             </a:extLst>
           </p:cNvPr>
@@ -12749,7 +12749,7 @@
           <p:cNvPr id="5" name="">
             <a:extLst xmlns:a="http://schemas.openxmlformats.org/drawingml/2006/main">
               <a:ext uri="{FF2B5EF4-FFF2-40B4-BE49-F238E27FC236}">
-                <a16:creationId xmlns:a16="http://schemas.microsoft.com/office/drawing/2014/main" id="{C8A6FB47-631B-422D-963D-50BA82048CCD}"/>
+                <a16:creationId xmlns:a16="http://schemas.microsoft.com/office/drawing/2014/main" id="{5192606C-7EA6-4B3E-ACA7-3DC456FEFDB4}"/>
               </a:ext>
             </a:extLst>
           </p:cNvPr>
@@ -12929,7 +12929,7 @@
           <p:cNvPr id="6" name="">
             <a:extLst xmlns:a="http://schemas.openxmlformats.org/drawingml/2006/main">
               <a:ext uri="{FF2B5EF4-FFF2-40B4-BE49-F238E27FC236}">
-                <a16:creationId xmlns:a16="http://schemas.microsoft.com/office/drawing/2014/main" id="{086B4E5A-6370-480F-AB19-9359ADD64C0A}"/>
+                <a16:creationId xmlns:a16="http://schemas.microsoft.com/office/drawing/2014/main" id="{FB51B406-5DA6-4936-9DFC-0C7ABB100EDF}"/>
               </a:ext>
             </a:extLst>
           </p:cNvPr>
@@ -13084,7 +13084,7 @@
     </p:spTree>
     <p:extLst>
       <p:ext uri="{BB962C8B-B14F-4D97-AF65-F5344CB8AC3E}">
-        <p14:creationId xmlns:p14="http://schemas.microsoft.com/office/powerpoint/2010/main" val="1471085883"/>
+        <p14:creationId xmlns:p14="http://schemas.microsoft.com/office/powerpoint/2010/main" val="1020141214"/>
       </p:ext>
     </p:extLst>
   </p:cSld>
@@ -13115,7 +13115,7 @@
           <p:cNvPr id="7" name="">
             <a:extLst xmlns:a="http://schemas.openxmlformats.org/drawingml/2006/main">
               <a:ext uri="{FF2B5EF4-FFF2-40B4-BE49-F238E27FC236}">
-                <a16:creationId xmlns:a16="http://schemas.microsoft.com/office/drawing/2014/main" id="{990FAFC7-AACB-48C2-9481-F3BFBB3B219F}"/>
+                <a16:creationId xmlns:a16="http://schemas.microsoft.com/office/drawing/2014/main" id="{77816D8E-D074-473F-A081-F913F96D8F6D}"/>
               </a:ext>
             </a:extLst>
           </p:cNvPr>
@@ -13146,7 +13146,7 @@
           <p:cNvPr id="2" name="">
             <a:extLst xmlns:a="http://schemas.openxmlformats.org/drawingml/2006/main">
               <a:ext uri="{FF2B5EF4-FFF2-40B4-BE49-F238E27FC236}">
-                <a16:creationId xmlns:a16="http://schemas.microsoft.com/office/drawing/2014/main" id="{9E4B8660-0C6E-4935-8437-C18F6A8C2DE5}"/>
+                <a16:creationId xmlns:a16="http://schemas.microsoft.com/office/drawing/2014/main" id="{90D78EBF-B7BC-44AF-A3B3-0AB681941ACA}"/>
               </a:ext>
             </a:extLst>
           </p:cNvPr>
@@ -13177,7 +13177,7 @@
           <p:cNvPr id="3" name="">
             <a:extLst xmlns:a="http://schemas.openxmlformats.org/drawingml/2006/main">
               <a:ext uri="{FF2B5EF4-FFF2-40B4-BE49-F238E27FC236}">
-                <a16:creationId xmlns:a16="http://schemas.microsoft.com/office/drawing/2014/main" id="{1BB7D2AF-8880-4651-ADBC-1AD97F45A47B}"/>
+                <a16:creationId xmlns:a16="http://schemas.microsoft.com/office/drawing/2014/main" id="{973B3FC8-25C9-4C8A-985E-EF8E35A88907}"/>
               </a:ext>
             </a:extLst>
           </p:cNvPr>
@@ -13334,7 +13334,7 @@
           <p:cNvPr id="4" name="">
             <a:extLst xmlns:a="http://schemas.openxmlformats.org/drawingml/2006/main">
               <a:ext uri="{FF2B5EF4-FFF2-40B4-BE49-F238E27FC236}">
-                <a16:creationId xmlns:a16="http://schemas.microsoft.com/office/drawing/2014/main" id="{64E7FDE6-AFC7-4875-A8EF-2376C144E083}"/>
+                <a16:creationId xmlns:a16="http://schemas.microsoft.com/office/drawing/2014/main" id="{80366D05-A17F-440A-ACAE-682529E80285}"/>
               </a:ext>
             </a:extLst>
           </p:cNvPr>
@@ -13365,7 +13365,7 @@
           <p:cNvPr id="5" name="">
             <a:extLst xmlns:a="http://schemas.openxmlformats.org/drawingml/2006/main">
               <a:ext uri="{FF2B5EF4-FFF2-40B4-BE49-F238E27FC236}">
-                <a16:creationId xmlns:a16="http://schemas.microsoft.com/office/drawing/2014/main" id="{F3CF2C20-0B31-49CB-BD42-30DB65597713}"/>
+                <a16:creationId xmlns:a16="http://schemas.microsoft.com/office/drawing/2014/main" id="{C1E51C6A-85B4-482F-93D3-256311C09699}"/>
               </a:ext>
             </a:extLst>
           </p:cNvPr>
@@ -13522,7 +13522,7 @@
           <p:cNvPr id="6" name="">
             <a:extLst xmlns:a="http://schemas.openxmlformats.org/drawingml/2006/main">
               <a:ext uri="{FF2B5EF4-FFF2-40B4-BE49-F238E27FC236}">
-                <a16:creationId xmlns:a16="http://schemas.microsoft.com/office/drawing/2014/main" id="{7EC74F91-1C95-4AB9-A79F-E42CDD82E4A8}"/>
+                <a16:creationId xmlns:a16="http://schemas.microsoft.com/office/drawing/2014/main" id="{B2B6E441-21F8-484D-85A1-A85C369060A8}"/>
               </a:ext>
             </a:extLst>
           </p:cNvPr>
@@ -13677,7 +13677,7 @@
     </p:spTree>
     <p:extLst>
       <p:ext uri="{BB962C8B-B14F-4D97-AF65-F5344CB8AC3E}">
-        <p14:creationId xmlns:p14="http://schemas.microsoft.com/office/powerpoint/2010/main" val="576088398"/>
+        <p14:creationId xmlns:p14="http://schemas.microsoft.com/office/powerpoint/2010/main" val="1064171145"/>
       </p:ext>
     </p:extLst>
   </p:cSld>
@@ -13708,7 +13708,7 @@
           <p:cNvPr id="7" name="">
             <a:extLst xmlns:a="http://schemas.openxmlformats.org/drawingml/2006/main">
               <a:ext uri="{FF2B5EF4-FFF2-40B4-BE49-F238E27FC236}">
-                <a16:creationId xmlns:a16="http://schemas.microsoft.com/office/drawing/2014/main" id="{D034BA29-C44C-4C7E-AE08-787E0AFCE14F}"/>
+                <a16:creationId xmlns:a16="http://schemas.microsoft.com/office/drawing/2014/main" id="{EB438262-9120-4AAA-AFB6-1EF6579B3E57}"/>
               </a:ext>
             </a:extLst>
           </p:cNvPr>
@@ -13739,7 +13739,7 @@
           <p:cNvPr id="2" name="">
             <a:extLst xmlns:a="http://schemas.openxmlformats.org/drawingml/2006/main">
               <a:ext uri="{FF2B5EF4-FFF2-40B4-BE49-F238E27FC236}">
-                <a16:creationId xmlns:a16="http://schemas.microsoft.com/office/drawing/2014/main" id="{E86E7F79-8285-4BDB-A3FA-47835B018686}"/>
+                <a16:creationId xmlns:a16="http://schemas.microsoft.com/office/drawing/2014/main" id="{83AEF992-CF9F-4E81-87C3-922A4B5D6F2A}"/>
               </a:ext>
             </a:extLst>
           </p:cNvPr>
@@ -13770,7 +13770,7 @@
           <p:cNvPr id="3" name="">
             <a:extLst xmlns:a="http://schemas.openxmlformats.org/drawingml/2006/main">
               <a:ext uri="{FF2B5EF4-FFF2-40B4-BE49-F238E27FC236}">
-                <a16:creationId xmlns:a16="http://schemas.microsoft.com/office/drawing/2014/main" id="{4B29A2A3-9F77-4EC3-82AE-F7157F9733DA}"/>
+                <a16:creationId xmlns:a16="http://schemas.microsoft.com/office/drawing/2014/main" id="{03443C97-8631-498C-A476-C12AFD0794E3}"/>
               </a:ext>
             </a:extLst>
           </p:cNvPr>
@@ -13927,7 +13927,7 @@
           <p:cNvPr id="4" name="">
             <a:extLst xmlns:a="http://schemas.openxmlformats.org/drawingml/2006/main">
               <a:ext uri="{FF2B5EF4-FFF2-40B4-BE49-F238E27FC236}">
-                <a16:creationId xmlns:a16="http://schemas.microsoft.com/office/drawing/2014/main" id="{06FD9292-7DA8-4F87-B1CF-7738D6F836D6}"/>
+                <a16:creationId xmlns:a16="http://schemas.microsoft.com/office/drawing/2014/main" id="{D0B8DA73-728E-45DB-A3C2-2F3AAB6B555E}"/>
               </a:ext>
             </a:extLst>
           </p:cNvPr>
@@ -13958,7 +13958,7 @@
           <p:cNvPr id="5" name="">
             <a:extLst xmlns:a="http://schemas.openxmlformats.org/drawingml/2006/main">
               <a:ext uri="{FF2B5EF4-FFF2-40B4-BE49-F238E27FC236}">
-                <a16:creationId xmlns:a16="http://schemas.microsoft.com/office/drawing/2014/main" id="{10A9E4C6-0245-4C7E-9C57-27A2AEB8BA01}"/>
+                <a16:creationId xmlns:a16="http://schemas.microsoft.com/office/drawing/2014/main" id="{D8D972F3-A41C-4A33-8258-1C3FBE557A5B}"/>
               </a:ext>
             </a:extLst>
           </p:cNvPr>
@@ -14115,7 +14115,7 @@
           <p:cNvPr id="6" name="">
             <a:extLst xmlns:a="http://schemas.openxmlformats.org/drawingml/2006/main">
               <a:ext uri="{FF2B5EF4-FFF2-40B4-BE49-F238E27FC236}">
-                <a16:creationId xmlns:a16="http://schemas.microsoft.com/office/drawing/2014/main" id="{E5EDEF4A-34ED-490F-8060-987F600FC8CB}"/>
+                <a16:creationId xmlns:a16="http://schemas.microsoft.com/office/drawing/2014/main" id="{58B4E437-405D-4978-8850-3D2E5BF27C2C}"/>
               </a:ext>
             </a:extLst>
           </p:cNvPr>
@@ -14270,7 +14270,7 @@
     </p:spTree>
     <p:extLst>
       <p:ext uri="{BB962C8B-B14F-4D97-AF65-F5344CB8AC3E}">
-        <p14:creationId xmlns:p14="http://schemas.microsoft.com/office/powerpoint/2010/main" val="1224430713"/>
+        <p14:creationId xmlns:p14="http://schemas.microsoft.com/office/powerpoint/2010/main" val="172879379"/>
       </p:ext>
     </p:extLst>
   </p:cSld>
@@ -14301,7 +14301,7 @@
           <p:cNvPr id="7" name="">
             <a:extLst xmlns:a="http://schemas.openxmlformats.org/drawingml/2006/main">
               <a:ext uri="{FF2B5EF4-FFF2-40B4-BE49-F238E27FC236}">
-                <a16:creationId xmlns:a16="http://schemas.microsoft.com/office/drawing/2014/main" id="{ABB30C61-37B0-4C69-A24C-56FD74B01A32}"/>
+                <a16:creationId xmlns:a16="http://schemas.microsoft.com/office/drawing/2014/main" id="{8F3B6202-CE7F-489B-9000-E20D5040A450}"/>
               </a:ext>
             </a:extLst>
           </p:cNvPr>
@@ -14332,7 +14332,7 @@
           <p:cNvPr id="2" name="">
             <a:extLst xmlns:a="http://schemas.openxmlformats.org/drawingml/2006/main">
               <a:ext uri="{FF2B5EF4-FFF2-40B4-BE49-F238E27FC236}">
-                <a16:creationId xmlns:a16="http://schemas.microsoft.com/office/drawing/2014/main" id="{9E17A356-2B89-48A3-9349-FC70F5844C29}"/>
+                <a16:creationId xmlns:a16="http://schemas.microsoft.com/office/drawing/2014/main" id="{B40A6FD0-6726-4520-BE39-D3F41F54AD3A}"/>
               </a:ext>
             </a:extLst>
           </p:cNvPr>
@@ -14363,7 +14363,7 @@
           <p:cNvPr id="3" name="">
             <a:extLst xmlns:a="http://schemas.openxmlformats.org/drawingml/2006/main">
               <a:ext uri="{FF2B5EF4-FFF2-40B4-BE49-F238E27FC236}">
-                <a16:creationId xmlns:a16="http://schemas.microsoft.com/office/drawing/2014/main" id="{597348B5-B77F-408E-BCA3-6ADC537F1943}"/>
+                <a16:creationId xmlns:a16="http://schemas.microsoft.com/office/drawing/2014/main" id="{1198B698-C836-455C-B0C0-415CBB21F5CA}"/>
               </a:ext>
             </a:extLst>
           </p:cNvPr>
@@ -14543,7 +14543,7 @@
           <p:cNvPr id="4" name="">
             <a:extLst xmlns:a="http://schemas.openxmlformats.org/drawingml/2006/main">
               <a:ext uri="{FF2B5EF4-FFF2-40B4-BE49-F238E27FC236}">
-                <a16:creationId xmlns:a16="http://schemas.microsoft.com/office/drawing/2014/main" id="{D550BCD2-516F-4521-8E21-6242A7A5CFFB}"/>
+                <a16:creationId xmlns:a16="http://schemas.microsoft.com/office/drawing/2014/main" id="{251F880E-1C6A-4D5E-B98B-CCBFC7621D59}"/>
               </a:ext>
             </a:extLst>
           </p:cNvPr>
@@ -14574,7 +14574,7 @@
           <p:cNvPr id="5" name="">
             <a:extLst xmlns:a="http://schemas.openxmlformats.org/drawingml/2006/main">
               <a:ext uri="{FF2B5EF4-FFF2-40B4-BE49-F238E27FC236}">
-                <a16:creationId xmlns:a16="http://schemas.microsoft.com/office/drawing/2014/main" id="{7EF24316-516F-45F7-964A-97FC82D56A10}"/>
+                <a16:creationId xmlns:a16="http://schemas.microsoft.com/office/drawing/2014/main" id="{8FD8AAB5-20F0-4FEF-9575-7D53096C9C71}"/>
               </a:ext>
             </a:extLst>
           </p:cNvPr>
@@ -14731,7 +14731,7 @@
           <p:cNvPr id="6" name="">
             <a:extLst xmlns:a="http://schemas.openxmlformats.org/drawingml/2006/main">
               <a:ext uri="{FF2B5EF4-FFF2-40B4-BE49-F238E27FC236}">
-                <a16:creationId xmlns:a16="http://schemas.microsoft.com/office/drawing/2014/main" id="{55D745C3-4C13-47F4-9650-836ACCA76136}"/>
+                <a16:creationId xmlns:a16="http://schemas.microsoft.com/office/drawing/2014/main" id="{AFD3EFB7-A11B-4577-8629-A77B377424A5}"/>
               </a:ext>
             </a:extLst>
           </p:cNvPr>
@@ -14886,7 +14886,7 @@
     </p:spTree>
     <p:extLst>
       <p:ext uri="{BB962C8B-B14F-4D97-AF65-F5344CB8AC3E}">
-        <p14:creationId xmlns:p14="http://schemas.microsoft.com/office/powerpoint/2010/main" val="2133948702"/>
+        <p14:creationId xmlns:p14="http://schemas.microsoft.com/office/powerpoint/2010/main" val="1398699727"/>
       </p:ext>
     </p:extLst>
   </p:cSld>
@@ -14917,7 +14917,7 @@
           <p:cNvPr id="7" name="">
             <a:extLst xmlns:a="http://schemas.openxmlformats.org/drawingml/2006/main">
               <a:ext uri="{FF2B5EF4-FFF2-40B4-BE49-F238E27FC236}">
-                <a16:creationId xmlns:a16="http://schemas.microsoft.com/office/drawing/2014/main" id="{586E2DED-1273-4F29-931B-BA27C45A303E}"/>
+                <a16:creationId xmlns:a16="http://schemas.microsoft.com/office/drawing/2014/main" id="{F7C57F55-F31D-4D10-AB26-CE2B993E8CDC}"/>
               </a:ext>
             </a:extLst>
           </p:cNvPr>
@@ -14948,7 +14948,7 @@
           <p:cNvPr id="2" name="">
             <a:extLst xmlns:a="http://schemas.openxmlformats.org/drawingml/2006/main">
               <a:ext uri="{FF2B5EF4-FFF2-40B4-BE49-F238E27FC236}">
-                <a16:creationId xmlns:a16="http://schemas.microsoft.com/office/drawing/2014/main" id="{D522765C-C4E2-4D96-A64C-C3CF8E2974FC}"/>
+                <a16:creationId xmlns:a16="http://schemas.microsoft.com/office/drawing/2014/main" id="{98682B04-8874-488F-8CA9-740966D87DE8}"/>
               </a:ext>
             </a:extLst>
           </p:cNvPr>
@@ -14979,7 +14979,7 @@
           <p:cNvPr id="3" name="">
             <a:extLst xmlns:a="http://schemas.openxmlformats.org/drawingml/2006/main">
               <a:ext uri="{FF2B5EF4-FFF2-40B4-BE49-F238E27FC236}">
-                <a16:creationId xmlns:a16="http://schemas.microsoft.com/office/drawing/2014/main" id="{474FE672-76E8-4A16-8D78-31BF854CA10B}"/>
+                <a16:creationId xmlns:a16="http://schemas.microsoft.com/office/drawing/2014/main" id="{85884354-6EC5-4C3C-A747-5A36A679B664}"/>
               </a:ext>
             </a:extLst>
           </p:cNvPr>
@@ -15136,7 +15136,7 @@
           <p:cNvPr id="4" name="">
             <a:extLst xmlns:a="http://schemas.openxmlformats.org/drawingml/2006/main">
               <a:ext uri="{FF2B5EF4-FFF2-40B4-BE49-F238E27FC236}">
-                <a16:creationId xmlns:a16="http://schemas.microsoft.com/office/drawing/2014/main" id="{9DC9F88C-B9C1-4C2E-9F22-83DA4BC48EC0}"/>
+                <a16:creationId xmlns:a16="http://schemas.microsoft.com/office/drawing/2014/main" id="{A3686926-D0DF-4619-825C-AE3823D0B223}"/>
               </a:ext>
             </a:extLst>
           </p:cNvPr>
@@ -15167,7 +15167,7 @@
           <p:cNvPr id="5" name="">
             <a:extLst xmlns:a="http://schemas.openxmlformats.org/drawingml/2006/main">
               <a:ext uri="{FF2B5EF4-FFF2-40B4-BE49-F238E27FC236}">
-                <a16:creationId xmlns:a16="http://schemas.microsoft.com/office/drawing/2014/main" id="{F9BB070C-E194-4B04-AF92-686E06A89025}"/>
+                <a16:creationId xmlns:a16="http://schemas.microsoft.com/office/drawing/2014/main" id="{A8830C57-D8C2-4955-9E1C-30E35564C4F7}"/>
               </a:ext>
             </a:extLst>
           </p:cNvPr>
@@ -15324,7 +15324,7 @@
           <p:cNvPr id="6" name="">
             <a:extLst xmlns:a="http://schemas.openxmlformats.org/drawingml/2006/main">
               <a:ext uri="{FF2B5EF4-FFF2-40B4-BE49-F238E27FC236}">
-                <a16:creationId xmlns:a16="http://schemas.microsoft.com/office/drawing/2014/main" id="{82F7594F-5758-491A-ABA4-41806AC284BA}"/>
+                <a16:creationId xmlns:a16="http://schemas.microsoft.com/office/drawing/2014/main" id="{3AEF4D76-65B3-46E0-8A10-1DF808AF1C7C}"/>
               </a:ext>
             </a:extLst>
           </p:cNvPr>
@@ -15479,7 +15479,7 @@
     </p:spTree>
     <p:extLst>
       <p:ext uri="{BB962C8B-B14F-4D97-AF65-F5344CB8AC3E}">
-        <p14:creationId xmlns:p14="http://schemas.microsoft.com/office/powerpoint/2010/main" val="233509070"/>
+        <p14:creationId xmlns:p14="http://schemas.microsoft.com/office/powerpoint/2010/main" val="940427545"/>
       </p:ext>
     </p:extLst>
   </p:cSld>
@@ -15510,7 +15510,7 @@
           <p:cNvPr id="7" name="">
             <a:extLst xmlns:a="http://schemas.openxmlformats.org/drawingml/2006/main">
               <a:ext uri="{FF2B5EF4-FFF2-40B4-BE49-F238E27FC236}">
-                <a16:creationId xmlns:a16="http://schemas.microsoft.com/office/drawing/2014/main" id="{A216395C-C3E3-41B3-876C-0578537238FF}"/>
+                <a16:creationId xmlns:a16="http://schemas.microsoft.com/office/drawing/2014/main" id="{E2419CFD-FF18-4975-BDC0-8B0E3BB9F788}"/>
               </a:ext>
             </a:extLst>
           </p:cNvPr>
@@ -15541,7 +15541,7 @@
           <p:cNvPr id="2" name="">
             <a:extLst xmlns:a="http://schemas.openxmlformats.org/drawingml/2006/main">
               <a:ext uri="{FF2B5EF4-FFF2-40B4-BE49-F238E27FC236}">
-                <a16:creationId xmlns:a16="http://schemas.microsoft.com/office/drawing/2014/main" id="{FC65FE94-F201-473E-B22A-B1C58192B5D9}"/>
+                <a16:creationId xmlns:a16="http://schemas.microsoft.com/office/drawing/2014/main" id="{0217AF19-A7B0-4645-83E5-66A08F53220F}"/>
               </a:ext>
             </a:extLst>
           </p:cNvPr>
@@ -15572,7 +15572,7 @@
           <p:cNvPr id="3" name="">
             <a:extLst xmlns:a="http://schemas.openxmlformats.org/drawingml/2006/main">
               <a:ext uri="{FF2B5EF4-FFF2-40B4-BE49-F238E27FC236}">
-                <a16:creationId xmlns:a16="http://schemas.microsoft.com/office/drawing/2014/main" id="{4909212F-7FC4-40E2-8EF7-4190FB3BE4F3}"/>
+                <a16:creationId xmlns:a16="http://schemas.microsoft.com/office/drawing/2014/main" id="{04F22451-4DDB-47D9-8AD6-0C278B1862E5}"/>
               </a:ext>
             </a:extLst>
           </p:cNvPr>
@@ -15729,7 +15729,7 @@
           <p:cNvPr id="4" name="">
             <a:extLst xmlns:a="http://schemas.openxmlformats.org/drawingml/2006/main">
               <a:ext uri="{FF2B5EF4-FFF2-40B4-BE49-F238E27FC236}">
-                <a16:creationId xmlns:a16="http://schemas.microsoft.com/office/drawing/2014/main" id="{12869D89-E719-4916-AFB6-16C90285EDA6}"/>
+                <a16:creationId xmlns:a16="http://schemas.microsoft.com/office/drawing/2014/main" id="{454B5AEE-DB2F-46BC-965C-7A60656E3917}"/>
               </a:ext>
             </a:extLst>
           </p:cNvPr>
@@ -15760,7 +15760,7 @@
           <p:cNvPr id="5" name="">
             <a:extLst xmlns:a="http://schemas.openxmlformats.org/drawingml/2006/main">
               <a:ext uri="{FF2B5EF4-FFF2-40B4-BE49-F238E27FC236}">
-                <a16:creationId xmlns:a16="http://schemas.microsoft.com/office/drawing/2014/main" id="{47F6079C-E2E5-4E76-ADCB-50AC8C357D9C}"/>
+                <a16:creationId xmlns:a16="http://schemas.microsoft.com/office/drawing/2014/main" id="{F6EF5A66-71F6-4D7F-B049-7D15651E98AD}"/>
               </a:ext>
             </a:extLst>
           </p:cNvPr>
@@ -15917,7 +15917,7 @@
           <p:cNvPr id="6" name="">
             <a:extLst xmlns:a="http://schemas.openxmlformats.org/drawingml/2006/main">
               <a:ext uri="{FF2B5EF4-FFF2-40B4-BE49-F238E27FC236}">
-                <a16:creationId xmlns:a16="http://schemas.microsoft.com/office/drawing/2014/main" id="{C9512BE3-8461-4C4C-81D4-786B34EB3BF9}"/>
+                <a16:creationId xmlns:a16="http://schemas.microsoft.com/office/drawing/2014/main" id="{898F0E05-A89F-49CF-9E65-3271FB871D4A}"/>
               </a:ext>
             </a:extLst>
           </p:cNvPr>
@@ -16072,7 +16072,7 @@
     </p:spTree>
     <p:extLst>
       <p:ext uri="{BB962C8B-B14F-4D97-AF65-F5344CB8AC3E}">
-        <p14:creationId xmlns:p14="http://schemas.microsoft.com/office/powerpoint/2010/main" val="215042451"/>
+        <p14:creationId xmlns:p14="http://schemas.microsoft.com/office/powerpoint/2010/main" val="665256491"/>
       </p:ext>
     </p:extLst>
   </p:cSld>
@@ -16103,7 +16103,7 @@
           <p:cNvPr id="7" name="">
             <a:extLst xmlns:a="http://schemas.openxmlformats.org/drawingml/2006/main">
               <a:ext uri="{FF2B5EF4-FFF2-40B4-BE49-F238E27FC236}">
-                <a16:creationId xmlns:a16="http://schemas.microsoft.com/office/drawing/2014/main" id="{B2DCE6EB-5B08-4745-9C0F-9FB6F75D4EDC}"/>
+                <a16:creationId xmlns:a16="http://schemas.microsoft.com/office/drawing/2014/main" id="{C1264B79-D7C7-40F3-B525-D3C53BB91AA1}"/>
               </a:ext>
             </a:extLst>
           </p:cNvPr>
@@ -16134,7 +16134,7 @@
           <p:cNvPr id="2" name="">
             <a:extLst xmlns:a="http://schemas.openxmlformats.org/drawingml/2006/main">
               <a:ext uri="{FF2B5EF4-FFF2-40B4-BE49-F238E27FC236}">
-                <a16:creationId xmlns:a16="http://schemas.microsoft.com/office/drawing/2014/main" id="{7514675D-1723-47F0-9FB0-EAEAC6BD4921}"/>
+                <a16:creationId xmlns:a16="http://schemas.microsoft.com/office/drawing/2014/main" id="{D7407485-F89E-482F-8C1F-746226C3A34D}"/>
               </a:ext>
             </a:extLst>
           </p:cNvPr>
@@ -16165,7 +16165,7 @@
           <p:cNvPr id="3" name="">
             <a:extLst xmlns:a="http://schemas.openxmlformats.org/drawingml/2006/main">
               <a:ext uri="{FF2B5EF4-FFF2-40B4-BE49-F238E27FC236}">
-                <a16:creationId xmlns:a16="http://schemas.microsoft.com/office/drawing/2014/main" id="{00D051B6-D221-4D33-8B3E-1352994FD6B5}"/>
+                <a16:creationId xmlns:a16="http://schemas.microsoft.com/office/drawing/2014/main" id="{51837A81-D5DE-423E-A56D-1F5163BD6216}"/>
               </a:ext>
             </a:extLst>
           </p:cNvPr>
@@ -16322,7 +16322,7 @@
           <p:cNvPr id="4" name="">
             <a:extLst xmlns:a="http://schemas.openxmlformats.org/drawingml/2006/main">
               <a:ext uri="{FF2B5EF4-FFF2-40B4-BE49-F238E27FC236}">
-                <a16:creationId xmlns:a16="http://schemas.microsoft.com/office/drawing/2014/main" id="{7C527F10-5DA9-41AE-A788-9E4E46FD33ED}"/>
+                <a16:creationId xmlns:a16="http://schemas.microsoft.com/office/drawing/2014/main" id="{8F87D18E-8971-4B31-9FBA-37577F048989}"/>
               </a:ext>
             </a:extLst>
           </p:cNvPr>
@@ -16353,7 +16353,7 @@
           <p:cNvPr id="5" name="">
             <a:extLst xmlns:a="http://schemas.openxmlformats.org/drawingml/2006/main">
               <a:ext uri="{FF2B5EF4-FFF2-40B4-BE49-F238E27FC236}">
-                <a16:creationId xmlns:a16="http://schemas.microsoft.com/office/drawing/2014/main" id="{2F45DF55-9020-4C4E-8396-C0460AA29B18}"/>
+                <a16:creationId xmlns:a16="http://schemas.microsoft.com/office/drawing/2014/main" id="{0EA0E1FD-4D97-4F2B-BEC7-69F2921C701B}"/>
               </a:ext>
             </a:extLst>
           </p:cNvPr>
@@ -16510,7 +16510,7 @@
           <p:cNvPr id="6" name="">
             <a:extLst xmlns:a="http://schemas.openxmlformats.org/drawingml/2006/main">
               <a:ext uri="{FF2B5EF4-FFF2-40B4-BE49-F238E27FC236}">
-                <a16:creationId xmlns:a16="http://schemas.microsoft.com/office/drawing/2014/main" id="{072605A3-B523-4799-A8D6-AFC8B9E3C5F5}"/>
+                <a16:creationId xmlns:a16="http://schemas.microsoft.com/office/drawing/2014/main" id="{9EDA7D7F-4036-40E2-8A6E-8058C99EE9DC}"/>
               </a:ext>
             </a:extLst>
           </p:cNvPr>
@@ -16665,7 +16665,7 @@
     </p:spTree>
     <p:extLst>
       <p:ext uri="{BB962C8B-B14F-4D97-AF65-F5344CB8AC3E}">
-        <p14:creationId xmlns:p14="http://schemas.microsoft.com/office/powerpoint/2010/main" val="318617383"/>
+        <p14:creationId xmlns:p14="http://schemas.microsoft.com/office/powerpoint/2010/main" val="1725581554"/>
       </p:ext>
     </p:extLst>
   </p:cSld>
@@ -16696,7 +16696,7 @@
           <p:cNvPr id="7" name="">
             <a:extLst xmlns:a="http://schemas.openxmlformats.org/drawingml/2006/main">
               <a:ext uri="{FF2B5EF4-FFF2-40B4-BE49-F238E27FC236}">
-                <a16:creationId xmlns:a16="http://schemas.microsoft.com/office/drawing/2014/main" id="{3D915924-707C-4DB3-902F-CAF9D77228F6}"/>
+                <a16:creationId xmlns:a16="http://schemas.microsoft.com/office/drawing/2014/main" id="{55964E5A-F463-471E-B980-9D9D863067AC}"/>
               </a:ext>
             </a:extLst>
           </p:cNvPr>
@@ -16727,7 +16727,7 @@
           <p:cNvPr id="2" name="">
             <a:extLst xmlns:a="http://schemas.openxmlformats.org/drawingml/2006/main">
               <a:ext uri="{FF2B5EF4-FFF2-40B4-BE49-F238E27FC236}">
-                <a16:creationId xmlns:a16="http://schemas.microsoft.com/office/drawing/2014/main" id="{962C76B6-6E4F-4CAB-A8FE-731F79193B3D}"/>
+                <a16:creationId xmlns:a16="http://schemas.microsoft.com/office/drawing/2014/main" id="{0666259F-1BCF-4C33-AF8F-89F2EC448BAE}"/>
               </a:ext>
             </a:extLst>
           </p:cNvPr>
@@ -16758,7 +16758,7 @@
           <p:cNvPr id="3" name="">
             <a:extLst xmlns:a="http://schemas.openxmlformats.org/drawingml/2006/main">
               <a:ext uri="{FF2B5EF4-FFF2-40B4-BE49-F238E27FC236}">
-                <a16:creationId xmlns:a16="http://schemas.microsoft.com/office/drawing/2014/main" id="{0DC1D8F3-0CB9-4CF9-BB9C-1DCE6EE619B1}"/>
+                <a16:creationId xmlns:a16="http://schemas.microsoft.com/office/drawing/2014/main" id="{F840C30F-FF85-4D51-BEEA-2C2547E85205}"/>
               </a:ext>
             </a:extLst>
           </p:cNvPr>
@@ -16915,7 +16915,7 @@
           <p:cNvPr id="4" name="">
             <a:extLst xmlns:a="http://schemas.openxmlformats.org/drawingml/2006/main">
               <a:ext uri="{FF2B5EF4-FFF2-40B4-BE49-F238E27FC236}">
-                <a16:creationId xmlns:a16="http://schemas.microsoft.com/office/drawing/2014/main" id="{FA96CE5A-AE82-42A3-B5C9-B4043717C03A}"/>
+                <a16:creationId xmlns:a16="http://schemas.microsoft.com/office/drawing/2014/main" id="{F11784C5-8E31-45D2-8B65-6B191DA13CA9}"/>
               </a:ext>
             </a:extLst>
           </p:cNvPr>
@@ -16946,7 +16946,7 @@
           <p:cNvPr id="5" name="">
             <a:extLst xmlns:a="http://schemas.openxmlformats.org/drawingml/2006/main">
               <a:ext uri="{FF2B5EF4-FFF2-40B4-BE49-F238E27FC236}">
-                <a16:creationId xmlns:a16="http://schemas.microsoft.com/office/drawing/2014/main" id="{403A3022-6FC3-4C29-AA0B-5094268E5326}"/>
+                <a16:creationId xmlns:a16="http://schemas.microsoft.com/office/drawing/2014/main" id="{5AFB0F0F-CA7C-4819-B870-821AA1262ED6}"/>
               </a:ext>
             </a:extLst>
           </p:cNvPr>
@@ -17103,7 +17103,7 @@
           <p:cNvPr id="6" name="">
             <a:extLst xmlns:a="http://schemas.openxmlformats.org/drawingml/2006/main">
               <a:ext uri="{FF2B5EF4-FFF2-40B4-BE49-F238E27FC236}">
-                <a16:creationId xmlns:a16="http://schemas.microsoft.com/office/drawing/2014/main" id="{D45D8B2C-575F-4306-A02F-5E86F6910A1F}"/>
+                <a16:creationId xmlns:a16="http://schemas.microsoft.com/office/drawing/2014/main" id="{D7870631-3313-4468-9834-BB7E6E9645A1}"/>
               </a:ext>
             </a:extLst>
           </p:cNvPr>
@@ -17258,7 +17258,7 @@
     </p:spTree>
     <p:extLst>
       <p:ext uri="{BB962C8B-B14F-4D97-AF65-F5344CB8AC3E}">
-        <p14:creationId xmlns:p14="http://schemas.microsoft.com/office/powerpoint/2010/main" val="1109012407"/>
+        <p14:creationId xmlns:p14="http://schemas.microsoft.com/office/powerpoint/2010/main" val="1024052472"/>
       </p:ext>
     </p:extLst>
   </p:cSld>
@@ -17289,7 +17289,7 @@
           <p:cNvPr id="7" name="">
             <a:extLst xmlns:a="http://schemas.openxmlformats.org/drawingml/2006/main">
               <a:ext uri="{FF2B5EF4-FFF2-40B4-BE49-F238E27FC236}">
-                <a16:creationId xmlns:a16="http://schemas.microsoft.com/office/drawing/2014/main" id="{3FC9A00B-4ECF-4FEB-A1B4-136649EA6A69}"/>
+                <a16:creationId xmlns:a16="http://schemas.microsoft.com/office/drawing/2014/main" id="{FFD50925-D5AD-409B-81AF-A113D89C98BC}"/>
               </a:ext>
             </a:extLst>
           </p:cNvPr>
@@ -17320,7 +17320,7 @@
           <p:cNvPr id="2" name="">
             <a:extLst xmlns:a="http://schemas.openxmlformats.org/drawingml/2006/main">
               <a:ext uri="{FF2B5EF4-FFF2-40B4-BE49-F238E27FC236}">
-                <a16:creationId xmlns:a16="http://schemas.microsoft.com/office/drawing/2014/main" id="{0E4AB8F4-866F-4C50-9E9F-D69237517079}"/>
+                <a16:creationId xmlns:a16="http://schemas.microsoft.com/office/drawing/2014/main" id="{64C45344-CB29-463C-A45F-2BC47224E872}"/>
               </a:ext>
             </a:extLst>
           </p:cNvPr>
@@ -17351,7 +17351,7 @@
           <p:cNvPr id="3" name="">
             <a:extLst xmlns:a="http://schemas.openxmlformats.org/drawingml/2006/main">
               <a:ext uri="{FF2B5EF4-FFF2-40B4-BE49-F238E27FC236}">
-                <a16:creationId xmlns:a16="http://schemas.microsoft.com/office/drawing/2014/main" id="{3248DDBB-F2C7-492C-89B2-64B278B8605D}"/>
+                <a16:creationId xmlns:a16="http://schemas.microsoft.com/office/drawing/2014/main" id="{52B2532B-AE31-4EB3-9429-C60D2CBF5261}"/>
               </a:ext>
             </a:extLst>
           </p:cNvPr>
@@ -17508,7 +17508,7 @@
           <p:cNvPr id="4" name="">
             <a:extLst xmlns:a="http://schemas.openxmlformats.org/drawingml/2006/main">
               <a:ext uri="{FF2B5EF4-FFF2-40B4-BE49-F238E27FC236}">
-                <a16:creationId xmlns:a16="http://schemas.microsoft.com/office/drawing/2014/main" id="{36C819E4-08AC-4349-96B5-D4718D612752}"/>
+                <a16:creationId xmlns:a16="http://schemas.microsoft.com/office/drawing/2014/main" id="{C05E07C7-6C98-4F5A-828D-E01EDB53ECF2}"/>
               </a:ext>
             </a:extLst>
           </p:cNvPr>
@@ -17539,7 +17539,7 @@
           <p:cNvPr id="5" name="">
             <a:extLst xmlns:a="http://schemas.openxmlformats.org/drawingml/2006/main">
               <a:ext uri="{FF2B5EF4-FFF2-40B4-BE49-F238E27FC236}">
-                <a16:creationId xmlns:a16="http://schemas.microsoft.com/office/drawing/2014/main" id="{F52C9320-2C7B-4374-B9B8-B3CD8C5471E2}"/>
+                <a16:creationId xmlns:a16="http://schemas.microsoft.com/office/drawing/2014/main" id="{10B0270D-7142-4FBA-9152-3A4B56CBA14A}"/>
               </a:ext>
             </a:extLst>
           </p:cNvPr>
@@ -17696,7 +17696,7 @@
           <p:cNvPr id="6" name="">
             <a:extLst xmlns:a="http://schemas.openxmlformats.org/drawingml/2006/main">
               <a:ext uri="{FF2B5EF4-FFF2-40B4-BE49-F238E27FC236}">
-                <a16:creationId xmlns:a16="http://schemas.microsoft.com/office/drawing/2014/main" id="{29F21F30-D855-4A2A-AB38-92F9B0ABC5BB}"/>
+                <a16:creationId xmlns:a16="http://schemas.microsoft.com/office/drawing/2014/main" id="{A6C2088F-61F2-4C4F-9F35-7E07E417E31D}"/>
               </a:ext>
             </a:extLst>
           </p:cNvPr>
@@ -17851,7 +17851,7 @@
     </p:spTree>
     <p:extLst>
       <p:ext uri="{BB962C8B-B14F-4D97-AF65-F5344CB8AC3E}">
-        <p14:creationId xmlns:p14="http://schemas.microsoft.com/office/powerpoint/2010/main" val="1068694238"/>
+        <p14:creationId xmlns:p14="http://schemas.microsoft.com/office/powerpoint/2010/main" val="1028989388"/>
       </p:ext>
     </p:extLst>
   </p:cSld>
@@ -17882,7 +17882,7 @@
           <p:cNvPr id="7" name="">
             <a:extLst xmlns:a="http://schemas.openxmlformats.org/drawingml/2006/main">
               <a:ext uri="{FF2B5EF4-FFF2-40B4-BE49-F238E27FC236}">
-                <a16:creationId xmlns:a16="http://schemas.microsoft.com/office/drawing/2014/main" id="{560070F4-D1DD-459C-9847-17AEA5507FA8}"/>
+                <a16:creationId xmlns:a16="http://schemas.microsoft.com/office/drawing/2014/main" id="{43BA8669-D1AD-41C8-A2BC-33FC2309CAF8}"/>
               </a:ext>
             </a:extLst>
           </p:cNvPr>
@@ -17913,7 +17913,7 @@
           <p:cNvPr id="2" name="">
             <a:extLst xmlns:a="http://schemas.openxmlformats.org/drawingml/2006/main">
               <a:ext uri="{FF2B5EF4-FFF2-40B4-BE49-F238E27FC236}">
-                <a16:creationId xmlns:a16="http://schemas.microsoft.com/office/drawing/2014/main" id="{4EC38A99-8567-4279-95A2-60B1534523A1}"/>
+                <a16:creationId xmlns:a16="http://schemas.microsoft.com/office/drawing/2014/main" id="{8B0DCB0D-87EB-4D18-B07A-DD2ABCDF5EB7}"/>
               </a:ext>
             </a:extLst>
           </p:cNvPr>
@@ -17944,7 +17944,7 @@
           <p:cNvPr id="3" name="">
             <a:extLst xmlns:a="http://schemas.openxmlformats.org/drawingml/2006/main">
               <a:ext uri="{FF2B5EF4-FFF2-40B4-BE49-F238E27FC236}">
-                <a16:creationId xmlns:a16="http://schemas.microsoft.com/office/drawing/2014/main" id="{0FFF7C12-A90F-41DA-B21B-06BF07A3942A}"/>
+                <a16:creationId xmlns:a16="http://schemas.microsoft.com/office/drawing/2014/main" id="{FAA8BCE1-0229-457E-8BCA-A72441D6466C}"/>
               </a:ext>
             </a:extLst>
           </p:cNvPr>
@@ -18101,7 +18101,7 @@
           <p:cNvPr id="4" name="">
             <a:extLst xmlns:a="http://schemas.openxmlformats.org/drawingml/2006/main">
               <a:ext uri="{FF2B5EF4-FFF2-40B4-BE49-F238E27FC236}">
-                <a16:creationId xmlns:a16="http://schemas.microsoft.com/office/drawing/2014/main" id="{1D493055-60A3-42E1-8D19-5EAB1759E1F8}"/>
+                <a16:creationId xmlns:a16="http://schemas.microsoft.com/office/drawing/2014/main" id="{C9BB806E-E62E-446F-AF24-47EF64FFA96C}"/>
               </a:ext>
             </a:extLst>
           </p:cNvPr>
@@ -18132,7 +18132,7 @@
           <p:cNvPr id="5" name="">
             <a:extLst xmlns:a="http://schemas.openxmlformats.org/drawingml/2006/main">
               <a:ext uri="{FF2B5EF4-FFF2-40B4-BE49-F238E27FC236}">
-                <a16:creationId xmlns:a16="http://schemas.microsoft.com/office/drawing/2014/main" id="{26E47A44-85D7-4B21-B641-238AEE394546}"/>
+                <a16:creationId xmlns:a16="http://schemas.microsoft.com/office/drawing/2014/main" id="{9C699C9C-1A1B-4115-8288-C9B3E03C6C48}"/>
               </a:ext>
             </a:extLst>
           </p:cNvPr>
@@ -18312,7 +18312,7 @@
           <p:cNvPr id="6" name="">
             <a:extLst xmlns:a="http://schemas.openxmlformats.org/drawingml/2006/main">
               <a:ext uri="{FF2B5EF4-FFF2-40B4-BE49-F238E27FC236}">
-                <a16:creationId xmlns:a16="http://schemas.microsoft.com/office/drawing/2014/main" id="{F6091BC9-2C2D-4BE7-9A50-1A3B1D4C2EF2}"/>
+                <a16:creationId xmlns:a16="http://schemas.microsoft.com/office/drawing/2014/main" id="{054CB506-C3FB-48DC-81D9-DD93EE2D43A3}"/>
               </a:ext>
             </a:extLst>
           </p:cNvPr>
@@ -18467,7 +18467,7 @@
     </p:spTree>
     <p:extLst>
       <p:ext uri="{BB962C8B-B14F-4D97-AF65-F5344CB8AC3E}">
-        <p14:creationId xmlns:p14="http://schemas.microsoft.com/office/powerpoint/2010/main" val="998027149"/>
+        <p14:creationId xmlns:p14="http://schemas.microsoft.com/office/powerpoint/2010/main" val="1572283067"/>
       </p:ext>
     </p:extLst>
   </p:cSld>
@@ -18498,7 +18498,7 @@
           <p:cNvPr id="7" name="">
             <a:extLst xmlns:a="http://schemas.openxmlformats.org/drawingml/2006/main">
               <a:ext uri="{FF2B5EF4-FFF2-40B4-BE49-F238E27FC236}">
-                <a16:creationId xmlns:a16="http://schemas.microsoft.com/office/drawing/2014/main" id="{1DF20C04-9BCB-4650-9C80-13F55E40687E}"/>
+                <a16:creationId xmlns:a16="http://schemas.microsoft.com/office/drawing/2014/main" id="{C2904B10-79CE-4FBC-B6D2-66C7F9A20DFB}"/>
               </a:ext>
             </a:extLst>
           </p:cNvPr>
@@ -18529,7 +18529,7 @@
           <p:cNvPr id="2" name="">
             <a:extLst xmlns:a="http://schemas.openxmlformats.org/drawingml/2006/main">
               <a:ext uri="{FF2B5EF4-FFF2-40B4-BE49-F238E27FC236}">
-                <a16:creationId xmlns:a16="http://schemas.microsoft.com/office/drawing/2014/main" id="{B986A2BB-C837-4B7E-BC21-44D7CE0A679A}"/>
+                <a16:creationId xmlns:a16="http://schemas.microsoft.com/office/drawing/2014/main" id="{9A7C28D3-CBBB-403E-96BA-61FF5849D6ED}"/>
               </a:ext>
             </a:extLst>
           </p:cNvPr>
@@ -18560,7 +18560,7 @@
           <p:cNvPr id="3" name="">
             <a:extLst xmlns:a="http://schemas.openxmlformats.org/drawingml/2006/main">
               <a:ext uri="{FF2B5EF4-FFF2-40B4-BE49-F238E27FC236}">
-                <a16:creationId xmlns:a16="http://schemas.microsoft.com/office/drawing/2014/main" id="{8212060A-2CDA-42F6-85C3-178292C322FE}"/>
+                <a16:creationId xmlns:a16="http://schemas.microsoft.com/office/drawing/2014/main" id="{CC535F3F-D20D-488F-9866-9299744B8ADC}"/>
               </a:ext>
             </a:extLst>
           </p:cNvPr>
@@ -18717,7 +18717,7 @@
           <p:cNvPr id="4" name="">
             <a:extLst xmlns:a="http://schemas.openxmlformats.org/drawingml/2006/main">
               <a:ext uri="{FF2B5EF4-FFF2-40B4-BE49-F238E27FC236}">
-                <a16:creationId xmlns:a16="http://schemas.microsoft.com/office/drawing/2014/main" id="{2A85DB33-F238-4E9C-A11B-FFCF91183C5E}"/>
+                <a16:creationId xmlns:a16="http://schemas.microsoft.com/office/drawing/2014/main" id="{5AFF509B-9702-4389-8072-28A0E22BA541}"/>
               </a:ext>
             </a:extLst>
           </p:cNvPr>
@@ -18748,7 +18748,7 @@
           <p:cNvPr id="5" name="">
             <a:extLst xmlns:a="http://schemas.openxmlformats.org/drawingml/2006/main">
               <a:ext uri="{FF2B5EF4-FFF2-40B4-BE49-F238E27FC236}">
-                <a16:creationId xmlns:a16="http://schemas.microsoft.com/office/drawing/2014/main" id="{F314A965-5FA8-4497-AEDC-0153160878E0}"/>
+                <a16:creationId xmlns:a16="http://schemas.microsoft.com/office/drawing/2014/main" id="{03F8E96D-AF4A-4EBF-B5A1-A611F4A968D2}"/>
               </a:ext>
             </a:extLst>
           </p:cNvPr>
@@ -18905,7 +18905,7 @@
           <p:cNvPr id="6" name="">
             <a:extLst xmlns:a="http://schemas.openxmlformats.org/drawingml/2006/main">
               <a:ext uri="{FF2B5EF4-FFF2-40B4-BE49-F238E27FC236}">
-                <a16:creationId xmlns:a16="http://schemas.microsoft.com/office/drawing/2014/main" id="{B50BC247-F74B-4A01-A865-1ED669B63525}"/>
+                <a16:creationId xmlns:a16="http://schemas.microsoft.com/office/drawing/2014/main" id="{0ECEC351-80AF-4DDE-A65A-8891559438C6}"/>
               </a:ext>
             </a:extLst>
           </p:cNvPr>
@@ -19060,7 +19060,7 @@
     </p:spTree>
     <p:extLst>
       <p:ext uri="{BB962C8B-B14F-4D97-AF65-F5344CB8AC3E}">
-        <p14:creationId xmlns:p14="http://schemas.microsoft.com/office/powerpoint/2010/main" val="919249507"/>
+        <p14:creationId xmlns:p14="http://schemas.microsoft.com/office/powerpoint/2010/main" val="294663394"/>
       </p:ext>
     </p:extLst>
   </p:cSld>
@@ -19091,7 +19091,7 @@
           <p:cNvPr id="7" name="">
             <a:extLst xmlns:a="http://schemas.openxmlformats.org/drawingml/2006/main">
               <a:ext uri="{FF2B5EF4-FFF2-40B4-BE49-F238E27FC236}">
-                <a16:creationId xmlns:a16="http://schemas.microsoft.com/office/drawing/2014/main" id="{AC5D2935-4818-418C-B7C2-AFB94D09953A}"/>
+                <a16:creationId xmlns:a16="http://schemas.microsoft.com/office/drawing/2014/main" id="{656AFB35-9538-45D2-B3D1-67BFABC7C3BC}"/>
               </a:ext>
             </a:extLst>
           </p:cNvPr>
@@ -19122,7 +19122,7 @@
           <p:cNvPr id="2" name="">
             <a:extLst xmlns:a="http://schemas.openxmlformats.org/drawingml/2006/main">
               <a:ext uri="{FF2B5EF4-FFF2-40B4-BE49-F238E27FC236}">
-                <a16:creationId xmlns:a16="http://schemas.microsoft.com/office/drawing/2014/main" id="{77587463-2055-4A44-B585-55FA367A32B6}"/>
+                <a16:creationId xmlns:a16="http://schemas.microsoft.com/office/drawing/2014/main" id="{7073E7D5-A766-4E79-AAFB-B2A079B3A204}"/>
               </a:ext>
             </a:extLst>
           </p:cNvPr>
@@ -19153,7 +19153,7 @@
           <p:cNvPr id="3" name="">
             <a:extLst xmlns:a="http://schemas.openxmlformats.org/drawingml/2006/main">
               <a:ext uri="{FF2B5EF4-FFF2-40B4-BE49-F238E27FC236}">
-                <a16:creationId xmlns:a16="http://schemas.microsoft.com/office/drawing/2014/main" id="{33658A85-10BE-4483-A139-DD51B2394715}"/>
+                <a16:creationId xmlns:a16="http://schemas.microsoft.com/office/drawing/2014/main" id="{A9DBB6B8-0B2A-4B0F-90F5-93A34D45F8AD}"/>
               </a:ext>
             </a:extLst>
           </p:cNvPr>
@@ -19310,7 +19310,7 @@
           <p:cNvPr id="4" name="">
             <a:extLst xmlns:a="http://schemas.openxmlformats.org/drawingml/2006/main">
               <a:ext uri="{FF2B5EF4-FFF2-40B4-BE49-F238E27FC236}">
-                <a16:creationId xmlns:a16="http://schemas.microsoft.com/office/drawing/2014/main" id="{7CC3C136-9D87-4808-9995-3D02356E42CB}"/>
+                <a16:creationId xmlns:a16="http://schemas.microsoft.com/office/drawing/2014/main" id="{39BB8F2B-7909-475C-9206-674974A80821}"/>
               </a:ext>
             </a:extLst>
           </p:cNvPr>
@@ -19341,7 +19341,7 @@
           <p:cNvPr id="5" name="">
             <a:extLst xmlns:a="http://schemas.openxmlformats.org/drawingml/2006/main">
               <a:ext uri="{FF2B5EF4-FFF2-40B4-BE49-F238E27FC236}">
-                <a16:creationId xmlns:a16="http://schemas.microsoft.com/office/drawing/2014/main" id="{41BCC27E-EB5D-4241-82BC-8087B94706B6}"/>
+                <a16:creationId xmlns:a16="http://schemas.microsoft.com/office/drawing/2014/main" id="{FFFE0686-92D5-4831-B3EF-F7D940D5067F}"/>
               </a:ext>
             </a:extLst>
           </p:cNvPr>
@@ -19498,7 +19498,7 @@
           <p:cNvPr id="6" name="">
             <a:extLst xmlns:a="http://schemas.openxmlformats.org/drawingml/2006/main">
               <a:ext uri="{FF2B5EF4-FFF2-40B4-BE49-F238E27FC236}">
-                <a16:creationId xmlns:a16="http://schemas.microsoft.com/office/drawing/2014/main" id="{D4B59E74-31B1-41A5-8C50-D81FAE213165}"/>
+                <a16:creationId xmlns:a16="http://schemas.microsoft.com/office/drawing/2014/main" id="{DA01073B-B3DB-4220-AB54-F407321C1400}"/>
               </a:ext>
             </a:extLst>
           </p:cNvPr>
@@ -19653,7 +19653,7 @@
     </p:spTree>
     <p:extLst>
       <p:ext uri="{BB962C8B-B14F-4D97-AF65-F5344CB8AC3E}">
-        <p14:creationId xmlns:p14="http://schemas.microsoft.com/office/powerpoint/2010/main" val="1639170519"/>
+        <p14:creationId xmlns:p14="http://schemas.microsoft.com/office/powerpoint/2010/main" val="1379175739"/>
       </p:ext>
     </p:extLst>
   </p:cSld>
@@ -19684,7 +19684,7 @@
           <p:cNvPr id="7" name="">
             <a:extLst xmlns:a="http://schemas.openxmlformats.org/drawingml/2006/main">
               <a:ext uri="{FF2B5EF4-FFF2-40B4-BE49-F238E27FC236}">
-                <a16:creationId xmlns:a16="http://schemas.microsoft.com/office/drawing/2014/main" id="{31488B18-DB2F-4D3F-8506-7D8B3CDC5168}"/>
+                <a16:creationId xmlns:a16="http://schemas.microsoft.com/office/drawing/2014/main" id="{0788590F-A871-49DA-9A13-08A529F2E027}"/>
               </a:ext>
             </a:extLst>
           </p:cNvPr>
@@ -19715,7 +19715,7 @@
           <p:cNvPr id="2" name="">
             <a:extLst xmlns:a="http://schemas.openxmlformats.org/drawingml/2006/main">
               <a:ext uri="{FF2B5EF4-FFF2-40B4-BE49-F238E27FC236}">
-                <a16:creationId xmlns:a16="http://schemas.microsoft.com/office/drawing/2014/main" id="{32F8763C-1C52-4E0C-B5D8-A71D1F4BF90A}"/>
+                <a16:creationId xmlns:a16="http://schemas.microsoft.com/office/drawing/2014/main" id="{AA0B2B90-2FF5-49D2-8A4B-64510A54D0D6}"/>
               </a:ext>
             </a:extLst>
           </p:cNvPr>
@@ -19746,7 +19746,7 @@
           <p:cNvPr id="3" name="">
             <a:extLst xmlns:a="http://schemas.openxmlformats.org/drawingml/2006/main">
               <a:ext uri="{FF2B5EF4-FFF2-40B4-BE49-F238E27FC236}">
-                <a16:creationId xmlns:a16="http://schemas.microsoft.com/office/drawing/2014/main" id="{BA9449F4-A06E-4584-B76A-D7728CDDEF05}"/>
+                <a16:creationId xmlns:a16="http://schemas.microsoft.com/office/drawing/2014/main" id="{475555C8-65DF-4856-8B21-E8EAD3D4EE94}"/>
               </a:ext>
             </a:extLst>
           </p:cNvPr>
@@ -19926,7 +19926,7 @@
           <p:cNvPr id="4" name="">
             <a:extLst xmlns:a="http://schemas.openxmlformats.org/drawingml/2006/main">
               <a:ext uri="{FF2B5EF4-FFF2-40B4-BE49-F238E27FC236}">
-                <a16:creationId xmlns:a16="http://schemas.microsoft.com/office/drawing/2014/main" id="{4E699189-DE98-4830-B182-781B1011D355}"/>
+                <a16:creationId xmlns:a16="http://schemas.microsoft.com/office/drawing/2014/main" id="{0E43543E-5CE5-4137-ADFE-F81F6DBA3497}"/>
               </a:ext>
             </a:extLst>
           </p:cNvPr>
@@ -19957,7 +19957,7 @@
           <p:cNvPr id="5" name="">
             <a:extLst xmlns:a="http://schemas.openxmlformats.org/drawingml/2006/main">
               <a:ext uri="{FF2B5EF4-FFF2-40B4-BE49-F238E27FC236}">
-                <a16:creationId xmlns:a16="http://schemas.microsoft.com/office/drawing/2014/main" id="{C95A5E8C-A6CD-47A5-BC17-3368D943A8A3}"/>
+                <a16:creationId xmlns:a16="http://schemas.microsoft.com/office/drawing/2014/main" id="{346595D5-AA62-4F66-8AEF-B3CA08DD6CCA}"/>
               </a:ext>
             </a:extLst>
           </p:cNvPr>
@@ -20114,7 +20114,7 @@
           <p:cNvPr id="6" name="">
             <a:extLst xmlns:a="http://schemas.openxmlformats.org/drawingml/2006/main">
               <a:ext uri="{FF2B5EF4-FFF2-40B4-BE49-F238E27FC236}">
-                <a16:creationId xmlns:a16="http://schemas.microsoft.com/office/drawing/2014/main" id="{4407D9E3-31BC-4EA5-9A72-B7495B9E5B4F}"/>
+                <a16:creationId xmlns:a16="http://schemas.microsoft.com/office/drawing/2014/main" id="{443CFD9E-5381-4F62-A1A3-A81144CC3B62}"/>
               </a:ext>
             </a:extLst>
           </p:cNvPr>
@@ -20269,7 +20269,7 @@
     </p:spTree>
     <p:extLst>
       <p:ext uri="{BB962C8B-B14F-4D97-AF65-F5344CB8AC3E}">
-        <p14:creationId xmlns:p14="http://schemas.microsoft.com/office/powerpoint/2010/main" val="54364584"/>
+        <p14:creationId xmlns:p14="http://schemas.microsoft.com/office/powerpoint/2010/main" val="1551734078"/>
       </p:ext>
     </p:extLst>
   </p:cSld>
@@ -20300,7 +20300,7 @@
           <p:cNvPr id="7" name="">
             <a:extLst xmlns:a="http://schemas.openxmlformats.org/drawingml/2006/main">
               <a:ext uri="{FF2B5EF4-FFF2-40B4-BE49-F238E27FC236}">
-                <a16:creationId xmlns:a16="http://schemas.microsoft.com/office/drawing/2014/main" id="{06CD8CEC-669E-45AA-9F2F-ED71AF585B48}"/>
+                <a16:creationId xmlns:a16="http://schemas.microsoft.com/office/drawing/2014/main" id="{02CA7A25-913E-4185-A9CB-968B830441B3}"/>
               </a:ext>
             </a:extLst>
           </p:cNvPr>
@@ -20331,7 +20331,7 @@
           <p:cNvPr id="2" name="">
             <a:extLst xmlns:a="http://schemas.openxmlformats.org/drawingml/2006/main">
               <a:ext uri="{FF2B5EF4-FFF2-40B4-BE49-F238E27FC236}">
-                <a16:creationId xmlns:a16="http://schemas.microsoft.com/office/drawing/2014/main" id="{254C33FF-F4A0-4EC7-A665-0CB80ED900D8}"/>
+                <a16:creationId xmlns:a16="http://schemas.microsoft.com/office/drawing/2014/main" id="{87155E80-4820-496E-BC55-EC485809E31A}"/>
               </a:ext>
             </a:extLst>
           </p:cNvPr>
@@ -20362,7 +20362,7 @@
           <p:cNvPr id="3" name="">
             <a:extLst xmlns:a="http://schemas.openxmlformats.org/drawingml/2006/main">
               <a:ext uri="{FF2B5EF4-FFF2-40B4-BE49-F238E27FC236}">
-                <a16:creationId xmlns:a16="http://schemas.microsoft.com/office/drawing/2014/main" id="{7BDACF3A-AC42-4836-BCEB-7001BA6BF435}"/>
+                <a16:creationId xmlns:a16="http://schemas.microsoft.com/office/drawing/2014/main" id="{31FC96D8-CF7B-4E96-AE9A-97E223C766B9}"/>
               </a:ext>
             </a:extLst>
           </p:cNvPr>
@@ -20519,7 +20519,7 @@
           <p:cNvPr id="4" name="">
             <a:extLst xmlns:a="http://schemas.openxmlformats.org/drawingml/2006/main">
               <a:ext uri="{FF2B5EF4-FFF2-40B4-BE49-F238E27FC236}">
-                <a16:creationId xmlns:a16="http://schemas.microsoft.com/office/drawing/2014/main" id="{F0D8D189-FE72-4E66-838B-2BB64D43E803}"/>
+                <a16:creationId xmlns:a16="http://schemas.microsoft.com/office/drawing/2014/main" id="{8893B875-363C-4D96-98B4-260A64F68288}"/>
               </a:ext>
             </a:extLst>
           </p:cNvPr>
@@ -20550,7 +20550,7 @@
           <p:cNvPr id="5" name="">
             <a:extLst xmlns:a="http://schemas.openxmlformats.org/drawingml/2006/main">
               <a:ext uri="{FF2B5EF4-FFF2-40B4-BE49-F238E27FC236}">
-                <a16:creationId xmlns:a16="http://schemas.microsoft.com/office/drawing/2014/main" id="{10712B1F-FD15-4899-8621-E6E16A3D5C0E}"/>
+                <a16:creationId xmlns:a16="http://schemas.microsoft.com/office/drawing/2014/main" id="{AFC9296A-FC2A-48C0-BF70-08447BDC34AA}"/>
               </a:ext>
             </a:extLst>
           </p:cNvPr>
@@ -20707,7 +20707,7 @@
           <p:cNvPr id="6" name="">
             <a:extLst xmlns:a="http://schemas.openxmlformats.org/drawingml/2006/main">
               <a:ext uri="{FF2B5EF4-FFF2-40B4-BE49-F238E27FC236}">
-                <a16:creationId xmlns:a16="http://schemas.microsoft.com/office/drawing/2014/main" id="{64532E51-EC4E-43F6-918B-15ED967E1CA3}"/>
+                <a16:creationId xmlns:a16="http://schemas.microsoft.com/office/drawing/2014/main" id="{F9C8A197-D3E1-4091-87CD-E8650DDA977E}"/>
               </a:ext>
             </a:extLst>
           </p:cNvPr>
@@ -20862,7 +20862,7 @@
     </p:spTree>
     <p:extLst>
       <p:ext uri="{BB962C8B-B14F-4D97-AF65-F5344CB8AC3E}">
-        <p14:creationId xmlns:p14="http://schemas.microsoft.com/office/powerpoint/2010/main" val="640454280"/>
+        <p14:creationId xmlns:p14="http://schemas.microsoft.com/office/powerpoint/2010/main" val="1873744322"/>
       </p:ext>
     </p:extLst>
   </p:cSld>
@@ -20893,7 +20893,7 @@
           <p:cNvPr id="7" name="">
             <a:extLst xmlns:a="http://schemas.openxmlformats.org/drawingml/2006/main">
               <a:ext uri="{FF2B5EF4-FFF2-40B4-BE49-F238E27FC236}">
-                <a16:creationId xmlns:a16="http://schemas.microsoft.com/office/drawing/2014/main" id="{706FED3A-620B-4474-97BB-94CC39D2FFC3}"/>
+                <a16:creationId xmlns:a16="http://schemas.microsoft.com/office/drawing/2014/main" id="{E2060584-75B7-4C97-9810-160A5BD090F7}"/>
               </a:ext>
             </a:extLst>
           </p:cNvPr>
@@ -20924,7 +20924,7 @@
           <p:cNvPr id="2" name="">
             <a:extLst xmlns:a="http://schemas.openxmlformats.org/drawingml/2006/main">
               <a:ext uri="{FF2B5EF4-FFF2-40B4-BE49-F238E27FC236}">
-                <a16:creationId xmlns:a16="http://schemas.microsoft.com/office/drawing/2014/main" id="{5E80862A-CF2C-4EE0-ABB8-4D894523F632}"/>
+                <a16:creationId xmlns:a16="http://schemas.microsoft.com/office/drawing/2014/main" id="{75006B17-BED4-4AAB-B289-E57E08AB6664}"/>
               </a:ext>
             </a:extLst>
           </p:cNvPr>
@@ -20955,7 +20955,7 @@
           <p:cNvPr id="3" name="">
             <a:extLst xmlns:a="http://schemas.openxmlformats.org/drawingml/2006/main">
               <a:ext uri="{FF2B5EF4-FFF2-40B4-BE49-F238E27FC236}">
-                <a16:creationId xmlns:a16="http://schemas.microsoft.com/office/drawing/2014/main" id="{7936A9D7-CE0F-47AE-ACDD-912A2E035BCB}"/>
+                <a16:creationId xmlns:a16="http://schemas.microsoft.com/office/drawing/2014/main" id="{8C249A52-E333-401C-80B5-FF6D09796867}"/>
               </a:ext>
             </a:extLst>
           </p:cNvPr>
@@ -21135,7 +21135,7 @@
           <p:cNvPr id="4" name="">
             <a:extLst xmlns:a="http://schemas.openxmlformats.org/drawingml/2006/main">
               <a:ext uri="{FF2B5EF4-FFF2-40B4-BE49-F238E27FC236}">
-                <a16:creationId xmlns:a16="http://schemas.microsoft.com/office/drawing/2014/main" id="{1FF3E60A-7080-4431-865D-4717F0964ABD}"/>
+                <a16:creationId xmlns:a16="http://schemas.microsoft.com/office/drawing/2014/main" id="{A0FD556A-7664-48EE-94F5-1C6EC6C08AD6}"/>
               </a:ext>
             </a:extLst>
           </p:cNvPr>
@@ -21166,7 +21166,7 @@
           <p:cNvPr id="5" name="">
             <a:extLst xmlns:a="http://schemas.openxmlformats.org/drawingml/2006/main">
               <a:ext uri="{FF2B5EF4-FFF2-40B4-BE49-F238E27FC236}">
-                <a16:creationId xmlns:a16="http://schemas.microsoft.com/office/drawing/2014/main" id="{FFD5B44F-6B3B-463F-9C77-CB2947519B61}"/>
+                <a16:creationId xmlns:a16="http://schemas.microsoft.com/office/drawing/2014/main" id="{6248D2EF-7D88-4101-A380-1C49D19C7B47}"/>
               </a:ext>
             </a:extLst>
           </p:cNvPr>
@@ -21323,7 +21323,7 @@
           <p:cNvPr id="6" name="">
             <a:extLst xmlns:a="http://schemas.openxmlformats.org/drawingml/2006/main">
               <a:ext uri="{FF2B5EF4-FFF2-40B4-BE49-F238E27FC236}">
-                <a16:creationId xmlns:a16="http://schemas.microsoft.com/office/drawing/2014/main" id="{A5D74A68-57E9-4901-B6E7-328C1F82D876}"/>
+                <a16:creationId xmlns:a16="http://schemas.microsoft.com/office/drawing/2014/main" id="{42C0A859-9A68-4CB6-A7AC-FD0025B48750}"/>
               </a:ext>
             </a:extLst>
           </p:cNvPr>
@@ -21478,7 +21478,7 @@
     </p:spTree>
     <p:extLst>
       <p:ext uri="{BB962C8B-B14F-4D97-AF65-F5344CB8AC3E}">
-        <p14:creationId xmlns:p14="http://schemas.microsoft.com/office/powerpoint/2010/main" val="1176266301"/>
+        <p14:creationId xmlns:p14="http://schemas.microsoft.com/office/powerpoint/2010/main" val="940022140"/>
       </p:ext>
     </p:extLst>
   </p:cSld>
@@ -21509,7 +21509,7 @@
           <p:cNvPr id="7" name="">
             <a:extLst xmlns:a="http://schemas.openxmlformats.org/drawingml/2006/main">
               <a:ext uri="{FF2B5EF4-FFF2-40B4-BE49-F238E27FC236}">
-                <a16:creationId xmlns:a16="http://schemas.microsoft.com/office/drawing/2014/main" id="{A4C3BAB1-92AE-42C8-9E75-36DF173D9539}"/>
+                <a16:creationId xmlns:a16="http://schemas.microsoft.com/office/drawing/2014/main" id="{DD634429-5EC8-442B-98BF-849A7BADECBA}"/>
               </a:ext>
             </a:extLst>
           </p:cNvPr>
@@ -21540,7 +21540,7 @@
           <p:cNvPr id="2" name="">
             <a:extLst xmlns:a="http://schemas.openxmlformats.org/drawingml/2006/main">
               <a:ext uri="{FF2B5EF4-FFF2-40B4-BE49-F238E27FC236}">
-                <a16:creationId xmlns:a16="http://schemas.microsoft.com/office/drawing/2014/main" id="{74C5B140-ADFF-46C4-BC71-857CA35CB41A}"/>
+                <a16:creationId xmlns:a16="http://schemas.microsoft.com/office/drawing/2014/main" id="{8EE3A526-7D30-4653-8154-B8DD2D46FBCC}"/>
               </a:ext>
             </a:extLst>
           </p:cNvPr>
@@ -21571,7 +21571,7 @@
           <p:cNvPr id="3" name="">
             <a:extLst xmlns:a="http://schemas.openxmlformats.org/drawingml/2006/main">
               <a:ext uri="{FF2B5EF4-FFF2-40B4-BE49-F238E27FC236}">
-                <a16:creationId xmlns:a16="http://schemas.microsoft.com/office/drawing/2014/main" id="{28055C3C-8470-417F-81BE-7B6BC877A76D}"/>
+                <a16:creationId xmlns:a16="http://schemas.microsoft.com/office/drawing/2014/main" id="{0BD78106-D199-4CCE-BC92-3F287EB4411B}"/>
               </a:ext>
             </a:extLst>
           </p:cNvPr>
@@ -21728,7 +21728,7 @@
           <p:cNvPr id="4" name="">
             <a:extLst xmlns:a="http://schemas.openxmlformats.org/drawingml/2006/main">
               <a:ext uri="{FF2B5EF4-FFF2-40B4-BE49-F238E27FC236}">
-                <a16:creationId xmlns:a16="http://schemas.microsoft.com/office/drawing/2014/main" id="{9613F74E-B1C3-4E22-9E0B-D478FCD255F1}"/>
+                <a16:creationId xmlns:a16="http://schemas.microsoft.com/office/drawing/2014/main" id="{56F5B905-6D1A-48D4-83F7-CF1A4150923F}"/>
               </a:ext>
             </a:extLst>
           </p:cNvPr>
@@ -21759,7 +21759,7 @@
           <p:cNvPr id="5" name="">
             <a:extLst xmlns:a="http://schemas.openxmlformats.org/drawingml/2006/main">
               <a:ext uri="{FF2B5EF4-FFF2-40B4-BE49-F238E27FC236}">
-                <a16:creationId xmlns:a16="http://schemas.microsoft.com/office/drawing/2014/main" id="{9B15A87A-4B62-4393-A920-D087CA278595}"/>
+                <a16:creationId xmlns:a16="http://schemas.microsoft.com/office/drawing/2014/main" id="{0DBB3FB0-CC80-44FB-BD18-E939DBBC9874}"/>
               </a:ext>
             </a:extLst>
           </p:cNvPr>
@@ -21916,7 +21916,7 @@
           <p:cNvPr id="6" name="">
             <a:extLst xmlns:a="http://schemas.openxmlformats.org/drawingml/2006/main">
               <a:ext uri="{FF2B5EF4-FFF2-40B4-BE49-F238E27FC236}">
-                <a16:creationId xmlns:a16="http://schemas.microsoft.com/office/drawing/2014/main" id="{5F0D07B6-6775-494E-89BE-0FFEB477B207}"/>
+                <a16:creationId xmlns:a16="http://schemas.microsoft.com/office/drawing/2014/main" id="{3B80E545-FE14-4440-97A1-E6E1D1EE96FA}"/>
               </a:ext>
             </a:extLst>
           </p:cNvPr>
@@ -22071,7 +22071,7 @@
     </p:spTree>
     <p:extLst>
       <p:ext uri="{BB962C8B-B14F-4D97-AF65-F5344CB8AC3E}">
-        <p14:creationId xmlns:p14="http://schemas.microsoft.com/office/powerpoint/2010/main" val="57408076"/>
+        <p14:creationId xmlns:p14="http://schemas.microsoft.com/office/powerpoint/2010/main" val="433561427"/>
       </p:ext>
     </p:extLst>
   </p:cSld>
@@ -22102,7 +22102,7 @@
           <p:cNvPr id="7" name="">
             <a:extLst xmlns:a="http://schemas.openxmlformats.org/drawingml/2006/main">
               <a:ext uri="{FF2B5EF4-FFF2-40B4-BE49-F238E27FC236}">
-                <a16:creationId xmlns:a16="http://schemas.microsoft.com/office/drawing/2014/main" id="{D54AC7DC-B380-468C-8A15-1765E4306FC5}"/>
+                <a16:creationId xmlns:a16="http://schemas.microsoft.com/office/drawing/2014/main" id="{7CE5DD48-BDDD-46F9-955C-30316D217135}"/>
               </a:ext>
             </a:extLst>
           </p:cNvPr>
@@ -22133,7 +22133,7 @@
           <p:cNvPr id="2" name="">
             <a:extLst xmlns:a="http://schemas.openxmlformats.org/drawingml/2006/main">
               <a:ext uri="{FF2B5EF4-FFF2-40B4-BE49-F238E27FC236}">
-                <a16:creationId xmlns:a16="http://schemas.microsoft.com/office/drawing/2014/main" id="{0B54C521-6942-4AE6-8FE5-726C6968E51F}"/>
+                <a16:creationId xmlns:a16="http://schemas.microsoft.com/office/drawing/2014/main" id="{404B22E7-93C2-49CE-AFD3-5EB137986C09}"/>
               </a:ext>
             </a:extLst>
           </p:cNvPr>
@@ -22164,7 +22164,7 @@
           <p:cNvPr id="3" name="">
             <a:extLst xmlns:a="http://schemas.openxmlformats.org/drawingml/2006/main">
               <a:ext uri="{FF2B5EF4-FFF2-40B4-BE49-F238E27FC236}">
-                <a16:creationId xmlns:a16="http://schemas.microsoft.com/office/drawing/2014/main" id="{622428C7-10AF-494A-A1FE-65F6A6D293B5}"/>
+                <a16:creationId xmlns:a16="http://schemas.microsoft.com/office/drawing/2014/main" id="{3F1FA143-81FF-4DB6-AD15-A1C25061176F}"/>
               </a:ext>
             </a:extLst>
           </p:cNvPr>
@@ -22321,7 +22321,7 @@
           <p:cNvPr id="4" name="">
             <a:extLst xmlns:a="http://schemas.openxmlformats.org/drawingml/2006/main">
               <a:ext uri="{FF2B5EF4-FFF2-40B4-BE49-F238E27FC236}">
-                <a16:creationId xmlns:a16="http://schemas.microsoft.com/office/drawing/2014/main" id="{D7F3FE67-B109-4D4E-93C3-9F0E46E68AA5}"/>
+                <a16:creationId xmlns:a16="http://schemas.microsoft.com/office/drawing/2014/main" id="{F04C1F00-58FA-4F20-A803-3BC6797EDE62}"/>
               </a:ext>
             </a:extLst>
           </p:cNvPr>
@@ -22352,7 +22352,7 @@
           <p:cNvPr id="5" name="">
             <a:extLst xmlns:a="http://schemas.openxmlformats.org/drawingml/2006/main">
               <a:ext uri="{FF2B5EF4-FFF2-40B4-BE49-F238E27FC236}">
-                <a16:creationId xmlns:a16="http://schemas.microsoft.com/office/drawing/2014/main" id="{15D44F23-FE87-4DAD-B7AD-DB9FDF278F07}"/>
+                <a16:creationId xmlns:a16="http://schemas.microsoft.com/office/drawing/2014/main" id="{AC7F402A-15C8-419E-A8FC-8FD79B798BB6}"/>
               </a:ext>
             </a:extLst>
           </p:cNvPr>
@@ -22509,7 +22509,7 @@
           <p:cNvPr id="6" name="">
             <a:extLst xmlns:a="http://schemas.openxmlformats.org/drawingml/2006/main">
               <a:ext uri="{FF2B5EF4-FFF2-40B4-BE49-F238E27FC236}">
-                <a16:creationId xmlns:a16="http://schemas.microsoft.com/office/drawing/2014/main" id="{20DE2041-6252-4C70-9796-30FCFA2983EE}"/>
+                <a16:creationId xmlns:a16="http://schemas.microsoft.com/office/drawing/2014/main" id="{06DA609E-3120-44D1-B89F-771A769B5039}"/>
               </a:ext>
             </a:extLst>
           </p:cNvPr>
@@ -22664,7 +22664,7 @@
     </p:spTree>
     <p:extLst>
       <p:ext uri="{BB962C8B-B14F-4D97-AF65-F5344CB8AC3E}">
-        <p14:creationId xmlns:p14="http://schemas.microsoft.com/office/powerpoint/2010/main" val="1088248010"/>
+        <p14:creationId xmlns:p14="http://schemas.microsoft.com/office/powerpoint/2010/main" val="1013309843"/>
       </p:ext>
     </p:extLst>
   </p:cSld>
@@ -22695,7 +22695,7 @@
           <p:cNvPr id="7" name="">
             <a:extLst xmlns:a="http://schemas.openxmlformats.org/drawingml/2006/main">
               <a:ext uri="{FF2B5EF4-FFF2-40B4-BE49-F238E27FC236}">
-                <a16:creationId xmlns:a16="http://schemas.microsoft.com/office/drawing/2014/main" id="{97FD9006-774D-4004-A2A7-122F9A025398}"/>
+                <a16:creationId xmlns:a16="http://schemas.microsoft.com/office/drawing/2014/main" id="{2C09A6F8-5B9A-459F-855F-D59C03122315}"/>
               </a:ext>
             </a:extLst>
           </p:cNvPr>
@@ -22726,7 +22726,7 @@
           <p:cNvPr id="2" name="">
             <a:extLst xmlns:a="http://schemas.openxmlformats.org/drawingml/2006/main">
               <a:ext uri="{FF2B5EF4-FFF2-40B4-BE49-F238E27FC236}">
-                <a16:creationId xmlns:a16="http://schemas.microsoft.com/office/drawing/2014/main" id="{B9719E7F-10A3-4729-AF70-98233794DE57}"/>
+                <a16:creationId xmlns:a16="http://schemas.microsoft.com/office/drawing/2014/main" id="{19CE34BA-7B74-4DFD-A54A-7ED4F0C934D1}"/>
               </a:ext>
             </a:extLst>
           </p:cNvPr>
@@ -22757,7 +22757,7 @@
           <p:cNvPr id="3" name="">
             <a:extLst xmlns:a="http://schemas.openxmlformats.org/drawingml/2006/main">
               <a:ext uri="{FF2B5EF4-FFF2-40B4-BE49-F238E27FC236}">
-                <a16:creationId xmlns:a16="http://schemas.microsoft.com/office/drawing/2014/main" id="{112563B0-9510-4491-9F41-6D2A9A3A4F1A}"/>
+                <a16:creationId xmlns:a16="http://schemas.microsoft.com/office/drawing/2014/main" id="{991D6E9E-B2EB-44A9-B317-DB3CD0D62C7C}"/>
               </a:ext>
             </a:extLst>
           </p:cNvPr>
@@ -22914,7 +22914,7 @@
           <p:cNvPr id="4" name="">
             <a:extLst xmlns:a="http://schemas.openxmlformats.org/drawingml/2006/main">
               <a:ext uri="{FF2B5EF4-FFF2-40B4-BE49-F238E27FC236}">
-                <a16:creationId xmlns:a16="http://schemas.microsoft.com/office/drawing/2014/main" id="{EB052462-45E0-4603-838A-5E3ED790D129}"/>
+                <a16:creationId xmlns:a16="http://schemas.microsoft.com/office/drawing/2014/main" id="{F63101FB-E027-431D-9C1D-95DF136872D7}"/>
               </a:ext>
             </a:extLst>
           </p:cNvPr>
@@ -22945,7 +22945,7 @@
           <p:cNvPr id="5" name="">
             <a:extLst xmlns:a="http://schemas.openxmlformats.org/drawingml/2006/main">
               <a:ext uri="{FF2B5EF4-FFF2-40B4-BE49-F238E27FC236}">
-                <a16:creationId xmlns:a16="http://schemas.microsoft.com/office/drawing/2014/main" id="{00502BF4-B2F5-4F84-8E8C-F1B4089C6AF2}"/>
+                <a16:creationId xmlns:a16="http://schemas.microsoft.com/office/drawing/2014/main" id="{1800D08D-3A33-4B0C-8E29-DAE83D0328B3}"/>
               </a:ext>
             </a:extLst>
           </p:cNvPr>
@@ -23102,7 +23102,7 @@
           <p:cNvPr id="6" name="">
             <a:extLst xmlns:a="http://schemas.openxmlformats.org/drawingml/2006/main">
               <a:ext uri="{FF2B5EF4-FFF2-40B4-BE49-F238E27FC236}">
-                <a16:creationId xmlns:a16="http://schemas.microsoft.com/office/drawing/2014/main" id="{A10714E0-D12A-4507-9219-FD6F9835693B}"/>
+                <a16:creationId xmlns:a16="http://schemas.microsoft.com/office/drawing/2014/main" id="{00E14FB2-91FF-49D6-A5A1-456B9CC2F37A}"/>
               </a:ext>
             </a:extLst>
           </p:cNvPr>
@@ -23257,7 +23257,7 @@
     </p:spTree>
     <p:extLst>
       <p:ext uri="{BB962C8B-B14F-4D97-AF65-F5344CB8AC3E}">
-        <p14:creationId xmlns:p14="http://schemas.microsoft.com/office/powerpoint/2010/main" val="1600047673"/>
+        <p14:creationId xmlns:p14="http://schemas.microsoft.com/office/powerpoint/2010/main" val="1166320575"/>
       </p:ext>
     </p:extLst>
   </p:cSld>
@@ -23288,7 +23288,7 @@
           <p:cNvPr id="7" name="">
             <a:extLst xmlns:a="http://schemas.openxmlformats.org/drawingml/2006/main">
               <a:ext uri="{FF2B5EF4-FFF2-40B4-BE49-F238E27FC236}">
-                <a16:creationId xmlns:a16="http://schemas.microsoft.com/office/drawing/2014/main" id="{D7D5B226-8817-4CDD-9D49-B2242F91A1D4}"/>
+                <a16:creationId xmlns:a16="http://schemas.microsoft.com/office/drawing/2014/main" id="{1373D045-DAAF-4C94-90DC-91234C46ECF4}"/>
               </a:ext>
             </a:extLst>
           </p:cNvPr>
@@ -23319,7 +23319,7 @@
           <p:cNvPr id="2" name="">
             <a:extLst xmlns:a="http://schemas.openxmlformats.org/drawingml/2006/main">
               <a:ext uri="{FF2B5EF4-FFF2-40B4-BE49-F238E27FC236}">
-                <a16:creationId xmlns:a16="http://schemas.microsoft.com/office/drawing/2014/main" id="{B3ED1E3E-C120-4FDB-9082-32E6C81EC49A}"/>
+                <a16:creationId xmlns:a16="http://schemas.microsoft.com/office/drawing/2014/main" id="{994AD22B-9FF6-43C7-8986-0C6DC3B6D436}"/>
               </a:ext>
             </a:extLst>
           </p:cNvPr>
@@ -23350,7 +23350,7 @@
           <p:cNvPr id="3" name="">
             <a:extLst xmlns:a="http://schemas.openxmlformats.org/drawingml/2006/main">
               <a:ext uri="{FF2B5EF4-FFF2-40B4-BE49-F238E27FC236}">
-                <a16:creationId xmlns:a16="http://schemas.microsoft.com/office/drawing/2014/main" id="{C5417D90-E397-470A-B28B-3AB5C126F35D}"/>
+                <a16:creationId xmlns:a16="http://schemas.microsoft.com/office/drawing/2014/main" id="{23759E33-69D9-4355-81A2-BFA6345EEFBE}"/>
               </a:ext>
             </a:extLst>
           </p:cNvPr>
@@ -23530,7 +23530,7 @@
           <p:cNvPr id="4" name="">
             <a:extLst xmlns:a="http://schemas.openxmlformats.org/drawingml/2006/main">
               <a:ext uri="{FF2B5EF4-FFF2-40B4-BE49-F238E27FC236}">
-                <a16:creationId xmlns:a16="http://schemas.microsoft.com/office/drawing/2014/main" id="{B758A6BD-BC10-4F13-9663-E21B1B091C53}"/>
+                <a16:creationId xmlns:a16="http://schemas.microsoft.com/office/drawing/2014/main" id="{01E5794E-8FA2-46B3-AC54-2F822A7B3AC4}"/>
               </a:ext>
             </a:extLst>
           </p:cNvPr>
@@ -23561,7 +23561,7 @@
           <p:cNvPr id="5" name="">
             <a:extLst xmlns:a="http://schemas.openxmlformats.org/drawingml/2006/main">
               <a:ext uri="{FF2B5EF4-FFF2-40B4-BE49-F238E27FC236}">
-                <a16:creationId xmlns:a16="http://schemas.microsoft.com/office/drawing/2014/main" id="{AD365BD9-E44C-4741-A484-A068997FB102}"/>
+                <a16:creationId xmlns:a16="http://schemas.microsoft.com/office/drawing/2014/main" id="{D388E6B4-D576-4F72-A884-A331BB204636}"/>
               </a:ext>
             </a:extLst>
           </p:cNvPr>
@@ -23718,7 +23718,7 @@
           <p:cNvPr id="6" name="">
             <a:extLst xmlns:a="http://schemas.openxmlformats.org/drawingml/2006/main">
               <a:ext uri="{FF2B5EF4-FFF2-40B4-BE49-F238E27FC236}">
-                <a16:creationId xmlns:a16="http://schemas.microsoft.com/office/drawing/2014/main" id="{6190BE56-BFC1-4B89-8FC0-FA2CC6B58E42}"/>
+                <a16:creationId xmlns:a16="http://schemas.microsoft.com/office/drawing/2014/main" id="{C9CC99C8-E243-4E2C-A720-E25A7E253066}"/>
               </a:ext>
             </a:extLst>
           </p:cNvPr>
@@ -23873,7 +23873,7 @@
     </p:spTree>
     <p:extLst>
       <p:ext uri="{BB962C8B-B14F-4D97-AF65-F5344CB8AC3E}">
-        <p14:creationId xmlns:p14="http://schemas.microsoft.com/office/powerpoint/2010/main" val="1570552451"/>
+        <p14:creationId xmlns:p14="http://schemas.microsoft.com/office/powerpoint/2010/main" val="1507548223"/>
       </p:ext>
     </p:extLst>
   </p:cSld>
@@ -23904,7 +23904,7 @@
           <p:cNvPr id="7" name="">
             <a:extLst xmlns:a="http://schemas.openxmlformats.org/drawingml/2006/main">
               <a:ext uri="{FF2B5EF4-FFF2-40B4-BE49-F238E27FC236}">
-                <a16:creationId xmlns:a16="http://schemas.microsoft.com/office/drawing/2014/main" id="{5B8329A8-151E-47F0-B846-A05F609800EB}"/>
+                <a16:creationId xmlns:a16="http://schemas.microsoft.com/office/drawing/2014/main" id="{EAE41A57-A172-42F2-9ECB-0066BD244888}"/>
               </a:ext>
             </a:extLst>
           </p:cNvPr>
@@ -23935,7 +23935,7 @@
           <p:cNvPr id="2" name="">
             <a:extLst xmlns:a="http://schemas.openxmlformats.org/drawingml/2006/main">
               <a:ext uri="{FF2B5EF4-FFF2-40B4-BE49-F238E27FC236}">
-                <a16:creationId xmlns:a16="http://schemas.microsoft.com/office/drawing/2014/main" id="{FF96A928-DFA9-43C1-BEC4-A398B81B06C9}"/>
+                <a16:creationId xmlns:a16="http://schemas.microsoft.com/office/drawing/2014/main" id="{7EF18C5A-D61F-4237-890F-F33C2FED8CCE}"/>
               </a:ext>
             </a:extLst>
           </p:cNvPr>
@@ -23966,7 +23966,7 @@
           <p:cNvPr id="3" name="">
             <a:extLst xmlns:a="http://schemas.openxmlformats.org/drawingml/2006/main">
               <a:ext uri="{FF2B5EF4-FFF2-40B4-BE49-F238E27FC236}">
-                <a16:creationId xmlns:a16="http://schemas.microsoft.com/office/drawing/2014/main" id="{E3CCDE0D-C7A9-4B0D-ADDC-318A50EE3DD3}"/>
+                <a16:creationId xmlns:a16="http://schemas.microsoft.com/office/drawing/2014/main" id="{19DF5E41-E960-4DCA-9629-A0FA8B64B553}"/>
               </a:ext>
             </a:extLst>
           </p:cNvPr>
@@ -24123,7 +24123,7 @@
           <p:cNvPr id="4" name="">
             <a:extLst xmlns:a="http://schemas.openxmlformats.org/drawingml/2006/main">
               <a:ext uri="{FF2B5EF4-FFF2-40B4-BE49-F238E27FC236}">
-                <a16:creationId xmlns:a16="http://schemas.microsoft.com/office/drawing/2014/main" id="{97E80286-37DD-4202-98F8-1A22772D2716}"/>
+                <a16:creationId xmlns:a16="http://schemas.microsoft.com/office/drawing/2014/main" id="{6D68337B-0264-468D-B894-0DE3335EFD6E}"/>
               </a:ext>
             </a:extLst>
           </p:cNvPr>
@@ -24154,7 +24154,7 @@
           <p:cNvPr id="5" name="">
             <a:extLst xmlns:a="http://schemas.openxmlformats.org/drawingml/2006/main">
               <a:ext uri="{FF2B5EF4-FFF2-40B4-BE49-F238E27FC236}">
-                <a16:creationId xmlns:a16="http://schemas.microsoft.com/office/drawing/2014/main" id="{509F6DEB-A539-4BAC-9A5B-F95E7D309FB9}"/>
+                <a16:creationId xmlns:a16="http://schemas.microsoft.com/office/drawing/2014/main" id="{39A837BF-F687-4761-9CF4-0C568471C3F9}"/>
               </a:ext>
             </a:extLst>
           </p:cNvPr>
@@ -24311,7 +24311,7 @@
           <p:cNvPr id="6" name="">
             <a:extLst xmlns:a="http://schemas.openxmlformats.org/drawingml/2006/main">
               <a:ext uri="{FF2B5EF4-FFF2-40B4-BE49-F238E27FC236}">
-                <a16:creationId xmlns:a16="http://schemas.microsoft.com/office/drawing/2014/main" id="{B0CA198C-F640-462A-AFA7-B667F05D6457}"/>
+                <a16:creationId xmlns:a16="http://schemas.microsoft.com/office/drawing/2014/main" id="{DBC16B41-37C5-4F7A-B4B1-05EAD926C1B7}"/>
               </a:ext>
             </a:extLst>
           </p:cNvPr>
@@ -24466,7 +24466,7 @@
     </p:spTree>
     <p:extLst>
       <p:ext uri="{BB962C8B-B14F-4D97-AF65-F5344CB8AC3E}">
-        <p14:creationId xmlns:p14="http://schemas.microsoft.com/office/powerpoint/2010/main" val="1403648674"/>
+        <p14:creationId xmlns:p14="http://schemas.microsoft.com/office/powerpoint/2010/main" val="665770359"/>
       </p:ext>
     </p:extLst>
   </p:cSld>
@@ -24497,7 +24497,7 @@
           <p:cNvPr id="7" name="">
             <a:extLst xmlns:a="http://schemas.openxmlformats.org/drawingml/2006/main">
               <a:ext uri="{FF2B5EF4-FFF2-40B4-BE49-F238E27FC236}">
-                <a16:creationId xmlns:a16="http://schemas.microsoft.com/office/drawing/2014/main" id="{DAE858AE-6FA2-40C6-8512-BA4329E84D11}"/>
+                <a16:creationId xmlns:a16="http://schemas.microsoft.com/office/drawing/2014/main" id="{EF86D74C-5005-45DB-97CE-D236C72E64AA}"/>
               </a:ext>
             </a:extLst>
           </p:cNvPr>
@@ -24528,7 +24528,7 @@
           <p:cNvPr id="2" name="">
             <a:extLst xmlns:a="http://schemas.openxmlformats.org/drawingml/2006/main">
               <a:ext uri="{FF2B5EF4-FFF2-40B4-BE49-F238E27FC236}">
-                <a16:creationId xmlns:a16="http://schemas.microsoft.com/office/drawing/2014/main" id="{201B66E1-D1C0-48C3-8123-9BA74EDF5AB3}"/>
+                <a16:creationId xmlns:a16="http://schemas.microsoft.com/office/drawing/2014/main" id="{2891F92A-A83D-4C0E-A776-3CEE015A647F}"/>
               </a:ext>
             </a:extLst>
           </p:cNvPr>
@@ -24559,7 +24559,7 @@
           <p:cNvPr id="3" name="">
             <a:extLst xmlns:a="http://schemas.openxmlformats.org/drawingml/2006/main">
               <a:ext uri="{FF2B5EF4-FFF2-40B4-BE49-F238E27FC236}">
-                <a16:creationId xmlns:a16="http://schemas.microsoft.com/office/drawing/2014/main" id="{6EDBEF11-5352-403E-B656-23F4324D8D84}"/>
+                <a16:creationId xmlns:a16="http://schemas.microsoft.com/office/drawing/2014/main" id="{5485D888-AC9C-440E-ACF9-3BE02A931B3E}"/>
               </a:ext>
             </a:extLst>
           </p:cNvPr>
@@ -24716,7 +24716,7 @@
           <p:cNvPr id="4" name="">
             <a:extLst xmlns:a="http://schemas.openxmlformats.org/drawingml/2006/main">
               <a:ext uri="{FF2B5EF4-FFF2-40B4-BE49-F238E27FC236}">
-                <a16:creationId xmlns:a16="http://schemas.microsoft.com/office/drawing/2014/main" id="{0BD0AE04-58A8-4D47-8D5A-2E7DC59568F3}"/>
+                <a16:creationId xmlns:a16="http://schemas.microsoft.com/office/drawing/2014/main" id="{83D3A792-8E0E-4ACA-80D5-244606D36E11}"/>
               </a:ext>
             </a:extLst>
           </p:cNvPr>
@@ -24747,7 +24747,7 @@
           <p:cNvPr id="5" name="">
             <a:extLst xmlns:a="http://schemas.openxmlformats.org/drawingml/2006/main">
               <a:ext uri="{FF2B5EF4-FFF2-40B4-BE49-F238E27FC236}">
-                <a16:creationId xmlns:a16="http://schemas.microsoft.com/office/drawing/2014/main" id="{0DE92737-EACE-4044-AE10-2C0858452ACA}"/>
+                <a16:creationId xmlns:a16="http://schemas.microsoft.com/office/drawing/2014/main" id="{81F3AD48-7DA4-4D59-91DD-462ED0183EA4}"/>
               </a:ext>
             </a:extLst>
           </p:cNvPr>
@@ -24904,7 +24904,7 @@
           <p:cNvPr id="6" name="">
             <a:extLst xmlns:a="http://schemas.openxmlformats.org/drawingml/2006/main">
               <a:ext uri="{FF2B5EF4-FFF2-40B4-BE49-F238E27FC236}">
-                <a16:creationId xmlns:a16="http://schemas.microsoft.com/office/drawing/2014/main" id="{F329F655-A7FE-43BE-85F5-B2C33055744B}"/>
+                <a16:creationId xmlns:a16="http://schemas.microsoft.com/office/drawing/2014/main" id="{AB08E65F-0512-4AA9-A6EC-86B09949BE4E}"/>
               </a:ext>
             </a:extLst>
           </p:cNvPr>
@@ -25059,7 +25059,7 @@
     </p:spTree>
     <p:extLst>
       <p:ext uri="{BB962C8B-B14F-4D97-AF65-F5344CB8AC3E}">
-        <p14:creationId xmlns:p14="http://schemas.microsoft.com/office/powerpoint/2010/main" val="1082973852"/>
+        <p14:creationId xmlns:p14="http://schemas.microsoft.com/office/powerpoint/2010/main" val="1653312057"/>
       </p:ext>
     </p:extLst>
   </p:cSld>
@@ -25090,7 +25090,7 @@
           <p:cNvPr id="11" name="">
             <a:extLst xmlns:a="http://schemas.openxmlformats.org/drawingml/2006/main">
               <a:ext uri="{FF2B5EF4-FFF2-40B4-BE49-F238E27FC236}">
-                <a16:creationId xmlns:a16="http://schemas.microsoft.com/office/drawing/2014/main" id="{E64F7648-95D9-45CC-8FC9-8793586BDC7B}"/>
+                <a16:creationId xmlns:a16="http://schemas.microsoft.com/office/drawing/2014/main" id="{2AC8F3F1-1D45-4A57-BEFD-2BE0A3784962}"/>
               </a:ext>
             </a:extLst>
           </p:cNvPr>
@@ -25121,7 +25121,7 @@
           <p:cNvPr id="2" name="">
             <a:extLst xmlns:a="http://schemas.openxmlformats.org/drawingml/2006/main">
               <a:ext uri="{FF2B5EF4-FFF2-40B4-BE49-F238E27FC236}">
-                <a16:creationId xmlns:a16="http://schemas.microsoft.com/office/drawing/2014/main" id="{FA5F991F-582B-4B38-8D60-7444D92E1954}"/>
+                <a16:creationId xmlns:a16="http://schemas.microsoft.com/office/drawing/2014/main" id="{05BCB502-2D4A-42CA-A080-F84909C77000}"/>
               </a:ext>
             </a:extLst>
           </p:cNvPr>
@@ -25152,7 +25152,7 @@
           <p:cNvPr id="3" name="">
             <a:extLst xmlns:a="http://schemas.openxmlformats.org/drawingml/2006/main">
               <a:ext uri="{FF2B5EF4-FFF2-40B4-BE49-F238E27FC236}">
-                <a16:creationId xmlns:a16="http://schemas.microsoft.com/office/drawing/2014/main" id="{A314D269-3DBB-4826-8968-AB8DAAB2F8BD}"/>
+                <a16:creationId xmlns:a16="http://schemas.microsoft.com/office/drawing/2014/main" id="{95AE9449-59DC-432D-BAE4-2F41A947FA63}"/>
               </a:ext>
             </a:extLst>
           </p:cNvPr>
@@ -25309,7 +25309,7 @@
           <p:cNvPr id="4" name="">
             <a:extLst xmlns:a="http://schemas.openxmlformats.org/drawingml/2006/main">
               <a:ext uri="{FF2B5EF4-FFF2-40B4-BE49-F238E27FC236}">
-                <a16:creationId xmlns:a16="http://schemas.microsoft.com/office/drawing/2014/main" id="{B0D9B815-5368-4549-9B27-9D0AB8E281F7}"/>
+                <a16:creationId xmlns:a16="http://schemas.microsoft.com/office/drawing/2014/main" id="{DE70112E-69CF-48ED-8527-5F95DF6166C2}"/>
               </a:ext>
             </a:extLst>
           </p:cNvPr>
@@ -25340,7 +25340,7 @@
           <p:cNvPr id="5" name="">
             <a:extLst xmlns:a="http://schemas.openxmlformats.org/drawingml/2006/main">
               <a:ext uri="{FF2B5EF4-FFF2-40B4-BE49-F238E27FC236}">
-                <a16:creationId xmlns:a16="http://schemas.microsoft.com/office/drawing/2014/main" id="{B41FCBD7-047F-4D9C-A5B7-D24A247FA479}"/>
+                <a16:creationId xmlns:a16="http://schemas.microsoft.com/office/drawing/2014/main" id="{348DD580-3601-4B62-8F36-384ABF4F7ECB}"/>
               </a:ext>
             </a:extLst>
           </p:cNvPr>
@@ -25520,7 +25520,7 @@
           <p:cNvPr id="6" name="">
             <a:extLst xmlns:a="http://schemas.openxmlformats.org/drawingml/2006/main">
               <a:ext uri="{FF2B5EF4-FFF2-40B4-BE49-F238E27FC236}">
-                <a16:creationId xmlns:a16="http://schemas.microsoft.com/office/drawing/2014/main" id="{333C5FB9-39B8-426A-8DC0-1A7F8AA8191C}"/>
+                <a16:creationId xmlns:a16="http://schemas.microsoft.com/office/drawing/2014/main" id="{5ED58ECB-B9A8-4D55-A703-076468D9B63D}"/>
               </a:ext>
             </a:extLst>
           </p:cNvPr>
@@ -25551,7 +25551,7 @@
           <p:cNvPr id="7" name="">
             <a:extLst xmlns:a="http://schemas.openxmlformats.org/drawingml/2006/main">
               <a:ext uri="{FF2B5EF4-FFF2-40B4-BE49-F238E27FC236}">
-                <a16:creationId xmlns:a16="http://schemas.microsoft.com/office/drawing/2014/main" id="{3E2FC08C-F70A-4267-9A56-044A08E4E8EB}"/>
+                <a16:creationId xmlns:a16="http://schemas.microsoft.com/office/drawing/2014/main" id="{2DCC864E-FB79-4760-8041-D6D6D93E89B6}"/>
               </a:ext>
             </a:extLst>
           </p:cNvPr>
@@ -25731,7 +25731,7 @@
           <p:cNvPr id="8" name="">
             <a:extLst xmlns:a="http://schemas.openxmlformats.org/drawingml/2006/main">
               <a:ext uri="{FF2B5EF4-FFF2-40B4-BE49-F238E27FC236}">
-                <a16:creationId xmlns:a16="http://schemas.microsoft.com/office/drawing/2014/main" id="{A66F5B31-8577-4DB4-9826-A45C3AE31663}"/>
+                <a16:creationId xmlns:a16="http://schemas.microsoft.com/office/drawing/2014/main" id="{7343D5EB-448E-449D-9298-E8141B18805D}"/>
               </a:ext>
             </a:extLst>
           </p:cNvPr>
@@ -25762,7 +25762,7 @@
           <p:cNvPr id="9" name="">
             <a:extLst xmlns:a="http://schemas.openxmlformats.org/drawingml/2006/main">
               <a:ext uri="{FF2B5EF4-FFF2-40B4-BE49-F238E27FC236}">
-                <a16:creationId xmlns:a16="http://schemas.microsoft.com/office/drawing/2014/main" id="{12998F2C-8CBA-43FF-B385-8CA769FBEB87}"/>
+                <a16:creationId xmlns:a16="http://schemas.microsoft.com/office/drawing/2014/main" id="{48A8B508-2C40-4BE3-BBDB-2F8BA98B2562}"/>
               </a:ext>
             </a:extLst>
           </p:cNvPr>
@@ -25942,7 +25942,7 @@
           <p:cNvPr id="10" name="">
             <a:extLst xmlns:a="http://schemas.openxmlformats.org/drawingml/2006/main">
               <a:ext uri="{FF2B5EF4-FFF2-40B4-BE49-F238E27FC236}">
-                <a16:creationId xmlns:a16="http://schemas.microsoft.com/office/drawing/2014/main" id="{F784733A-CA78-45D8-834A-FD99FEB342FB}"/>
+                <a16:creationId xmlns:a16="http://schemas.microsoft.com/office/drawing/2014/main" id="{53283F04-0AF0-44E2-9425-0912B1DB3441}"/>
               </a:ext>
             </a:extLst>
           </p:cNvPr>
@@ -26097,7 +26097,7 @@
     </p:spTree>
     <p:extLst>
       <p:ext uri="{BB962C8B-B14F-4D97-AF65-F5344CB8AC3E}">
-        <p14:creationId xmlns:p14="http://schemas.microsoft.com/office/powerpoint/2010/main" val="1746512885"/>
+        <p14:creationId xmlns:p14="http://schemas.microsoft.com/office/powerpoint/2010/main" val="2108303728"/>
       </p:ext>
     </p:extLst>
   </p:cSld>
@@ -26128,7 +26128,7 @@
           <p:cNvPr id="9" name="">
             <a:extLst xmlns:a="http://schemas.openxmlformats.org/drawingml/2006/main">
               <a:ext uri="{FF2B5EF4-FFF2-40B4-BE49-F238E27FC236}">
-                <a16:creationId xmlns:a16="http://schemas.microsoft.com/office/drawing/2014/main" id="{5AA24313-5D94-4FB9-A4A3-41618DBBF05A}"/>
+                <a16:creationId xmlns:a16="http://schemas.microsoft.com/office/drawing/2014/main" id="{4D5B2541-8045-4FB1-8E47-498CA3FC4BC2}"/>
               </a:ext>
             </a:extLst>
           </p:cNvPr>
@@ -26159,7 +26159,7 @@
           <p:cNvPr id="2" name="">
             <a:extLst xmlns:a="http://schemas.openxmlformats.org/drawingml/2006/main">
               <a:ext uri="{FF2B5EF4-FFF2-40B4-BE49-F238E27FC236}">
-                <a16:creationId xmlns:a16="http://schemas.microsoft.com/office/drawing/2014/main" id="{39B5463C-F6E5-4015-9721-449BF90EFE66}"/>
+                <a16:creationId xmlns:a16="http://schemas.microsoft.com/office/drawing/2014/main" id="{B52A4EC8-855A-452E-97B0-C04D8F90DE7A}"/>
               </a:ext>
             </a:extLst>
           </p:cNvPr>
@@ -26190,7 +26190,7 @@
           <p:cNvPr id="3" name="">
             <a:extLst xmlns:a="http://schemas.openxmlformats.org/drawingml/2006/main">
               <a:ext uri="{FF2B5EF4-FFF2-40B4-BE49-F238E27FC236}">
-                <a16:creationId xmlns:a16="http://schemas.microsoft.com/office/drawing/2014/main" id="{1776185D-C80C-4165-919D-901B1822B374}"/>
+                <a16:creationId xmlns:a16="http://schemas.microsoft.com/office/drawing/2014/main" id="{88CB83CB-2533-4ECC-A691-9DFE8D7E543E}"/>
               </a:ext>
             </a:extLst>
           </p:cNvPr>
@@ -26370,7 +26370,7 @@
           <p:cNvPr id="4" name="">
             <a:extLst xmlns:a="http://schemas.openxmlformats.org/drawingml/2006/main">
               <a:ext uri="{FF2B5EF4-FFF2-40B4-BE49-F238E27FC236}">
-                <a16:creationId xmlns:a16="http://schemas.microsoft.com/office/drawing/2014/main" id="{0FF62E12-8098-4A24-B80E-F111F101FE53}"/>
+                <a16:creationId xmlns:a16="http://schemas.microsoft.com/office/drawing/2014/main" id="{8A8C889C-E769-4558-A42D-F1E5F6F3518C}"/>
               </a:ext>
             </a:extLst>
           </p:cNvPr>
@@ -26527,7 +26527,7 @@
           <p:cNvPr id="5" name="">
             <a:extLst xmlns:a="http://schemas.openxmlformats.org/drawingml/2006/main">
               <a:ext uri="{FF2B5EF4-FFF2-40B4-BE49-F238E27FC236}">
-                <a16:creationId xmlns:a16="http://schemas.microsoft.com/office/drawing/2014/main" id="{116EC40A-C2B7-4709-A612-E3D0F647E9CD}"/>
+                <a16:creationId xmlns:a16="http://schemas.microsoft.com/office/drawing/2014/main" id="{445BCF14-929B-4657-849E-9E124B3601AA}"/>
               </a:ext>
             </a:extLst>
           </p:cNvPr>
@@ -26537,7 +26537,7 @@
           <p:nvPr/>
         </p:nvPicPr>
         <p:blipFill>
-          <a:blip xmlns:r="http://schemas.openxmlformats.org/officeDocument/2006/relationships" xmlns:a="http://schemas.openxmlformats.org/drawingml/2006/main" r:embed="R061dd7e13f3246ec"/>
+          <a:blip xmlns:r="http://schemas.openxmlformats.org/officeDocument/2006/relationships" xmlns:a="http://schemas.openxmlformats.org/drawingml/2006/main" r:embed="R747f3c95ea6c46d6"/>
           <a:stretch xmlns:a="http://schemas.openxmlformats.org/drawingml/2006/main"/>
         </p:blipFill>
         <p:spPr>
@@ -26555,7 +26555,7 @@
           <p:cNvPr id="6" name="">
             <a:extLst xmlns:a="http://schemas.openxmlformats.org/drawingml/2006/main">
               <a:ext uri="{FF2B5EF4-FFF2-40B4-BE49-F238E27FC236}">
-                <a16:creationId xmlns:a16="http://schemas.microsoft.com/office/drawing/2014/main" id="{840E592B-9490-4883-B968-5C974796A1E3}"/>
+                <a16:creationId xmlns:a16="http://schemas.microsoft.com/office/drawing/2014/main" id="{22101338-EC0A-4FDC-8018-84312E7B9F20}"/>
               </a:ext>
             </a:extLst>
           </p:cNvPr>
@@ -26565,7 +26565,7 @@
           <p:nvPr/>
         </p:nvPicPr>
         <p:blipFill>
-          <a:blip xmlns:r="http://schemas.openxmlformats.org/officeDocument/2006/relationships" xmlns:a="http://schemas.openxmlformats.org/drawingml/2006/main" r:embed="Rb56e315b97e84e17"/>
+          <a:blip xmlns:r="http://schemas.openxmlformats.org/officeDocument/2006/relationships" xmlns:a="http://schemas.openxmlformats.org/drawingml/2006/main" r:embed="R3f3a012475f643c2"/>
           <a:stretch xmlns:a="http://schemas.openxmlformats.org/drawingml/2006/main"/>
         </p:blipFill>
         <p:spPr>
@@ -26583,7 +26583,7 @@
           <p:cNvPr id="7" name="">
             <a:extLst xmlns:a="http://schemas.openxmlformats.org/drawingml/2006/main">
               <a:ext uri="{FF2B5EF4-FFF2-40B4-BE49-F238E27FC236}">
-                <a16:creationId xmlns:a16="http://schemas.microsoft.com/office/drawing/2014/main" id="{42BD525A-6B1C-4F58-AECE-67620137E62C}"/>
+                <a16:creationId xmlns:a16="http://schemas.microsoft.com/office/drawing/2014/main" id="{B8DD6C0B-7C35-4346-8AC4-C325B1639F8B}"/>
               </a:ext>
             </a:extLst>
           </p:cNvPr>
@@ -26593,7 +26593,7 @@
           <p:nvPr/>
         </p:nvPicPr>
         <p:blipFill>
-          <a:blip xmlns:r="http://schemas.openxmlformats.org/officeDocument/2006/relationships" xmlns:a="http://schemas.openxmlformats.org/drawingml/2006/main" r:embed="R70e60a66e8024aa0"/>
+          <a:blip xmlns:r="http://schemas.openxmlformats.org/officeDocument/2006/relationships" xmlns:a="http://schemas.openxmlformats.org/drawingml/2006/main" r:embed="R430ce7785e154b47"/>
           <a:stretch xmlns:a="http://schemas.openxmlformats.org/drawingml/2006/main"/>
         </p:blipFill>
         <p:spPr>
@@ -26611,7 +26611,7 @@
           <p:cNvPr id="8" name="">
             <a:extLst xmlns:a="http://schemas.openxmlformats.org/drawingml/2006/main">
               <a:ext uri="{FF2B5EF4-FFF2-40B4-BE49-F238E27FC236}">
-                <a16:creationId xmlns:a16="http://schemas.microsoft.com/office/drawing/2014/main" id="{A98D4018-6287-41B3-973C-318760C247FB}"/>
+                <a16:creationId xmlns:a16="http://schemas.microsoft.com/office/drawing/2014/main" id="{E352D22D-A057-4E1B-9910-9BF023C0BD90}"/>
               </a:ext>
             </a:extLst>
           </p:cNvPr>
@@ -26766,7 +26766,7 @@
     </p:spTree>
     <p:extLst>
       <p:ext uri="{BB962C8B-B14F-4D97-AF65-F5344CB8AC3E}">
-        <p14:creationId xmlns:p14="http://schemas.microsoft.com/office/powerpoint/2010/main" val="48768340"/>
+        <p14:creationId xmlns:p14="http://schemas.microsoft.com/office/powerpoint/2010/main" val="1148940470"/>
       </p:ext>
     </p:extLst>
   </p:cSld>
@@ -26797,7 +26797,7 @@
           <p:cNvPr id="7" name="">
             <a:extLst xmlns:a="http://schemas.openxmlformats.org/drawingml/2006/main">
               <a:ext uri="{FF2B5EF4-FFF2-40B4-BE49-F238E27FC236}">
-                <a16:creationId xmlns:a16="http://schemas.microsoft.com/office/drawing/2014/main" id="{1EB72886-11CD-4D69-8F02-627DB5F06DF8}"/>
+                <a16:creationId xmlns:a16="http://schemas.microsoft.com/office/drawing/2014/main" id="{56131627-8B1B-49BB-AB6C-C7D6D775F62E}"/>
               </a:ext>
             </a:extLst>
           </p:cNvPr>
@@ -26828,7 +26828,7 @@
           <p:cNvPr id="2" name="">
             <a:extLst xmlns:a="http://schemas.openxmlformats.org/drawingml/2006/main">
               <a:ext uri="{FF2B5EF4-FFF2-40B4-BE49-F238E27FC236}">
-                <a16:creationId xmlns:a16="http://schemas.microsoft.com/office/drawing/2014/main" id="{FA9EEFD5-13CB-4696-A804-7F3C5807B08D}"/>
+                <a16:creationId xmlns:a16="http://schemas.microsoft.com/office/drawing/2014/main" id="{C74DDD2A-1599-4F1D-A7C6-6996E0625463}"/>
               </a:ext>
             </a:extLst>
           </p:cNvPr>
@@ -26859,7 +26859,7 @@
           <p:cNvPr id="3" name="">
             <a:extLst xmlns:a="http://schemas.openxmlformats.org/drawingml/2006/main">
               <a:ext uri="{FF2B5EF4-FFF2-40B4-BE49-F238E27FC236}">
-                <a16:creationId xmlns:a16="http://schemas.microsoft.com/office/drawing/2014/main" id="{741A3E70-0560-4016-A4C5-3476F4FC7A82}"/>
+                <a16:creationId xmlns:a16="http://schemas.microsoft.com/office/drawing/2014/main" id="{BBA9B054-63C9-4E47-97A4-025920B14CC5}"/>
               </a:ext>
             </a:extLst>
           </p:cNvPr>
@@ -27016,7 +27016,7 @@
           <p:cNvPr id="4" name="">
             <a:extLst xmlns:a="http://schemas.openxmlformats.org/drawingml/2006/main">
               <a:ext uri="{FF2B5EF4-FFF2-40B4-BE49-F238E27FC236}">
-                <a16:creationId xmlns:a16="http://schemas.microsoft.com/office/drawing/2014/main" id="{69A0F76E-AEC1-466E-B909-D1EF74AB1B38}"/>
+                <a16:creationId xmlns:a16="http://schemas.microsoft.com/office/drawing/2014/main" id="{F13C3E9D-CB7F-4206-BF59-F817937B5CBF}"/>
               </a:ext>
             </a:extLst>
           </p:cNvPr>
@@ -27047,7 +27047,7 @@
           <p:cNvPr id="5" name="">
             <a:extLst xmlns:a="http://schemas.openxmlformats.org/drawingml/2006/main">
               <a:ext uri="{FF2B5EF4-FFF2-40B4-BE49-F238E27FC236}">
-                <a16:creationId xmlns:a16="http://schemas.microsoft.com/office/drawing/2014/main" id="{B0472E11-6587-44B0-9624-469C3CC0453B}"/>
+                <a16:creationId xmlns:a16="http://schemas.microsoft.com/office/drawing/2014/main" id="{759F3AD1-09EF-4301-A827-3F93C93225E7}"/>
               </a:ext>
             </a:extLst>
           </p:cNvPr>
@@ -27204,7 +27204,7 @@
           <p:cNvPr id="6" name="">
             <a:extLst xmlns:a="http://schemas.openxmlformats.org/drawingml/2006/main">
               <a:ext uri="{FF2B5EF4-FFF2-40B4-BE49-F238E27FC236}">
-                <a16:creationId xmlns:a16="http://schemas.microsoft.com/office/drawing/2014/main" id="{1DA63F69-7DD0-44F1-8CFD-DD4E85BC741F}"/>
+                <a16:creationId xmlns:a16="http://schemas.microsoft.com/office/drawing/2014/main" id="{80455FDF-2B66-4113-B327-4F72C27CEE5A}"/>
               </a:ext>
             </a:extLst>
           </p:cNvPr>
@@ -27359,7 +27359,7 @@
     </p:spTree>
     <p:extLst>
       <p:ext uri="{BB962C8B-B14F-4D97-AF65-F5344CB8AC3E}">
-        <p14:creationId xmlns:p14="http://schemas.microsoft.com/office/powerpoint/2010/main" val="475491309"/>
+        <p14:creationId xmlns:p14="http://schemas.microsoft.com/office/powerpoint/2010/main" val="220225641"/>
       </p:ext>
     </p:extLst>
   </p:cSld>
@@ -27390,7 +27390,7 @@
           <p:cNvPr id="7" name="">
             <a:extLst xmlns:a="http://schemas.openxmlformats.org/drawingml/2006/main">
               <a:ext uri="{FF2B5EF4-FFF2-40B4-BE49-F238E27FC236}">
-                <a16:creationId xmlns:a16="http://schemas.microsoft.com/office/drawing/2014/main" id="{C0E316DB-ADCE-4D14-893F-6E0138CE6BC5}"/>
+                <a16:creationId xmlns:a16="http://schemas.microsoft.com/office/drawing/2014/main" id="{66AF2EB4-55F0-4DDB-B96C-4E0C53F0E05B}"/>
               </a:ext>
             </a:extLst>
           </p:cNvPr>
@@ -27421,7 +27421,7 @@
           <p:cNvPr id="2" name="">
             <a:extLst xmlns:a="http://schemas.openxmlformats.org/drawingml/2006/main">
               <a:ext uri="{FF2B5EF4-FFF2-40B4-BE49-F238E27FC236}">
-                <a16:creationId xmlns:a16="http://schemas.microsoft.com/office/drawing/2014/main" id="{EAD39865-7542-41F8-9B3A-13345A765A46}"/>
+                <a16:creationId xmlns:a16="http://schemas.microsoft.com/office/drawing/2014/main" id="{BD2F1C12-C54E-43D4-B37C-ADF239A6D1A1}"/>
               </a:ext>
             </a:extLst>
           </p:cNvPr>
@@ -27452,7 +27452,7 @@
           <p:cNvPr id="3" name="">
             <a:extLst xmlns:a="http://schemas.openxmlformats.org/drawingml/2006/main">
               <a:ext uri="{FF2B5EF4-FFF2-40B4-BE49-F238E27FC236}">
-                <a16:creationId xmlns:a16="http://schemas.microsoft.com/office/drawing/2014/main" id="{9FA57FAF-44BB-4B2E-B80D-F3739FF78A2E}"/>
+                <a16:creationId xmlns:a16="http://schemas.microsoft.com/office/drawing/2014/main" id="{4BAC0977-927C-45CD-8E3B-CDFD1E99EF44}"/>
               </a:ext>
             </a:extLst>
           </p:cNvPr>
@@ -27609,7 +27609,7 @@
           <p:cNvPr id="4" name="">
             <a:extLst xmlns:a="http://schemas.openxmlformats.org/drawingml/2006/main">
               <a:ext uri="{FF2B5EF4-FFF2-40B4-BE49-F238E27FC236}">
-                <a16:creationId xmlns:a16="http://schemas.microsoft.com/office/drawing/2014/main" id="{5A4C651C-4512-4D4E-A362-1BA2DE6DB871}"/>
+                <a16:creationId xmlns:a16="http://schemas.microsoft.com/office/drawing/2014/main" id="{EB92E637-01FF-4653-9809-6380C2A0C5E3}"/>
               </a:ext>
             </a:extLst>
           </p:cNvPr>
@@ -27640,7 +27640,7 @@
           <p:cNvPr id="5" name="">
             <a:extLst xmlns:a="http://schemas.openxmlformats.org/drawingml/2006/main">
               <a:ext uri="{FF2B5EF4-FFF2-40B4-BE49-F238E27FC236}">
-                <a16:creationId xmlns:a16="http://schemas.microsoft.com/office/drawing/2014/main" id="{0968D7F1-021D-4E20-B44B-44245D1E2591}"/>
+                <a16:creationId xmlns:a16="http://schemas.microsoft.com/office/drawing/2014/main" id="{607F4F4D-5BDC-40B6-9258-BEAA2850BD35}"/>
               </a:ext>
             </a:extLst>
           </p:cNvPr>
@@ -27797,7 +27797,7 @@
           <p:cNvPr id="6" name="">
             <a:extLst xmlns:a="http://schemas.openxmlformats.org/drawingml/2006/main">
               <a:ext uri="{FF2B5EF4-FFF2-40B4-BE49-F238E27FC236}">
-                <a16:creationId xmlns:a16="http://schemas.microsoft.com/office/drawing/2014/main" id="{069012A7-E7CF-4212-AF96-C46593ED9208}"/>
+                <a16:creationId xmlns:a16="http://schemas.microsoft.com/office/drawing/2014/main" id="{C3D35926-23BA-4B56-9056-2CA650503089}"/>
               </a:ext>
             </a:extLst>
           </p:cNvPr>
@@ -27952,7 +27952,7 @@
     </p:spTree>
     <p:extLst>
       <p:ext uri="{BB962C8B-B14F-4D97-AF65-F5344CB8AC3E}">
-        <p14:creationId xmlns:p14="http://schemas.microsoft.com/office/powerpoint/2010/main" val="1557987460"/>
+        <p14:creationId xmlns:p14="http://schemas.microsoft.com/office/powerpoint/2010/main" val="1421016379"/>
       </p:ext>
     </p:extLst>
   </p:cSld>
@@ -27983,7 +27983,7 @@
           <p:cNvPr id="8" name="">
             <a:extLst xmlns:a="http://schemas.openxmlformats.org/drawingml/2006/main">
               <a:ext uri="{FF2B5EF4-FFF2-40B4-BE49-F238E27FC236}">
-                <a16:creationId xmlns:a16="http://schemas.microsoft.com/office/drawing/2014/main" id="{B8AB0430-D917-48C6-8B75-D4874CF80309}"/>
+                <a16:creationId xmlns:a16="http://schemas.microsoft.com/office/drawing/2014/main" id="{DADD0013-9AFE-457A-A6DE-48BDB79BEEE6}"/>
               </a:ext>
             </a:extLst>
           </p:cNvPr>
@@ -28014,7 +28014,7 @@
           <p:cNvPr id="2" name="">
             <a:extLst xmlns:a="http://schemas.openxmlformats.org/drawingml/2006/main">
               <a:ext uri="{FF2B5EF4-FFF2-40B4-BE49-F238E27FC236}">
-                <a16:creationId xmlns:a16="http://schemas.microsoft.com/office/drawing/2014/main" id="{60BE3241-EB51-4869-A6B7-BF04FFD6C6B1}"/>
+                <a16:creationId xmlns:a16="http://schemas.microsoft.com/office/drawing/2014/main" id="{A4341634-8236-4CCE-8D96-5E73184346FF}"/>
               </a:ext>
             </a:extLst>
           </p:cNvPr>
@@ -28045,7 +28045,7 @@
           <p:cNvPr id="3" name="">
             <a:extLst xmlns:a="http://schemas.openxmlformats.org/drawingml/2006/main">
               <a:ext uri="{FF2B5EF4-FFF2-40B4-BE49-F238E27FC236}">
-                <a16:creationId xmlns:a16="http://schemas.microsoft.com/office/drawing/2014/main" id="{0D8F948E-102F-4C90-9030-546206788B20}"/>
+                <a16:creationId xmlns:a16="http://schemas.microsoft.com/office/drawing/2014/main" id="{BEF12D88-6670-4665-AC2D-EC1B1989C453}"/>
               </a:ext>
             </a:extLst>
           </p:cNvPr>
@@ -28202,7 +28202,7 @@
           <p:cNvPr id="4" name="">
             <a:extLst xmlns:a="http://schemas.openxmlformats.org/drawingml/2006/main">
               <a:ext uri="{FF2B5EF4-FFF2-40B4-BE49-F238E27FC236}">
-                <a16:creationId xmlns:a16="http://schemas.microsoft.com/office/drawing/2014/main" id="{0D25B495-0CF7-4BB1-AE3F-E1333FC23588}"/>
+                <a16:creationId xmlns:a16="http://schemas.microsoft.com/office/drawing/2014/main" id="{2F1A4492-F7D9-44E7-987B-627AD928A3AA}"/>
               </a:ext>
             </a:extLst>
           </p:cNvPr>
@@ -28382,7 +28382,7 @@
           <p:cNvPr id="5" name="">
             <a:extLst xmlns:a="http://schemas.openxmlformats.org/drawingml/2006/main">
               <a:ext uri="{FF2B5EF4-FFF2-40B4-BE49-F238E27FC236}">
-                <a16:creationId xmlns:a16="http://schemas.microsoft.com/office/drawing/2014/main" id="{CDDA5029-68AB-45FF-A362-BCEF37526746}"/>
+                <a16:creationId xmlns:a16="http://schemas.microsoft.com/office/drawing/2014/main" id="{5B70AA6E-6753-4FC3-8194-E79A6C926214}"/>
               </a:ext>
             </a:extLst>
           </p:cNvPr>
@@ -28539,7 +28539,7 @@
           <p:cNvPr id="6" name="">
             <a:extLst xmlns:a="http://schemas.openxmlformats.org/drawingml/2006/main">
               <a:ext uri="{FF2B5EF4-FFF2-40B4-BE49-F238E27FC236}">
-                <a16:creationId xmlns:a16="http://schemas.microsoft.com/office/drawing/2014/main" id="{CBF362BB-38A1-48EA-8E33-A4C8C821CF5A}"/>
+                <a16:creationId xmlns:a16="http://schemas.microsoft.com/office/drawing/2014/main" id="{93BC0FF3-46E1-4768-9A6D-B4C187DC25EF}"/>
               </a:ext>
             </a:extLst>
           </p:cNvPr>
@@ -28549,7 +28549,7 @@
           <p:nvPr/>
         </p:nvPicPr>
         <p:blipFill>
-          <a:blip xmlns:r="http://schemas.openxmlformats.org/officeDocument/2006/relationships" xmlns:a="http://schemas.openxmlformats.org/drawingml/2006/main" r:embed="R849d1960da934a70"/>
+          <a:blip xmlns:r="http://schemas.openxmlformats.org/officeDocument/2006/relationships" xmlns:a="http://schemas.openxmlformats.org/drawingml/2006/main" r:embed="R3e181e6c979b48de"/>
           <a:srcRect xmlns:a="http://schemas.openxmlformats.org/drawingml/2006/main" l="0" t="1945" r="0" b="1945"/>
           <a:stretch xmlns:a="http://schemas.openxmlformats.org/drawingml/2006/main">
             <a:fillRect l="0" t="0" r="0" b="0"/>
@@ -28570,7 +28570,7 @@
           <p:cNvPr id="7" name="">
             <a:extLst xmlns:a="http://schemas.openxmlformats.org/drawingml/2006/main">
               <a:ext uri="{FF2B5EF4-FFF2-40B4-BE49-F238E27FC236}">
-                <a16:creationId xmlns:a16="http://schemas.microsoft.com/office/drawing/2014/main" id="{8A1D98F1-FA1C-4A24-8FA6-04CFED21636B}"/>
+                <a16:creationId xmlns:a16="http://schemas.microsoft.com/office/drawing/2014/main" id="{B7BF92E0-9B5F-494F-8100-8E43E1AD2D96}"/>
               </a:ext>
             </a:extLst>
           </p:cNvPr>
@@ -28725,7 +28725,7 @@
     </p:spTree>
     <p:extLst>
       <p:ext uri="{BB962C8B-B14F-4D97-AF65-F5344CB8AC3E}">
-        <p14:creationId xmlns:p14="http://schemas.microsoft.com/office/powerpoint/2010/main" val="1154637307"/>
+        <p14:creationId xmlns:p14="http://schemas.microsoft.com/office/powerpoint/2010/main" val="367902717"/>
       </p:ext>
     </p:extLst>
   </p:cSld>
@@ -28756,7 +28756,7 @@
           <p:cNvPr id="7" name="">
             <a:extLst xmlns:a="http://schemas.openxmlformats.org/drawingml/2006/main">
               <a:ext uri="{FF2B5EF4-FFF2-40B4-BE49-F238E27FC236}">
-                <a16:creationId xmlns:a16="http://schemas.microsoft.com/office/drawing/2014/main" id="{3BC15CEA-711A-47E9-A4B6-B73DAA0ABA95}"/>
+                <a16:creationId xmlns:a16="http://schemas.microsoft.com/office/drawing/2014/main" id="{34B73351-B537-406E-B353-60594A036C2F}"/>
               </a:ext>
             </a:extLst>
           </p:cNvPr>
@@ -28787,7 +28787,7 @@
           <p:cNvPr id="2" name="">
             <a:extLst xmlns:a="http://schemas.openxmlformats.org/drawingml/2006/main">
               <a:ext uri="{FF2B5EF4-FFF2-40B4-BE49-F238E27FC236}">
-                <a16:creationId xmlns:a16="http://schemas.microsoft.com/office/drawing/2014/main" id="{E087C8B0-5613-40FA-93BC-AC168505D3FB}"/>
+                <a16:creationId xmlns:a16="http://schemas.microsoft.com/office/drawing/2014/main" id="{50A0D8F8-CA77-484C-8C5D-06B6BBE3DA6A}"/>
               </a:ext>
             </a:extLst>
           </p:cNvPr>
@@ -28818,7 +28818,7 @@
           <p:cNvPr id="3" name="">
             <a:extLst xmlns:a="http://schemas.openxmlformats.org/drawingml/2006/main">
               <a:ext uri="{FF2B5EF4-FFF2-40B4-BE49-F238E27FC236}">
-                <a16:creationId xmlns:a16="http://schemas.microsoft.com/office/drawing/2014/main" id="{57250C75-DBAD-4970-86CA-C4A7350D883E}"/>
+                <a16:creationId xmlns:a16="http://schemas.microsoft.com/office/drawing/2014/main" id="{CCA1C5A0-8538-400E-9AEA-4ADF48B65DD2}"/>
               </a:ext>
             </a:extLst>
           </p:cNvPr>
@@ -28975,7 +28975,7 @@
           <p:cNvPr id="4" name="">
             <a:extLst xmlns:a="http://schemas.openxmlformats.org/drawingml/2006/main">
               <a:ext uri="{FF2B5EF4-FFF2-40B4-BE49-F238E27FC236}">
-                <a16:creationId xmlns:a16="http://schemas.microsoft.com/office/drawing/2014/main" id="{4132AD7C-FCBD-415B-A20C-E6F78E3DE38F}"/>
+                <a16:creationId xmlns:a16="http://schemas.microsoft.com/office/drawing/2014/main" id="{7FAB5B1B-1779-4BC7-BE4C-D93FB1181C01}"/>
               </a:ext>
             </a:extLst>
           </p:cNvPr>
@@ -29006,7 +29006,7 @@
           <p:cNvPr id="5" name="">
             <a:extLst xmlns:a="http://schemas.openxmlformats.org/drawingml/2006/main">
               <a:ext uri="{FF2B5EF4-FFF2-40B4-BE49-F238E27FC236}">
-                <a16:creationId xmlns:a16="http://schemas.microsoft.com/office/drawing/2014/main" id="{27A32183-B75C-4A23-A0B4-F0329CC148CA}"/>
+                <a16:creationId xmlns:a16="http://schemas.microsoft.com/office/drawing/2014/main" id="{0D7EABAA-A11F-4BCC-8779-0FD07BCE57A0}"/>
               </a:ext>
             </a:extLst>
           </p:cNvPr>
@@ -29163,7 +29163,7 @@
           <p:cNvPr id="6" name="">
             <a:extLst xmlns:a="http://schemas.openxmlformats.org/drawingml/2006/main">
               <a:ext uri="{FF2B5EF4-FFF2-40B4-BE49-F238E27FC236}">
-                <a16:creationId xmlns:a16="http://schemas.microsoft.com/office/drawing/2014/main" id="{AA7721A6-0751-4346-BF78-15B23DA0B35E}"/>
+                <a16:creationId xmlns:a16="http://schemas.microsoft.com/office/drawing/2014/main" id="{C73652AC-FE70-4EC3-915C-D00C0A211CA4}"/>
               </a:ext>
             </a:extLst>
           </p:cNvPr>
@@ -29318,7 +29318,7 @@
     </p:spTree>
     <p:extLst>
       <p:ext uri="{BB962C8B-B14F-4D97-AF65-F5344CB8AC3E}">
-        <p14:creationId xmlns:p14="http://schemas.microsoft.com/office/powerpoint/2010/main" val="256095391"/>
+        <p14:creationId xmlns:p14="http://schemas.microsoft.com/office/powerpoint/2010/main" val="191422885"/>
       </p:ext>
     </p:extLst>
   </p:cSld>
@@ -29349,7 +29349,7 @@
           <p:cNvPr id="11" name="">
             <a:extLst xmlns:a="http://schemas.openxmlformats.org/drawingml/2006/main">
               <a:ext uri="{FF2B5EF4-FFF2-40B4-BE49-F238E27FC236}">
-                <a16:creationId xmlns:a16="http://schemas.microsoft.com/office/drawing/2014/main" id="{B931C9BE-8BF7-4047-A929-77C58621F341}"/>
+                <a16:creationId xmlns:a16="http://schemas.microsoft.com/office/drawing/2014/main" id="{70025A65-C5AC-477A-BE10-E1FD9F04647B}"/>
               </a:ext>
             </a:extLst>
           </p:cNvPr>
@@ -29380,7 +29380,7 @@
           <p:cNvPr id="2" name="">
             <a:extLst xmlns:a="http://schemas.openxmlformats.org/drawingml/2006/main">
               <a:ext uri="{FF2B5EF4-FFF2-40B4-BE49-F238E27FC236}">
-                <a16:creationId xmlns:a16="http://schemas.microsoft.com/office/drawing/2014/main" id="{4EE8615D-21D0-4E70-981E-EA9D489E7A11}"/>
+                <a16:creationId xmlns:a16="http://schemas.microsoft.com/office/drawing/2014/main" id="{7EFF0A4B-7155-4790-973F-B25D2B592C5D}"/>
               </a:ext>
             </a:extLst>
           </p:cNvPr>
@@ -29411,7 +29411,7 @@
           <p:cNvPr id="3" name="">
             <a:extLst xmlns:a="http://schemas.openxmlformats.org/drawingml/2006/main">
               <a:ext uri="{FF2B5EF4-FFF2-40B4-BE49-F238E27FC236}">
-                <a16:creationId xmlns:a16="http://schemas.microsoft.com/office/drawing/2014/main" id="{043B13DF-7904-40F9-A07C-46B8B83944CB}"/>
+                <a16:creationId xmlns:a16="http://schemas.microsoft.com/office/drawing/2014/main" id="{8A7476F1-518C-4FBE-AF87-B05E465F8DC3}"/>
               </a:ext>
             </a:extLst>
           </p:cNvPr>
@@ -29568,7 +29568,7 @@
           <p:cNvPr id="4" name="">
             <a:extLst xmlns:a="http://schemas.openxmlformats.org/drawingml/2006/main">
               <a:ext uri="{FF2B5EF4-FFF2-40B4-BE49-F238E27FC236}">
-                <a16:creationId xmlns:a16="http://schemas.microsoft.com/office/drawing/2014/main" id="{6C902319-1506-4473-845D-1F59E99F7C7C}"/>
+                <a16:creationId xmlns:a16="http://schemas.microsoft.com/office/drawing/2014/main" id="{B901A3AF-D501-4384-A510-CFE1A7CF0619}"/>
               </a:ext>
             </a:extLst>
           </p:cNvPr>
@@ -29599,7 +29599,7 @@
           <p:cNvPr id="5" name="">
             <a:extLst xmlns:a="http://schemas.openxmlformats.org/drawingml/2006/main">
               <a:ext uri="{FF2B5EF4-FFF2-40B4-BE49-F238E27FC236}">
-                <a16:creationId xmlns:a16="http://schemas.microsoft.com/office/drawing/2014/main" id="{D9CF38C1-4A0F-40DE-B1C8-CBC4BE8C1211}"/>
+                <a16:creationId xmlns:a16="http://schemas.microsoft.com/office/drawing/2014/main" id="{E069FDEC-DD45-4B04-864E-619B073CAC28}"/>
               </a:ext>
             </a:extLst>
           </p:cNvPr>
@@ -29756,7 +29756,7 @@
           <p:cNvPr id="6" name="">
             <a:extLst xmlns:a="http://schemas.openxmlformats.org/drawingml/2006/main">
               <a:ext uri="{FF2B5EF4-FFF2-40B4-BE49-F238E27FC236}">
-                <a16:creationId xmlns:a16="http://schemas.microsoft.com/office/drawing/2014/main" id="{4044E0D6-67F9-43F0-8A1F-60D7FFE51DBD}"/>
+                <a16:creationId xmlns:a16="http://schemas.microsoft.com/office/drawing/2014/main" id="{78DEFD4C-14EE-4C70-ACB2-D98500BDBBC3}"/>
               </a:ext>
             </a:extLst>
           </p:cNvPr>
@@ -29787,7 +29787,7 @@
           <p:cNvPr id="7" name="">
             <a:extLst xmlns:a="http://schemas.openxmlformats.org/drawingml/2006/main">
               <a:ext uri="{FF2B5EF4-FFF2-40B4-BE49-F238E27FC236}">
-                <a16:creationId xmlns:a16="http://schemas.microsoft.com/office/drawing/2014/main" id="{536D8EC1-10F6-4849-B296-8D8055CCF5CD}"/>
+                <a16:creationId xmlns:a16="http://schemas.microsoft.com/office/drawing/2014/main" id="{27B9C036-6307-4CCE-BCD1-564BFF9CC443}"/>
               </a:ext>
             </a:extLst>
           </p:cNvPr>
@@ -29944,7 +29944,7 @@
           <p:cNvPr id="8" name="">
             <a:extLst xmlns:a="http://schemas.openxmlformats.org/drawingml/2006/main">
               <a:ext uri="{FF2B5EF4-FFF2-40B4-BE49-F238E27FC236}">
-                <a16:creationId xmlns:a16="http://schemas.microsoft.com/office/drawing/2014/main" id="{8A509661-5A36-450D-B196-AEC4D507A5A7}"/>
+                <a16:creationId xmlns:a16="http://schemas.microsoft.com/office/drawing/2014/main" id="{49326940-857C-422F-BDA6-1C36B35FA115}"/>
               </a:ext>
             </a:extLst>
           </p:cNvPr>
@@ -29975,7 +29975,7 @@
           <p:cNvPr id="9" name="">
             <a:extLst xmlns:a="http://schemas.openxmlformats.org/drawingml/2006/main">
               <a:ext uri="{FF2B5EF4-FFF2-40B4-BE49-F238E27FC236}">
-                <a16:creationId xmlns:a16="http://schemas.microsoft.com/office/drawing/2014/main" id="{B4985F08-D5D2-4C4C-8318-613AFA4ED1B3}"/>
+                <a16:creationId xmlns:a16="http://schemas.microsoft.com/office/drawing/2014/main" id="{5DB11C59-AD7C-4288-B5BE-DEBE3760E343}"/>
               </a:ext>
             </a:extLst>
           </p:cNvPr>
@@ -30132,7 +30132,7 @@
           <p:cNvPr id="10" name="">
             <a:extLst xmlns:a="http://schemas.openxmlformats.org/drawingml/2006/main">
               <a:ext uri="{FF2B5EF4-FFF2-40B4-BE49-F238E27FC236}">
-                <a16:creationId xmlns:a16="http://schemas.microsoft.com/office/drawing/2014/main" id="{0A5BCE03-B433-4A71-BC69-B28BCDEDE42A}"/>
+                <a16:creationId xmlns:a16="http://schemas.microsoft.com/office/drawing/2014/main" id="{11D0A17D-9A16-4295-AA19-B156157CCE26}"/>
               </a:ext>
             </a:extLst>
           </p:cNvPr>
@@ -30287,7 +30287,7 @@
     </p:spTree>
     <p:extLst>
       <p:ext uri="{BB962C8B-B14F-4D97-AF65-F5344CB8AC3E}">
-        <p14:creationId xmlns:p14="http://schemas.microsoft.com/office/powerpoint/2010/main" val="1749753974"/>
+        <p14:creationId xmlns:p14="http://schemas.microsoft.com/office/powerpoint/2010/main" val="1897056860"/>
       </p:ext>
     </p:extLst>
   </p:cSld>
@@ -30318,7 +30318,7 @@
           <p:cNvPr id="7" name="">
             <a:extLst xmlns:a="http://schemas.openxmlformats.org/drawingml/2006/main">
               <a:ext uri="{FF2B5EF4-FFF2-40B4-BE49-F238E27FC236}">
-                <a16:creationId xmlns:a16="http://schemas.microsoft.com/office/drawing/2014/main" id="{6401E20F-EDC1-4A97-A9D1-CE483CACB255}"/>
+                <a16:creationId xmlns:a16="http://schemas.microsoft.com/office/drawing/2014/main" id="{BAD75E35-FA24-4952-A336-97D70C4BC2DB}"/>
               </a:ext>
             </a:extLst>
           </p:cNvPr>
@@ -30349,7 +30349,7 @@
           <p:cNvPr id="2" name="">
             <a:extLst xmlns:a="http://schemas.openxmlformats.org/drawingml/2006/main">
               <a:ext uri="{FF2B5EF4-FFF2-40B4-BE49-F238E27FC236}">
-                <a16:creationId xmlns:a16="http://schemas.microsoft.com/office/drawing/2014/main" id="{482E09F0-6E0F-47CD-A85A-DC270C69FB87}"/>
+                <a16:creationId xmlns:a16="http://schemas.microsoft.com/office/drawing/2014/main" id="{F3D3AD43-7D8C-459A-B152-9D9183DDDAC8}"/>
               </a:ext>
             </a:extLst>
           </p:cNvPr>
@@ -30380,7 +30380,7 @@
           <p:cNvPr id="3" name="">
             <a:extLst xmlns:a="http://schemas.openxmlformats.org/drawingml/2006/main">
               <a:ext uri="{FF2B5EF4-FFF2-40B4-BE49-F238E27FC236}">
-                <a16:creationId xmlns:a16="http://schemas.microsoft.com/office/drawing/2014/main" id="{13C2455C-CFCA-45DE-9D3C-0EAE6A0720F4}"/>
+                <a16:creationId xmlns:a16="http://schemas.microsoft.com/office/drawing/2014/main" id="{891E0FD2-A1D2-48E0-A39C-C1AFBDFAB4F9}"/>
               </a:ext>
             </a:extLst>
           </p:cNvPr>
@@ -30537,7 +30537,7 @@
           <p:cNvPr id="4" name="">
             <a:extLst xmlns:a="http://schemas.openxmlformats.org/drawingml/2006/main">
               <a:ext uri="{FF2B5EF4-FFF2-40B4-BE49-F238E27FC236}">
-                <a16:creationId xmlns:a16="http://schemas.microsoft.com/office/drawing/2014/main" id="{21E379E0-BCB9-4551-B737-D7A6DCC1D231}"/>
+                <a16:creationId xmlns:a16="http://schemas.microsoft.com/office/drawing/2014/main" id="{5F151895-C698-422D-AF25-10EBD5E5BF4C}"/>
               </a:ext>
             </a:extLst>
           </p:cNvPr>
@@ -30568,7 +30568,7 @@
           <p:cNvPr id="5" name="">
             <a:extLst xmlns:a="http://schemas.openxmlformats.org/drawingml/2006/main">
               <a:ext uri="{FF2B5EF4-FFF2-40B4-BE49-F238E27FC236}">
-                <a16:creationId xmlns:a16="http://schemas.microsoft.com/office/drawing/2014/main" id="{5B471F75-292C-4C62-82E3-6D61E8CFA544}"/>
+                <a16:creationId xmlns:a16="http://schemas.microsoft.com/office/drawing/2014/main" id="{0CFD5B16-F14D-4030-8228-E4EAAF9922EB}"/>
               </a:ext>
             </a:extLst>
           </p:cNvPr>
@@ -30725,7 +30725,7 @@
           <p:cNvPr id="6" name="">
             <a:extLst xmlns:a="http://schemas.openxmlformats.org/drawingml/2006/main">
               <a:ext uri="{FF2B5EF4-FFF2-40B4-BE49-F238E27FC236}">
-                <a16:creationId xmlns:a16="http://schemas.microsoft.com/office/drawing/2014/main" id="{AFD9EF85-B6E3-4113-8C20-43E19C3DB9EB}"/>
+                <a16:creationId xmlns:a16="http://schemas.microsoft.com/office/drawing/2014/main" id="{7CA0A7FD-A908-4664-9D60-DC2691CA69C4}"/>
               </a:ext>
             </a:extLst>
           </p:cNvPr>
@@ -30880,7 +30880,7 @@
     </p:spTree>
     <p:extLst>
       <p:ext uri="{BB962C8B-B14F-4D97-AF65-F5344CB8AC3E}">
-        <p14:creationId xmlns:p14="http://schemas.microsoft.com/office/powerpoint/2010/main" val="373628130"/>
+        <p14:creationId xmlns:p14="http://schemas.microsoft.com/office/powerpoint/2010/main" val="361099487"/>
       </p:ext>
     </p:extLst>
   </p:cSld>
@@ -30911,7 +30911,7 @@
           <p:cNvPr id="8" name="">
             <a:extLst xmlns:a="http://schemas.openxmlformats.org/drawingml/2006/main">
               <a:ext uri="{FF2B5EF4-FFF2-40B4-BE49-F238E27FC236}">
-                <a16:creationId xmlns:a16="http://schemas.microsoft.com/office/drawing/2014/main" id="{06BE8E13-F9DF-4A45-9E76-5B5E05484BE6}"/>
+                <a16:creationId xmlns:a16="http://schemas.microsoft.com/office/drawing/2014/main" id="{F992B09F-3F9E-41D2-A737-7C9C1AA57450}"/>
               </a:ext>
             </a:extLst>
           </p:cNvPr>
@@ -30942,7 +30942,7 @@
           <p:cNvPr id="2" name="">
             <a:extLst xmlns:a="http://schemas.openxmlformats.org/drawingml/2006/main">
               <a:ext uri="{FF2B5EF4-FFF2-40B4-BE49-F238E27FC236}">
-                <a16:creationId xmlns:a16="http://schemas.microsoft.com/office/drawing/2014/main" id="{8A064B1F-8D33-4D39-8208-5EF0C529C59D}"/>
+                <a16:creationId xmlns:a16="http://schemas.microsoft.com/office/drawing/2014/main" id="{F3AB03E3-31E2-4AD2-BD19-03CCDD53FDB8}"/>
               </a:ext>
             </a:extLst>
           </p:cNvPr>
@@ -30973,7 +30973,7 @@
           <p:cNvPr id="3" name="">
             <a:extLst xmlns:a="http://schemas.openxmlformats.org/drawingml/2006/main">
               <a:ext uri="{FF2B5EF4-FFF2-40B4-BE49-F238E27FC236}">
-                <a16:creationId xmlns:a16="http://schemas.microsoft.com/office/drawing/2014/main" id="{2A976B25-30DE-4F5F-8201-79B5EB7A27FF}"/>
+                <a16:creationId xmlns:a16="http://schemas.microsoft.com/office/drawing/2014/main" id="{5450DECD-5B39-488E-94C3-F340BC571F0E}"/>
               </a:ext>
             </a:extLst>
           </p:cNvPr>
@@ -31130,7 +31130,7 @@
           <p:cNvPr id="4" name="">
             <a:extLst xmlns:a="http://schemas.openxmlformats.org/drawingml/2006/main">
               <a:ext uri="{FF2B5EF4-FFF2-40B4-BE49-F238E27FC236}">
-                <a16:creationId xmlns:a16="http://schemas.microsoft.com/office/drawing/2014/main" id="{9E63C770-7BFF-4A82-91D3-986DE08ADB28}"/>
+                <a16:creationId xmlns:a16="http://schemas.microsoft.com/office/drawing/2014/main" id="{71AD93AD-E0A3-4134-A033-541E92615969}"/>
               </a:ext>
             </a:extLst>
           </p:cNvPr>
@@ -31161,7 +31161,7 @@
           <p:cNvPr id="5" name="">
             <a:extLst xmlns:a="http://schemas.openxmlformats.org/drawingml/2006/main">
               <a:ext uri="{FF2B5EF4-FFF2-40B4-BE49-F238E27FC236}">
-                <a16:creationId xmlns:a16="http://schemas.microsoft.com/office/drawing/2014/main" id="{2CF32A6F-E414-44D2-A23A-13A7F416F239}"/>
+                <a16:creationId xmlns:a16="http://schemas.microsoft.com/office/drawing/2014/main" id="{020AF4FA-9268-4BAE-8FB2-6A9F6226BA3E}"/>
               </a:ext>
             </a:extLst>
           </p:cNvPr>
@@ -31318,7 +31318,7 @@
           <p:cNvPr id="6" name="">
             <a:extLst xmlns:a="http://schemas.openxmlformats.org/drawingml/2006/main">
               <a:ext uri="{FF2B5EF4-FFF2-40B4-BE49-F238E27FC236}">
-                <a16:creationId xmlns:a16="http://schemas.microsoft.com/office/drawing/2014/main" id="{FA118DE1-1B00-4CD6-9BA5-7C2C654DDBBB}"/>
+                <a16:creationId xmlns:a16="http://schemas.microsoft.com/office/drawing/2014/main" id="{5446B40A-2B28-4F75-8FB2-F1F6FDA0335B}"/>
               </a:ext>
             </a:extLst>
           </p:cNvPr>
@@ -31475,7 +31475,7 @@
           <p:cNvPr id="7" name="">
             <a:extLst xmlns:a="http://schemas.openxmlformats.org/drawingml/2006/main">
               <a:ext uri="{FF2B5EF4-FFF2-40B4-BE49-F238E27FC236}">
-                <a16:creationId xmlns:a16="http://schemas.microsoft.com/office/drawing/2014/main" id="{1F713885-784D-46BE-83E5-190DF999E9F9}"/>
+                <a16:creationId xmlns:a16="http://schemas.microsoft.com/office/drawing/2014/main" id="{8206DF78-6739-4CC7-B472-722AFCE52B9A}"/>
               </a:ext>
             </a:extLst>
           </p:cNvPr>
@@ -31630,7 +31630,7 @@
     </p:spTree>
     <p:extLst>
       <p:ext uri="{BB962C8B-B14F-4D97-AF65-F5344CB8AC3E}">
-        <p14:creationId xmlns:p14="http://schemas.microsoft.com/office/powerpoint/2010/main" val="363307991"/>
+        <p14:creationId xmlns:p14="http://schemas.microsoft.com/office/powerpoint/2010/main" val="186251999"/>
       </p:ext>
     </p:extLst>
   </p:cSld>
@@ -31661,7 +31661,7 @@
           <p:cNvPr id="8" name="">
             <a:extLst xmlns:a="http://schemas.openxmlformats.org/drawingml/2006/main">
               <a:ext uri="{FF2B5EF4-FFF2-40B4-BE49-F238E27FC236}">
-                <a16:creationId xmlns:a16="http://schemas.microsoft.com/office/drawing/2014/main" id="{7E001A81-5D42-4F22-B8DC-AF4D3ADA97E2}"/>
+                <a16:creationId xmlns:a16="http://schemas.microsoft.com/office/drawing/2014/main" id="{B8E99B02-293E-4C49-98C8-DA2F2D09067B}"/>
               </a:ext>
             </a:extLst>
           </p:cNvPr>
@@ -31692,7 +31692,7 @@
           <p:cNvPr id="2" name="">
             <a:extLst xmlns:a="http://schemas.openxmlformats.org/drawingml/2006/main">
               <a:ext uri="{FF2B5EF4-FFF2-40B4-BE49-F238E27FC236}">
-                <a16:creationId xmlns:a16="http://schemas.microsoft.com/office/drawing/2014/main" id="{BEF95F24-0E75-4A84-8B43-0F1801D78DB2}"/>
+                <a16:creationId xmlns:a16="http://schemas.microsoft.com/office/drawing/2014/main" id="{7704175B-956D-4606-A50F-7CDE5A11A458}"/>
               </a:ext>
             </a:extLst>
           </p:cNvPr>
@@ -31723,7 +31723,7 @@
           <p:cNvPr id="3" name="">
             <a:extLst xmlns:a="http://schemas.openxmlformats.org/drawingml/2006/main">
               <a:ext uri="{FF2B5EF4-FFF2-40B4-BE49-F238E27FC236}">
-                <a16:creationId xmlns:a16="http://schemas.microsoft.com/office/drawing/2014/main" id="{912BAAF3-A038-49F4-BBE4-B50FA8D26E34}"/>
+                <a16:creationId xmlns:a16="http://schemas.microsoft.com/office/drawing/2014/main" id="{F05AD7EA-0220-4FAE-8F08-34C61CF4AACC}"/>
               </a:ext>
             </a:extLst>
           </p:cNvPr>
@@ -31880,7 +31880,7 @@
           <p:cNvPr id="4" name="">
             <a:extLst xmlns:a="http://schemas.openxmlformats.org/drawingml/2006/main">
               <a:ext uri="{FF2B5EF4-FFF2-40B4-BE49-F238E27FC236}">
-                <a16:creationId xmlns:a16="http://schemas.microsoft.com/office/drawing/2014/main" id="{6A332077-5139-4ABB-83AD-2394E9586CCC}"/>
+                <a16:creationId xmlns:a16="http://schemas.microsoft.com/office/drawing/2014/main" id="{DF03CE24-AFE8-41AC-A5E9-CAED068F4EC4}"/>
               </a:ext>
             </a:extLst>
           </p:cNvPr>
@@ -31911,7 +31911,7 @@
           <p:cNvPr id="5" name="">
             <a:extLst xmlns:a="http://schemas.openxmlformats.org/drawingml/2006/main">
               <a:ext uri="{FF2B5EF4-FFF2-40B4-BE49-F238E27FC236}">
-                <a16:creationId xmlns:a16="http://schemas.microsoft.com/office/drawing/2014/main" id="{5CE72A78-8550-4E6F-8874-8071CBD30192}"/>
+                <a16:creationId xmlns:a16="http://schemas.microsoft.com/office/drawing/2014/main" id="{FCD12F05-8617-411C-9270-A802FECE9449}"/>
               </a:ext>
             </a:extLst>
           </p:cNvPr>
@@ -32068,7 +32068,7 @@
           <p:cNvPr id="6" name="">
             <a:extLst xmlns:a="http://schemas.openxmlformats.org/drawingml/2006/main">
               <a:ext uri="{FF2B5EF4-FFF2-40B4-BE49-F238E27FC236}">
-                <a16:creationId xmlns:a16="http://schemas.microsoft.com/office/drawing/2014/main" id="{14078A2F-0045-4507-B25F-1E06F59AC01C}"/>
+                <a16:creationId xmlns:a16="http://schemas.microsoft.com/office/drawing/2014/main" id="{105D1D4F-7E07-491C-8129-D68AB7F0C1E1}"/>
               </a:ext>
             </a:extLst>
           </p:cNvPr>
@@ -32225,7 +32225,7 @@
           <p:cNvPr id="7" name="">
             <a:extLst xmlns:a="http://schemas.openxmlformats.org/drawingml/2006/main">
               <a:ext uri="{FF2B5EF4-FFF2-40B4-BE49-F238E27FC236}">
-                <a16:creationId xmlns:a16="http://schemas.microsoft.com/office/drawing/2014/main" id="{D547D430-49D6-486C-959C-FCAB3FC129BF}"/>
+                <a16:creationId xmlns:a16="http://schemas.microsoft.com/office/drawing/2014/main" id="{99986051-F910-441B-8338-8D3C231225A8}"/>
               </a:ext>
             </a:extLst>
           </p:cNvPr>
@@ -32380,7 +32380,7 @@
     </p:spTree>
     <p:extLst>
       <p:ext uri="{BB962C8B-B14F-4D97-AF65-F5344CB8AC3E}">
-        <p14:creationId xmlns:p14="http://schemas.microsoft.com/office/powerpoint/2010/main" val="196575504"/>
+        <p14:creationId xmlns:p14="http://schemas.microsoft.com/office/powerpoint/2010/main" val="453082379"/>
       </p:ext>
     </p:extLst>
   </p:cSld>
@@ -32411,7 +32411,7 @@
           <p:cNvPr id="7" name="">
             <a:extLst xmlns:a="http://schemas.openxmlformats.org/drawingml/2006/main">
               <a:ext uri="{FF2B5EF4-FFF2-40B4-BE49-F238E27FC236}">
-                <a16:creationId xmlns:a16="http://schemas.microsoft.com/office/drawing/2014/main" id="{F6FAA664-692D-490E-BDB4-F5BE8B1F4799}"/>
+                <a16:creationId xmlns:a16="http://schemas.microsoft.com/office/drawing/2014/main" id="{FEDB9C78-8674-4152-BF0E-366EB211ED13}"/>
               </a:ext>
             </a:extLst>
           </p:cNvPr>
@@ -32442,7 +32442,7 @@
           <p:cNvPr id="2" name="">
             <a:extLst xmlns:a="http://schemas.openxmlformats.org/drawingml/2006/main">
               <a:ext uri="{FF2B5EF4-FFF2-40B4-BE49-F238E27FC236}">
-                <a16:creationId xmlns:a16="http://schemas.microsoft.com/office/drawing/2014/main" id="{74DC70F8-F5FC-434A-A603-EE89AC08799B}"/>
+                <a16:creationId xmlns:a16="http://schemas.microsoft.com/office/drawing/2014/main" id="{CAAFFF7D-8482-4E0F-81E9-6E9A493217F2}"/>
               </a:ext>
             </a:extLst>
           </p:cNvPr>
@@ -32473,7 +32473,7 @@
           <p:cNvPr id="3" name="">
             <a:extLst xmlns:a="http://schemas.openxmlformats.org/drawingml/2006/main">
               <a:ext uri="{FF2B5EF4-FFF2-40B4-BE49-F238E27FC236}">
-                <a16:creationId xmlns:a16="http://schemas.microsoft.com/office/drawing/2014/main" id="{80852A75-E71F-4FEC-84DD-F14B829952EF}"/>
+                <a16:creationId xmlns:a16="http://schemas.microsoft.com/office/drawing/2014/main" id="{BA4316A2-BCB7-4B2A-BA52-617697DE14FB}"/>
               </a:ext>
             </a:extLst>
           </p:cNvPr>
@@ -32653,7 +32653,7 @@
           <p:cNvPr id="4" name="">
             <a:extLst xmlns:a="http://schemas.openxmlformats.org/drawingml/2006/main">
               <a:ext uri="{FF2B5EF4-FFF2-40B4-BE49-F238E27FC236}">
-                <a16:creationId xmlns:a16="http://schemas.microsoft.com/office/drawing/2014/main" id="{E15FCE35-10B3-4AE9-9DCE-4655A621B79D}"/>
+                <a16:creationId xmlns:a16="http://schemas.microsoft.com/office/drawing/2014/main" id="{6C27D385-DB0C-4601-ABF8-8C29926301ED}"/>
               </a:ext>
             </a:extLst>
           </p:cNvPr>
@@ -32684,7 +32684,7 @@
           <p:cNvPr id="5" name="">
             <a:extLst xmlns:a="http://schemas.openxmlformats.org/drawingml/2006/main">
               <a:ext uri="{FF2B5EF4-FFF2-40B4-BE49-F238E27FC236}">
-                <a16:creationId xmlns:a16="http://schemas.microsoft.com/office/drawing/2014/main" id="{D5F8C923-6861-47CF-A408-EC0203D2B14F}"/>
+                <a16:creationId xmlns:a16="http://schemas.microsoft.com/office/drawing/2014/main" id="{2D28525D-B336-41BC-815A-86DDE29E1A86}"/>
               </a:ext>
             </a:extLst>
           </p:cNvPr>
@@ -32841,7 +32841,7 @@
           <p:cNvPr id="6" name="">
             <a:extLst xmlns:a="http://schemas.openxmlformats.org/drawingml/2006/main">
               <a:ext uri="{FF2B5EF4-FFF2-40B4-BE49-F238E27FC236}">
-                <a16:creationId xmlns:a16="http://schemas.microsoft.com/office/drawing/2014/main" id="{AD9A4326-9883-489B-9A9D-ED05959C52B4}"/>
+                <a16:creationId xmlns:a16="http://schemas.microsoft.com/office/drawing/2014/main" id="{195FC7FB-0706-497D-AFB8-02FD0BC3C52E}"/>
               </a:ext>
             </a:extLst>
           </p:cNvPr>
@@ -32996,7 +32996,7 @@
     </p:spTree>
     <p:extLst>
       <p:ext uri="{BB962C8B-B14F-4D97-AF65-F5344CB8AC3E}">
-        <p14:creationId xmlns:p14="http://schemas.microsoft.com/office/powerpoint/2010/main" val="17772862"/>
+        <p14:creationId xmlns:p14="http://schemas.microsoft.com/office/powerpoint/2010/main" val="1370135938"/>
       </p:ext>
     </p:extLst>
   </p:cSld>
@@ -33027,7 +33027,7 @@
           <p:cNvPr id="7" name="">
             <a:extLst xmlns:a="http://schemas.openxmlformats.org/drawingml/2006/main">
               <a:ext uri="{FF2B5EF4-FFF2-40B4-BE49-F238E27FC236}">
-                <a16:creationId xmlns:a16="http://schemas.microsoft.com/office/drawing/2014/main" id="{C289B1B1-CD92-424C-AF78-52C2FA86E1ED}"/>
+                <a16:creationId xmlns:a16="http://schemas.microsoft.com/office/drawing/2014/main" id="{6B38A2A7-87DA-4C90-92EC-47A0026A6ED7}"/>
               </a:ext>
             </a:extLst>
           </p:cNvPr>
@@ -33058,7 +33058,7 @@
           <p:cNvPr id="2" name="">
             <a:extLst xmlns:a="http://schemas.openxmlformats.org/drawingml/2006/main">
               <a:ext uri="{FF2B5EF4-FFF2-40B4-BE49-F238E27FC236}">
-                <a16:creationId xmlns:a16="http://schemas.microsoft.com/office/drawing/2014/main" id="{A1D21B03-DE36-4033-9C4D-0E3DEF1A048B}"/>
+                <a16:creationId xmlns:a16="http://schemas.microsoft.com/office/drawing/2014/main" id="{1CE77E6B-FF1F-4B1B-B918-1D7A41D3B9F0}"/>
               </a:ext>
             </a:extLst>
           </p:cNvPr>
@@ -33089,7 +33089,7 @@
           <p:cNvPr id="3" name="">
             <a:extLst xmlns:a="http://schemas.openxmlformats.org/drawingml/2006/main">
               <a:ext uri="{FF2B5EF4-FFF2-40B4-BE49-F238E27FC236}">
-                <a16:creationId xmlns:a16="http://schemas.microsoft.com/office/drawing/2014/main" id="{F850E163-5335-4FAC-89E2-D0EB5FA9C8D9}"/>
+                <a16:creationId xmlns:a16="http://schemas.microsoft.com/office/drawing/2014/main" id="{3ED0947F-B79E-43B9-87BC-BFB9BA67BBD8}"/>
               </a:ext>
             </a:extLst>
           </p:cNvPr>
@@ -33269,7 +33269,7 @@
           <p:cNvPr id="4" name="">
             <a:extLst xmlns:a="http://schemas.openxmlformats.org/drawingml/2006/main">
               <a:ext uri="{FF2B5EF4-FFF2-40B4-BE49-F238E27FC236}">
-                <a16:creationId xmlns:a16="http://schemas.microsoft.com/office/drawing/2014/main" id="{1C1E2100-A79F-4D70-995E-9801462268CB}"/>
+                <a16:creationId xmlns:a16="http://schemas.microsoft.com/office/drawing/2014/main" id="{FAB0A914-85C4-4AC8-999B-2DA11DBDE540}"/>
               </a:ext>
             </a:extLst>
           </p:cNvPr>
@@ -33300,7 +33300,7 @@
           <p:cNvPr id="5" name="">
             <a:extLst xmlns:a="http://schemas.openxmlformats.org/drawingml/2006/main">
               <a:ext uri="{FF2B5EF4-FFF2-40B4-BE49-F238E27FC236}">
-                <a16:creationId xmlns:a16="http://schemas.microsoft.com/office/drawing/2014/main" id="{F0F0CDC7-0004-44C6-A47B-008955FBAD21}"/>
+                <a16:creationId xmlns:a16="http://schemas.microsoft.com/office/drawing/2014/main" id="{3D909704-1B06-4371-B7AB-1FCD0E45DC8A}"/>
               </a:ext>
             </a:extLst>
           </p:cNvPr>
@@ -33457,7 +33457,7 @@
           <p:cNvPr id="6" name="">
             <a:extLst xmlns:a="http://schemas.openxmlformats.org/drawingml/2006/main">
               <a:ext uri="{FF2B5EF4-FFF2-40B4-BE49-F238E27FC236}">
-                <a16:creationId xmlns:a16="http://schemas.microsoft.com/office/drawing/2014/main" id="{C98530E9-86FA-4F43-BBD1-0F49FD3A0A09}"/>
+                <a16:creationId xmlns:a16="http://schemas.microsoft.com/office/drawing/2014/main" id="{89FCC53B-3A72-4C89-96BC-A8D10610DD8C}"/>
               </a:ext>
             </a:extLst>
           </p:cNvPr>
@@ -33612,7 +33612,7 @@
     </p:spTree>
     <p:extLst>
       <p:ext uri="{BB962C8B-B14F-4D97-AF65-F5344CB8AC3E}">
-        <p14:creationId xmlns:p14="http://schemas.microsoft.com/office/powerpoint/2010/main" val="1620036819"/>
+        <p14:creationId xmlns:p14="http://schemas.microsoft.com/office/powerpoint/2010/main" val="1103654422"/>
       </p:ext>
     </p:extLst>
   </p:cSld>
@@ -33643,7 +33643,7 @@
           <p:cNvPr id="6" name="">
             <a:extLst xmlns:a="http://schemas.openxmlformats.org/drawingml/2006/main">
               <a:ext uri="{FF2B5EF4-FFF2-40B4-BE49-F238E27FC236}">
-                <a16:creationId xmlns:a16="http://schemas.microsoft.com/office/drawing/2014/main" id="{49E01CB2-607B-4323-944E-56B6B5C91207}"/>
+                <a16:creationId xmlns:a16="http://schemas.microsoft.com/office/drawing/2014/main" id="{B2F2AE8E-CEAE-41CA-BB97-33FB7503ECA7}"/>
               </a:ext>
             </a:extLst>
           </p:cNvPr>
@@ -33674,7 +33674,7 @@
           <p:cNvPr id="2" name="">
             <a:extLst xmlns:a="http://schemas.openxmlformats.org/drawingml/2006/main">
               <a:ext uri="{FF2B5EF4-FFF2-40B4-BE49-F238E27FC236}">
-                <a16:creationId xmlns:a16="http://schemas.microsoft.com/office/drawing/2014/main" id="{07914803-02A0-41A4-BC5C-62F4F52BA7FF}"/>
+                <a16:creationId xmlns:a16="http://schemas.microsoft.com/office/drawing/2014/main" id="{0019C258-F243-476A-BE4D-1D8DCFAC96CF}"/>
               </a:ext>
             </a:extLst>
           </p:cNvPr>
@@ -33705,7 +33705,7 @@
           <p:cNvPr id="3" name="">
             <a:extLst xmlns:a="http://schemas.openxmlformats.org/drawingml/2006/main">
               <a:ext uri="{FF2B5EF4-FFF2-40B4-BE49-F238E27FC236}">
-                <a16:creationId xmlns:a16="http://schemas.microsoft.com/office/drawing/2014/main" id="{8B1F0DD1-12D2-4FF1-B2A7-F3F4A9B86DFC}"/>
+                <a16:creationId xmlns:a16="http://schemas.microsoft.com/office/drawing/2014/main" id="{DF014EC8-E23B-44FA-B467-18FB3E5DBB0F}"/>
               </a:ext>
             </a:extLst>
           </p:cNvPr>
@@ -33862,7 +33862,7 @@
           <p:cNvPr id="4" name="">
             <a:extLst xmlns:a="http://schemas.openxmlformats.org/drawingml/2006/main">
               <a:ext uri="{FF2B5EF4-FFF2-40B4-BE49-F238E27FC236}">
-                <a16:creationId xmlns:a16="http://schemas.microsoft.com/office/drawing/2014/main" id="{A23CDB4D-C7A8-4B71-9AF2-7EC9A66BAAEB}"/>
+                <a16:creationId xmlns:a16="http://schemas.microsoft.com/office/drawing/2014/main" id="{7D61D1E9-80DC-458A-B9B2-0F12AE8C2BED}"/>
               </a:ext>
             </a:extLst>
           </p:cNvPr>
@@ -33893,7 +33893,7 @@
           <p:cNvPr id="5" name="">
             <a:extLst xmlns:a="http://schemas.openxmlformats.org/drawingml/2006/main">
               <a:ext uri="{FF2B5EF4-FFF2-40B4-BE49-F238E27FC236}">
-                <a16:creationId xmlns:a16="http://schemas.microsoft.com/office/drawing/2014/main" id="{BAFF93B2-B674-4515-AB02-E7453F5640CB}"/>
+                <a16:creationId xmlns:a16="http://schemas.microsoft.com/office/drawing/2014/main" id="{4D940408-C0E9-4345-94D0-9282155AF6F6}"/>
               </a:ext>
             </a:extLst>
           </p:cNvPr>
@@ -34048,7 +34048,7 @@
     </p:spTree>
     <p:extLst>
       <p:ext uri="{BB962C8B-B14F-4D97-AF65-F5344CB8AC3E}">
-        <p14:creationId xmlns:p14="http://schemas.microsoft.com/office/powerpoint/2010/main" val="1570184567"/>
+        <p14:creationId xmlns:p14="http://schemas.microsoft.com/office/powerpoint/2010/main" val="2141463262"/>
       </p:ext>
     </p:extLst>
   </p:cSld>
@@ -34079,7 +34079,7 @@
           <p:cNvPr id="7" name="">
             <a:extLst xmlns:a="http://schemas.openxmlformats.org/drawingml/2006/main">
               <a:ext uri="{FF2B5EF4-FFF2-40B4-BE49-F238E27FC236}">
-                <a16:creationId xmlns:a16="http://schemas.microsoft.com/office/drawing/2014/main" id="{7C2F56A7-5C0A-4ADB-B055-B037E2CD3968}"/>
+                <a16:creationId xmlns:a16="http://schemas.microsoft.com/office/drawing/2014/main" id="{B454BF21-9E46-417B-8B28-34799BCAA815}"/>
               </a:ext>
             </a:extLst>
           </p:cNvPr>
@@ -34110,7 +34110,7 @@
           <p:cNvPr id="2" name="">
             <a:extLst xmlns:a="http://schemas.openxmlformats.org/drawingml/2006/main">
               <a:ext uri="{FF2B5EF4-FFF2-40B4-BE49-F238E27FC236}">
-                <a16:creationId xmlns:a16="http://schemas.microsoft.com/office/drawing/2014/main" id="{EE41FD91-36F4-4FB8-877B-E0B558078B5C}"/>
+                <a16:creationId xmlns:a16="http://schemas.microsoft.com/office/drawing/2014/main" id="{D34C5D43-9B6A-4816-99A1-C8E0A6FF51B8}"/>
               </a:ext>
             </a:extLst>
           </p:cNvPr>
@@ -34141,7 +34141,7 @@
           <p:cNvPr id="3" name="">
             <a:extLst xmlns:a="http://schemas.openxmlformats.org/drawingml/2006/main">
               <a:ext uri="{FF2B5EF4-FFF2-40B4-BE49-F238E27FC236}">
-                <a16:creationId xmlns:a16="http://schemas.microsoft.com/office/drawing/2014/main" id="{3FC37C5B-7C01-4543-8592-F379ED6B4E4A}"/>
+                <a16:creationId xmlns:a16="http://schemas.microsoft.com/office/drawing/2014/main" id="{EC1D400C-B531-4C28-BD9E-809C584A57CE}"/>
               </a:ext>
             </a:extLst>
           </p:cNvPr>
@@ -34152,8 +34152,8 @@
         </p:nvSpPr>
         <p:spPr>
           <a:xfrm xmlns:a="http://schemas.openxmlformats.org/drawingml/2006/main">
-            <a:off x="809625" y="857250"/>
-            <a:ext cx="10525125" cy="1619250"/>
+            <a:off x="781050" y="1162050"/>
+            <a:ext cx="10629900" cy="2286000"/>
           </a:xfrm>
           <a:prstGeom xmlns:a="http://schemas.openxmlformats.org/drawingml/2006/main" prst="rect">
             <a:avLst/>
@@ -34167,8 +34167,8 @@
         <p:txBody>
           <a:bodyPr xmlns:a="http://schemas.openxmlformats.org/drawingml/2006/main" anchor="ctr"/>
           <a:lstStyle xmlns:a="http://schemas.openxmlformats.org/drawingml/2006/main">
-            <a:defPPr algn="l">
-              <a:defRPr sz="3900" b="1">
+            <a:defPPr algn="ctr">
+              <a:defRPr sz="3975" b="1">
                 <a:solidFill>
                   <a:srgbClr val="202428"/>
                 </a:solidFill>
@@ -34177,8 +34177,8 @@
                 <a:cs typeface="Hiragino Kaku Gothic ProN"/>
               </a:defRPr>
             </a:defPPr>
-            <a:lvl1pPr algn="l">
-              <a:defRPr sz="3900" b="1">
+            <a:lvl1pPr algn="ctr">
+              <a:defRPr sz="3975" b="1">
                 <a:solidFill>
                   <a:srgbClr val="202428"/>
                 </a:solidFill>
@@ -34187,8 +34187,8 @@
                 <a:cs typeface="Hiragino Kaku Gothic ProN"/>
               </a:defRPr>
             </a:lvl1pPr>
-            <a:lvl2pPr algn="l">
-              <a:defRPr sz="3900" b="1">
+            <a:lvl2pPr algn="ctr">
+              <a:defRPr sz="3975" b="1">
                 <a:solidFill>
                   <a:srgbClr val="202428"/>
                 </a:solidFill>
@@ -34197,8 +34197,8 @@
                 <a:cs typeface="Hiragino Kaku Gothic ProN"/>
               </a:defRPr>
             </a:lvl2pPr>
-            <a:lvl3pPr algn="l">
-              <a:defRPr sz="3900" b="1">
+            <a:lvl3pPr algn="ctr">
+              <a:defRPr sz="3975" b="1">
                 <a:solidFill>
                   <a:srgbClr val="202428"/>
                 </a:solidFill>
@@ -34207,8 +34207,8 @@
                 <a:cs typeface="Hiragino Kaku Gothic ProN"/>
               </a:defRPr>
             </a:lvl3pPr>
-            <a:lvl4pPr algn="l">
-              <a:defRPr sz="3900" b="1">
+            <a:lvl4pPr algn="ctr">
+              <a:defRPr sz="3975" b="1">
                 <a:solidFill>
                   <a:srgbClr val="202428"/>
                 </a:solidFill>
@@ -34217,8 +34217,8 @@
                 <a:cs typeface="Hiragino Kaku Gothic ProN"/>
               </a:defRPr>
             </a:lvl4pPr>
-            <a:lvl5pPr algn="l">
-              <a:defRPr sz="3900" b="1">
+            <a:lvl5pPr algn="ctr">
+              <a:defRPr sz="3975" b="1">
                 <a:solidFill>
                   <a:srgbClr val="202428"/>
                 </a:solidFill>
@@ -34227,8 +34227,8 @@
                 <a:cs typeface="Hiragino Kaku Gothic ProN"/>
               </a:defRPr>
             </a:lvl5pPr>
-            <a:lvl6pPr algn="l">
-              <a:defRPr sz="3900" b="1">
+            <a:lvl6pPr algn="ctr">
+              <a:defRPr sz="3975" b="1">
                 <a:solidFill>
                   <a:srgbClr val="202428"/>
                 </a:solidFill>
@@ -34237,8 +34237,8 @@
                 <a:cs typeface="Hiragino Kaku Gothic ProN"/>
               </a:defRPr>
             </a:lvl6pPr>
-            <a:lvl7pPr algn="l">
-              <a:defRPr sz="3900" b="1">
+            <a:lvl7pPr algn="ctr">
+              <a:defRPr sz="3975" b="1">
                 <a:solidFill>
                   <a:srgbClr val="202428"/>
                 </a:solidFill>
@@ -34247,8 +34247,8 @@
                 <a:cs typeface="Hiragino Kaku Gothic ProN"/>
               </a:defRPr>
             </a:lvl7pPr>
-            <a:lvl8pPr algn="l">
-              <a:defRPr sz="3900" b="1">
+            <a:lvl8pPr algn="ctr">
+              <a:defRPr sz="3975" b="1">
                 <a:solidFill>
                   <a:srgbClr val="202428"/>
                 </a:solidFill>
@@ -34257,8 +34257,8 @@
                 <a:cs typeface="Hiragino Kaku Gothic ProN"/>
               </a:defRPr>
             </a:lvl8pPr>
-            <a:lvl9pPr algn="l">
-              <a:defRPr sz="3900" b="1">
+            <a:lvl9pPr algn="ctr">
+              <a:defRPr sz="3975" b="1">
                 <a:solidFill>
                   <a:srgbClr val="202428"/>
                 </a:solidFill>
@@ -34269,8 +34269,8 @@
             </a:lvl9pPr>
           </a:lstStyle>
           <a:p xmlns:a="http://schemas.openxmlformats.org/drawingml/2006/main">
-            <a:pPr algn="l">
-              <a:defRPr sz="3900" b="1">
+            <a:pPr algn="ctr">
+              <a:defRPr sz="3975" b="1">
                 <a:solidFill>
                   <a:srgbClr val="202428"/>
                 </a:solidFill>
@@ -34280,7 +34280,7 @@
               </a:defRPr>
             </a:pPr>
             <a:r>
-              <a:rPr sz="3900" b="1">
+              <a:rPr sz="3975" b="1">
                 <a:solidFill>
                   <a:srgbClr val="202428"/>
                 </a:solidFill>
@@ -34288,12 +34288,12 @@
                 <a:ea typeface="Hiragino Kaku Gothic ProN"/>
                 <a:cs typeface="Hiragino Kaku Gothic ProN"/>
               </a:rPr>
-              <a:t>仕事で英語を使う人を</a:t>
+              <a:t>教科書の「ガール」と、</a:t>
             </a:r>
           </a:p>
           <a:p xmlns:a="http://schemas.openxmlformats.org/drawingml/2006/main">
-            <a:pPr algn="l">
-              <a:defRPr sz="3900" b="1">
+            <a:pPr algn="ctr">
+              <a:defRPr sz="3975" b="1">
                 <a:solidFill>
                   <a:srgbClr val="202428"/>
                 </a:solidFill>
@@ -34303,7 +34303,7 @@
               </a:defRPr>
             </a:pPr>
             <a:r>
-              <a:rPr sz="3900" b="1">
+              <a:rPr sz="3975" b="1">
                 <a:solidFill>
                   <a:srgbClr val="202428"/>
                 </a:solidFill>
@@ -34311,7 +34311,7 @@
                 <a:ea typeface="Hiragino Kaku Gothic ProN"/>
                 <a:cs typeface="Hiragino Kaku Gothic ProN"/>
               </a:rPr>
-              <a:t>見てきました</a:t>
+              <a:t>耳で覚えた音が違った</a:t>
             </a:r>
           </a:p>
         </p:txBody>
@@ -34321,7 +34321,7 @@
           <p:cNvPr id="4" name="">
             <a:extLst xmlns:a="http://schemas.openxmlformats.org/drawingml/2006/main">
               <a:ext uri="{FF2B5EF4-FFF2-40B4-BE49-F238E27FC236}">
-                <a16:creationId xmlns:a16="http://schemas.microsoft.com/office/drawing/2014/main" id="{E5380FAB-23F7-4432-9E38-C36E340953A0}"/>
+                <a16:creationId xmlns:a16="http://schemas.microsoft.com/office/drawing/2014/main" id="{CF1395F0-7C18-445B-979B-50F513FC5E89}"/>
               </a:ext>
             </a:extLst>
           </p:cNvPr>
@@ -34332,8 +34332,8 @@
         </p:nvSpPr>
         <p:spPr>
           <a:xfrm xmlns:a="http://schemas.openxmlformats.org/drawingml/2006/main">
-            <a:off x="838200" y="2914650"/>
-            <a:ext cx="1314450" cy="28575"/>
+            <a:off x="4600575" y="3876675"/>
+            <a:ext cx="2990850" cy="28575"/>
           </a:xfrm>
           <a:prstGeom xmlns:a="http://schemas.openxmlformats.org/drawingml/2006/main" prst="rect">
             <a:avLst/>
@@ -34352,7 +34352,7 @@
           <p:cNvPr id="5" name="">
             <a:extLst xmlns:a="http://schemas.openxmlformats.org/drawingml/2006/main">
               <a:ext uri="{FF2B5EF4-FFF2-40B4-BE49-F238E27FC236}">
-                <a16:creationId xmlns:a16="http://schemas.microsoft.com/office/drawing/2014/main" id="{2065B751-C1A2-4CA5-86AD-5C4680A07D51}"/>
+                <a16:creationId xmlns:a16="http://schemas.microsoft.com/office/drawing/2014/main" id="{9901D4BB-6C77-45A3-893C-DDE4C3AB4D9E}"/>
               </a:ext>
             </a:extLst>
           </p:cNvPr>
@@ -34363,8 +34363,8 @@
         </p:nvSpPr>
         <p:spPr>
           <a:xfrm xmlns:a="http://schemas.openxmlformats.org/drawingml/2006/main">
-            <a:off x="838200" y="3286125"/>
-            <a:ext cx="10429875" cy="2171700"/>
+            <a:off x="990600" y="4295775"/>
+            <a:ext cx="10210800" cy="1381125"/>
           </a:xfrm>
           <a:prstGeom xmlns:a="http://schemas.openxmlformats.org/drawingml/2006/main" prst="rect">
             <a:avLst/>
@@ -34378,100 +34378,100 @@
         <p:txBody>
           <a:bodyPr xmlns:a="http://schemas.openxmlformats.org/drawingml/2006/main" anchor="ctr"/>
           <a:lstStyle xmlns:a="http://schemas.openxmlformats.org/drawingml/2006/main">
-            <a:defPPr algn="l">
-              <a:defRPr sz="2550" b="0">
-                <a:solidFill>
-                  <a:srgbClr val="222B31"/>
+            <a:defPPr algn="ctr">
+              <a:defRPr sz="2175" b="0">
+                <a:solidFill>
+                  <a:srgbClr val="526B73"/>
                 </a:solidFill>
                 <a:latin typeface="Hiragino Kaku Gothic ProN"/>
                 <a:ea typeface="Hiragino Kaku Gothic ProN"/>
                 <a:cs typeface="Hiragino Kaku Gothic ProN"/>
               </a:defRPr>
             </a:defPPr>
-            <a:lvl1pPr algn="l">
-              <a:defRPr sz="2550" b="0">
-                <a:solidFill>
-                  <a:srgbClr val="222B31"/>
+            <a:lvl1pPr algn="ctr">
+              <a:defRPr sz="2175" b="0">
+                <a:solidFill>
+                  <a:srgbClr val="526B73"/>
                 </a:solidFill>
                 <a:latin typeface="Hiragino Kaku Gothic ProN"/>
                 <a:ea typeface="Hiragino Kaku Gothic ProN"/>
                 <a:cs typeface="Hiragino Kaku Gothic ProN"/>
               </a:defRPr>
             </a:lvl1pPr>
-            <a:lvl2pPr algn="l">
-              <a:defRPr sz="2550" b="0">
-                <a:solidFill>
-                  <a:srgbClr val="222B31"/>
+            <a:lvl2pPr algn="ctr">
+              <a:defRPr sz="2175" b="0">
+                <a:solidFill>
+                  <a:srgbClr val="526B73"/>
                 </a:solidFill>
                 <a:latin typeface="Hiragino Kaku Gothic ProN"/>
                 <a:ea typeface="Hiragino Kaku Gothic ProN"/>
                 <a:cs typeface="Hiragino Kaku Gothic ProN"/>
               </a:defRPr>
             </a:lvl2pPr>
-            <a:lvl3pPr algn="l">
-              <a:defRPr sz="2550" b="0">
-                <a:solidFill>
-                  <a:srgbClr val="222B31"/>
+            <a:lvl3pPr algn="ctr">
+              <a:defRPr sz="2175" b="0">
+                <a:solidFill>
+                  <a:srgbClr val="526B73"/>
                 </a:solidFill>
                 <a:latin typeface="Hiragino Kaku Gothic ProN"/>
                 <a:ea typeface="Hiragino Kaku Gothic ProN"/>
                 <a:cs typeface="Hiragino Kaku Gothic ProN"/>
               </a:defRPr>
             </a:lvl3pPr>
-            <a:lvl4pPr algn="l">
-              <a:defRPr sz="2550" b="0">
-                <a:solidFill>
-                  <a:srgbClr val="222B31"/>
+            <a:lvl4pPr algn="ctr">
+              <a:defRPr sz="2175" b="0">
+                <a:solidFill>
+                  <a:srgbClr val="526B73"/>
                 </a:solidFill>
                 <a:latin typeface="Hiragino Kaku Gothic ProN"/>
                 <a:ea typeface="Hiragino Kaku Gothic ProN"/>
                 <a:cs typeface="Hiragino Kaku Gothic ProN"/>
               </a:defRPr>
             </a:lvl4pPr>
-            <a:lvl5pPr algn="l">
-              <a:defRPr sz="2550" b="0">
-                <a:solidFill>
-                  <a:srgbClr val="222B31"/>
+            <a:lvl5pPr algn="ctr">
+              <a:defRPr sz="2175" b="0">
+                <a:solidFill>
+                  <a:srgbClr val="526B73"/>
                 </a:solidFill>
                 <a:latin typeface="Hiragino Kaku Gothic ProN"/>
                 <a:ea typeface="Hiragino Kaku Gothic ProN"/>
                 <a:cs typeface="Hiragino Kaku Gothic ProN"/>
               </a:defRPr>
             </a:lvl5pPr>
-            <a:lvl6pPr algn="l">
-              <a:defRPr sz="2550" b="0">
-                <a:solidFill>
-                  <a:srgbClr val="222B31"/>
+            <a:lvl6pPr algn="ctr">
+              <a:defRPr sz="2175" b="0">
+                <a:solidFill>
+                  <a:srgbClr val="526B73"/>
                 </a:solidFill>
                 <a:latin typeface="Hiragino Kaku Gothic ProN"/>
                 <a:ea typeface="Hiragino Kaku Gothic ProN"/>
                 <a:cs typeface="Hiragino Kaku Gothic ProN"/>
               </a:defRPr>
             </a:lvl6pPr>
-            <a:lvl7pPr algn="l">
-              <a:defRPr sz="2550" b="0">
-                <a:solidFill>
-                  <a:srgbClr val="222B31"/>
+            <a:lvl7pPr algn="ctr">
+              <a:defRPr sz="2175" b="0">
+                <a:solidFill>
+                  <a:srgbClr val="526B73"/>
                 </a:solidFill>
                 <a:latin typeface="Hiragino Kaku Gothic ProN"/>
                 <a:ea typeface="Hiragino Kaku Gothic ProN"/>
                 <a:cs typeface="Hiragino Kaku Gothic ProN"/>
               </a:defRPr>
             </a:lvl7pPr>
-            <a:lvl8pPr algn="l">
-              <a:defRPr sz="2550" b="0">
-                <a:solidFill>
-                  <a:srgbClr val="222B31"/>
+            <a:lvl8pPr algn="ctr">
+              <a:defRPr sz="2175" b="0">
+                <a:solidFill>
+                  <a:srgbClr val="526B73"/>
                 </a:solidFill>
                 <a:latin typeface="Hiragino Kaku Gothic ProN"/>
                 <a:ea typeface="Hiragino Kaku Gothic ProN"/>
                 <a:cs typeface="Hiragino Kaku Gothic ProN"/>
               </a:defRPr>
             </a:lvl8pPr>
-            <a:lvl9pPr algn="l">
-              <a:defRPr sz="2550" b="0">
-                <a:solidFill>
-                  <a:srgbClr val="222B31"/>
+            <a:lvl9pPr algn="ctr">
+              <a:defRPr sz="2175" b="0">
+                <a:solidFill>
+                  <a:srgbClr val="526B73"/>
                 </a:solidFill>
                 <a:latin typeface="Hiragino Kaku Gothic ProN"/>
                 <a:ea typeface="Hiragino Kaku Gothic ProN"/>
@@ -34480,10 +34480,10 @@
             </a:lvl9pPr>
           </a:lstStyle>
           <a:p xmlns:a="http://schemas.openxmlformats.org/drawingml/2006/main">
-            <a:pPr algn="l">
-              <a:defRPr sz="2550" b="0">
-                <a:solidFill>
-                  <a:srgbClr val="222B31"/>
+            <a:pPr algn="ctr">
+              <a:defRPr sz="2175" b="0">
+                <a:solidFill>
+                  <a:srgbClr val="526B73"/>
                 </a:solidFill>
                 <a:latin typeface="Hiragino Kaku Gothic ProN"/>
                 <a:ea typeface="Hiragino Kaku Gothic ProN"/>
@@ -34491,15 +34491,15 @@
               </a:defRPr>
             </a:pPr>
             <a:r>
-              <a:rPr sz="2550" b="0">
-                <a:solidFill>
-                  <a:srgbClr val="222B31"/>
+              <a:rPr sz="2175" b="0">
+                <a:solidFill>
+                  <a:srgbClr val="526B73"/>
                 </a:solidFill>
                 <a:latin typeface="Hiragino Kaku Gothic ProN"/>
                 <a:ea typeface="Hiragino Kaku Gothic ProN"/>
                 <a:cs typeface="Hiragino Kaku Gothic ProN"/>
               </a:rPr>
-              <a:t>企業研修／英語コーチング／英語講師への指導</a:t>
+              <a:t>中学1年の夏、アメリカで気づいた音のズレ。</a:t>
             </a:r>
           </a:p>
         </p:txBody>
@@ -34509,7 +34509,7 @@
           <p:cNvPr id="6" name="">
             <a:extLst xmlns:a="http://schemas.openxmlformats.org/drawingml/2006/main">
               <a:ext uri="{FF2B5EF4-FFF2-40B4-BE49-F238E27FC236}">
-                <a16:creationId xmlns:a16="http://schemas.microsoft.com/office/drawing/2014/main" id="{24D4CFC9-EF5E-41C5-A544-D751DF33627F}"/>
+                <a16:creationId xmlns:a16="http://schemas.microsoft.com/office/drawing/2014/main" id="{C7CD2723-6D02-4624-881E-092722AE8938}"/>
               </a:ext>
             </a:extLst>
           </p:cNvPr>
@@ -34664,7 +34664,7 @@
     </p:spTree>
     <p:extLst>
       <p:ext uri="{BB962C8B-B14F-4D97-AF65-F5344CB8AC3E}">
-        <p14:creationId xmlns:p14="http://schemas.microsoft.com/office/powerpoint/2010/main" val="428708406"/>
+        <p14:creationId xmlns:p14="http://schemas.microsoft.com/office/powerpoint/2010/main" val="1416434418"/>
       </p:ext>
     </p:extLst>
   </p:cSld>
@@ -34695,7 +34695,7 @@
           <p:cNvPr id="7" name="">
             <a:extLst xmlns:a="http://schemas.openxmlformats.org/drawingml/2006/main">
               <a:ext uri="{FF2B5EF4-FFF2-40B4-BE49-F238E27FC236}">
-                <a16:creationId xmlns:a16="http://schemas.microsoft.com/office/drawing/2014/main" id="{1B1AAFA0-BAE1-4696-8F1A-857F36E78507}"/>
+                <a16:creationId xmlns:a16="http://schemas.microsoft.com/office/drawing/2014/main" id="{B94A9D50-D472-413A-83A1-E283AEF13C00}"/>
               </a:ext>
             </a:extLst>
           </p:cNvPr>
@@ -34726,7 +34726,7 @@
           <p:cNvPr id="2" name="">
             <a:extLst xmlns:a="http://schemas.openxmlformats.org/drawingml/2006/main">
               <a:ext uri="{FF2B5EF4-FFF2-40B4-BE49-F238E27FC236}">
-                <a16:creationId xmlns:a16="http://schemas.microsoft.com/office/drawing/2014/main" id="{D9418D1A-5051-4EAF-91B7-E87181E02EE9}"/>
+                <a16:creationId xmlns:a16="http://schemas.microsoft.com/office/drawing/2014/main" id="{03F085BF-D073-4141-A99A-0B468B08663D}"/>
               </a:ext>
             </a:extLst>
           </p:cNvPr>
@@ -34757,7 +34757,7 @@
           <p:cNvPr id="3" name="">
             <a:extLst xmlns:a="http://schemas.openxmlformats.org/drawingml/2006/main">
               <a:ext uri="{FF2B5EF4-FFF2-40B4-BE49-F238E27FC236}">
-                <a16:creationId xmlns:a16="http://schemas.microsoft.com/office/drawing/2014/main" id="{6D1FA5A5-63B0-4A55-8747-9FAC6B6C32B7}"/>
+                <a16:creationId xmlns:a16="http://schemas.microsoft.com/office/drawing/2014/main" id="{883EB9A5-BBA4-4901-9F96-4A2C41E86F46}"/>
               </a:ext>
             </a:extLst>
           </p:cNvPr>
@@ -34914,7 +34914,7 @@
           <p:cNvPr id="4" name="">
             <a:extLst xmlns:a="http://schemas.openxmlformats.org/drawingml/2006/main">
               <a:ext uri="{FF2B5EF4-FFF2-40B4-BE49-F238E27FC236}">
-                <a16:creationId xmlns:a16="http://schemas.microsoft.com/office/drawing/2014/main" id="{2679B7AE-DCF7-4D3E-BA06-9ACEDF95C486}"/>
+                <a16:creationId xmlns:a16="http://schemas.microsoft.com/office/drawing/2014/main" id="{474DBD1C-B59C-43AE-9ACF-856A87B97905}"/>
               </a:ext>
             </a:extLst>
           </p:cNvPr>
@@ -34945,7 +34945,7 @@
           <p:cNvPr id="5" name="">
             <a:extLst xmlns:a="http://schemas.openxmlformats.org/drawingml/2006/main">
               <a:ext uri="{FF2B5EF4-FFF2-40B4-BE49-F238E27FC236}">
-                <a16:creationId xmlns:a16="http://schemas.microsoft.com/office/drawing/2014/main" id="{A35DB362-BA94-4CD1-B03B-0A8B22CF2D52}"/>
+                <a16:creationId xmlns:a16="http://schemas.microsoft.com/office/drawing/2014/main" id="{0794357C-55F1-442C-83F8-01E2537C63E3}"/>
               </a:ext>
             </a:extLst>
           </p:cNvPr>
@@ -35102,7 +35102,7 @@
           <p:cNvPr id="6" name="">
             <a:extLst xmlns:a="http://schemas.openxmlformats.org/drawingml/2006/main">
               <a:ext uri="{FF2B5EF4-FFF2-40B4-BE49-F238E27FC236}">
-                <a16:creationId xmlns:a16="http://schemas.microsoft.com/office/drawing/2014/main" id="{C5D362D0-A899-4BFE-B5C2-D1DD7BC484C7}"/>
+                <a16:creationId xmlns:a16="http://schemas.microsoft.com/office/drawing/2014/main" id="{CAF972BF-E42E-437C-84A6-298BFD644366}"/>
               </a:ext>
             </a:extLst>
           </p:cNvPr>
@@ -35257,7 +35257,7 @@
     </p:spTree>
     <p:extLst>
       <p:ext uri="{BB962C8B-B14F-4D97-AF65-F5344CB8AC3E}">
-        <p14:creationId xmlns:p14="http://schemas.microsoft.com/office/powerpoint/2010/main" val="1030356159"/>
+        <p14:creationId xmlns:p14="http://schemas.microsoft.com/office/powerpoint/2010/main" val="1400143397"/>
       </p:ext>
     </p:extLst>
   </p:cSld>
@@ -35288,7 +35288,7 @@
           <p:cNvPr id="7" name="">
             <a:extLst xmlns:a="http://schemas.openxmlformats.org/drawingml/2006/main">
               <a:ext uri="{FF2B5EF4-FFF2-40B4-BE49-F238E27FC236}">
-                <a16:creationId xmlns:a16="http://schemas.microsoft.com/office/drawing/2014/main" id="{6FF41D6D-19C9-44DB-8708-6DCB87944BCA}"/>
+                <a16:creationId xmlns:a16="http://schemas.microsoft.com/office/drawing/2014/main" id="{A008871E-402E-4A22-8323-1AC4A413FC39}"/>
               </a:ext>
             </a:extLst>
           </p:cNvPr>
@@ -35319,7 +35319,7 @@
           <p:cNvPr id="2" name="">
             <a:extLst xmlns:a="http://schemas.openxmlformats.org/drawingml/2006/main">
               <a:ext uri="{FF2B5EF4-FFF2-40B4-BE49-F238E27FC236}">
-                <a16:creationId xmlns:a16="http://schemas.microsoft.com/office/drawing/2014/main" id="{56B52DC6-A2F4-4538-9759-AA7E654C9627}"/>
+                <a16:creationId xmlns:a16="http://schemas.microsoft.com/office/drawing/2014/main" id="{FCA46A83-53B8-4661-A9EE-07EAECDAF016}"/>
               </a:ext>
             </a:extLst>
           </p:cNvPr>
@@ -35350,7 +35350,7 @@
           <p:cNvPr id="3" name="">
             <a:extLst xmlns:a="http://schemas.openxmlformats.org/drawingml/2006/main">
               <a:ext uri="{FF2B5EF4-FFF2-40B4-BE49-F238E27FC236}">
-                <a16:creationId xmlns:a16="http://schemas.microsoft.com/office/drawing/2014/main" id="{FF479549-E5B1-43EA-A871-598C77CF5AF2}"/>
+                <a16:creationId xmlns:a16="http://schemas.microsoft.com/office/drawing/2014/main" id="{8CF82B47-9C6A-47A3-8DA9-9064BA842A2D}"/>
               </a:ext>
             </a:extLst>
           </p:cNvPr>
@@ -35530,7 +35530,7 @@
           <p:cNvPr id="4" name="">
             <a:extLst xmlns:a="http://schemas.openxmlformats.org/drawingml/2006/main">
               <a:ext uri="{FF2B5EF4-FFF2-40B4-BE49-F238E27FC236}">
-                <a16:creationId xmlns:a16="http://schemas.microsoft.com/office/drawing/2014/main" id="{C7B2297D-8A90-4652-96CC-B5586D640492}"/>
+                <a16:creationId xmlns:a16="http://schemas.microsoft.com/office/drawing/2014/main" id="{8F6DC217-3520-41A7-BAC0-449FE16D6D19}"/>
               </a:ext>
             </a:extLst>
           </p:cNvPr>
@@ -35561,7 +35561,7 @@
           <p:cNvPr id="5" name="">
             <a:extLst xmlns:a="http://schemas.openxmlformats.org/drawingml/2006/main">
               <a:ext uri="{FF2B5EF4-FFF2-40B4-BE49-F238E27FC236}">
-                <a16:creationId xmlns:a16="http://schemas.microsoft.com/office/drawing/2014/main" id="{87317C7D-B815-4292-A338-5C01C34F1640}"/>
+                <a16:creationId xmlns:a16="http://schemas.microsoft.com/office/drawing/2014/main" id="{CEC87077-6781-47A2-9D91-E87A2624A8CD}"/>
               </a:ext>
             </a:extLst>
           </p:cNvPr>
@@ -35718,7 +35718,7 @@
           <p:cNvPr id="6" name="">
             <a:extLst xmlns:a="http://schemas.openxmlformats.org/drawingml/2006/main">
               <a:ext uri="{FF2B5EF4-FFF2-40B4-BE49-F238E27FC236}">
-                <a16:creationId xmlns:a16="http://schemas.microsoft.com/office/drawing/2014/main" id="{A30FB8D5-D646-4A78-9A19-D39D54FDB2A8}"/>
+                <a16:creationId xmlns:a16="http://schemas.microsoft.com/office/drawing/2014/main" id="{A047E96C-3EE4-4D4C-8121-122AD3F44375}"/>
               </a:ext>
             </a:extLst>
           </p:cNvPr>
@@ -35873,7 +35873,7 @@
     </p:spTree>
     <p:extLst>
       <p:ext uri="{BB962C8B-B14F-4D97-AF65-F5344CB8AC3E}">
-        <p14:creationId xmlns:p14="http://schemas.microsoft.com/office/powerpoint/2010/main" val="1308120273"/>
+        <p14:creationId xmlns:p14="http://schemas.microsoft.com/office/powerpoint/2010/main" val="765878869"/>
       </p:ext>
     </p:extLst>
   </p:cSld>
@@ -35904,7 +35904,7 @@
           <p:cNvPr id="7" name="">
             <a:extLst xmlns:a="http://schemas.openxmlformats.org/drawingml/2006/main">
               <a:ext uri="{FF2B5EF4-FFF2-40B4-BE49-F238E27FC236}">
-                <a16:creationId xmlns:a16="http://schemas.microsoft.com/office/drawing/2014/main" id="{6C6B1468-2305-432E-8EB8-48F14E4FB524}"/>
+                <a16:creationId xmlns:a16="http://schemas.microsoft.com/office/drawing/2014/main" id="{C88F6800-51D1-41BC-89FF-311A7E29704A}"/>
               </a:ext>
             </a:extLst>
           </p:cNvPr>
@@ -35935,7 +35935,7 @@
           <p:cNvPr id="2" name="">
             <a:extLst xmlns:a="http://schemas.openxmlformats.org/drawingml/2006/main">
               <a:ext uri="{FF2B5EF4-FFF2-40B4-BE49-F238E27FC236}">
-                <a16:creationId xmlns:a16="http://schemas.microsoft.com/office/drawing/2014/main" id="{71B103D4-DF01-4BE1-A800-41570FFC6297}"/>
+                <a16:creationId xmlns:a16="http://schemas.microsoft.com/office/drawing/2014/main" id="{84B66723-9D31-448D-966D-BEA55546AE69}"/>
               </a:ext>
             </a:extLst>
           </p:cNvPr>
@@ -35966,7 +35966,7 @@
           <p:cNvPr id="3" name="">
             <a:extLst xmlns:a="http://schemas.openxmlformats.org/drawingml/2006/main">
               <a:ext uri="{FF2B5EF4-FFF2-40B4-BE49-F238E27FC236}">
-                <a16:creationId xmlns:a16="http://schemas.microsoft.com/office/drawing/2014/main" id="{B08CDE1B-4D69-4D43-A63C-C38623B09731}"/>
+                <a16:creationId xmlns:a16="http://schemas.microsoft.com/office/drawing/2014/main" id="{BFCE0C57-37F4-4BF7-A701-F40F14329512}"/>
               </a:ext>
             </a:extLst>
           </p:cNvPr>
@@ -36146,7 +36146,7 @@
           <p:cNvPr id="4" name="">
             <a:extLst xmlns:a="http://schemas.openxmlformats.org/drawingml/2006/main">
               <a:ext uri="{FF2B5EF4-FFF2-40B4-BE49-F238E27FC236}">
-                <a16:creationId xmlns:a16="http://schemas.microsoft.com/office/drawing/2014/main" id="{58D371F2-ABDD-44EC-9E68-A82C8A8AF33E}"/>
+                <a16:creationId xmlns:a16="http://schemas.microsoft.com/office/drawing/2014/main" id="{D4A9D87F-5C8C-49D7-8F69-F617BD89CA88}"/>
               </a:ext>
             </a:extLst>
           </p:cNvPr>
@@ -36177,7 +36177,7 @@
           <p:cNvPr id="5" name="">
             <a:extLst xmlns:a="http://schemas.openxmlformats.org/drawingml/2006/main">
               <a:ext uri="{FF2B5EF4-FFF2-40B4-BE49-F238E27FC236}">
-                <a16:creationId xmlns:a16="http://schemas.microsoft.com/office/drawing/2014/main" id="{78AF117B-0D38-426F-9DA1-00E813F1E9EF}"/>
+                <a16:creationId xmlns:a16="http://schemas.microsoft.com/office/drawing/2014/main" id="{F66050D7-6D2E-4D41-8112-653DF81D9D24}"/>
               </a:ext>
             </a:extLst>
           </p:cNvPr>
@@ -36334,7 +36334,7 @@
           <p:cNvPr id="6" name="">
             <a:extLst xmlns:a="http://schemas.openxmlformats.org/drawingml/2006/main">
               <a:ext uri="{FF2B5EF4-FFF2-40B4-BE49-F238E27FC236}">
-                <a16:creationId xmlns:a16="http://schemas.microsoft.com/office/drawing/2014/main" id="{FB7EF9C9-CF1F-4F8F-BDB8-13299881765F}"/>
+                <a16:creationId xmlns:a16="http://schemas.microsoft.com/office/drawing/2014/main" id="{054F3F17-1E29-411B-A29C-C3C2FB76D94E}"/>
               </a:ext>
             </a:extLst>
           </p:cNvPr>
@@ -36489,7 +36489,7 @@
     </p:spTree>
     <p:extLst>
       <p:ext uri="{BB962C8B-B14F-4D97-AF65-F5344CB8AC3E}">
-        <p14:creationId xmlns:p14="http://schemas.microsoft.com/office/powerpoint/2010/main" val="1536228693"/>
+        <p14:creationId xmlns:p14="http://schemas.microsoft.com/office/powerpoint/2010/main" val="2107593989"/>
       </p:ext>
     </p:extLst>
   </p:cSld>
@@ -36520,7 +36520,7 @@
           <p:cNvPr id="7" name="">
             <a:extLst xmlns:a="http://schemas.openxmlformats.org/drawingml/2006/main">
               <a:ext uri="{FF2B5EF4-FFF2-40B4-BE49-F238E27FC236}">
-                <a16:creationId xmlns:a16="http://schemas.microsoft.com/office/drawing/2014/main" id="{308FB6F7-A105-41C7-BBB3-58D1E14AACC9}"/>
+                <a16:creationId xmlns:a16="http://schemas.microsoft.com/office/drawing/2014/main" id="{5F0B58D2-F5DB-472D-90F2-1EA90E55B365}"/>
               </a:ext>
             </a:extLst>
           </p:cNvPr>
@@ -36551,7 +36551,7 @@
           <p:cNvPr id="2" name="">
             <a:extLst xmlns:a="http://schemas.openxmlformats.org/drawingml/2006/main">
               <a:ext uri="{FF2B5EF4-FFF2-40B4-BE49-F238E27FC236}">
-                <a16:creationId xmlns:a16="http://schemas.microsoft.com/office/drawing/2014/main" id="{5453915D-50FA-4330-A219-81BDE6FEC795}"/>
+                <a16:creationId xmlns:a16="http://schemas.microsoft.com/office/drawing/2014/main" id="{8C3180D5-FAA3-42C2-A7AD-A43F362E6744}"/>
               </a:ext>
             </a:extLst>
           </p:cNvPr>
@@ -36582,7 +36582,7 @@
           <p:cNvPr id="3" name="">
             <a:extLst xmlns:a="http://schemas.openxmlformats.org/drawingml/2006/main">
               <a:ext uri="{FF2B5EF4-FFF2-40B4-BE49-F238E27FC236}">
-                <a16:creationId xmlns:a16="http://schemas.microsoft.com/office/drawing/2014/main" id="{FD70E78A-805F-4D5C-B833-622FBA8FCAB5}"/>
+                <a16:creationId xmlns:a16="http://schemas.microsoft.com/office/drawing/2014/main" id="{CBD458CD-472E-4C76-80CC-DC4CEB608623}"/>
               </a:ext>
             </a:extLst>
           </p:cNvPr>
@@ -36762,7 +36762,7 @@
           <p:cNvPr id="4" name="">
             <a:extLst xmlns:a="http://schemas.openxmlformats.org/drawingml/2006/main">
               <a:ext uri="{FF2B5EF4-FFF2-40B4-BE49-F238E27FC236}">
-                <a16:creationId xmlns:a16="http://schemas.microsoft.com/office/drawing/2014/main" id="{DB440550-ECE2-4528-A8AF-125772530E75}"/>
+                <a16:creationId xmlns:a16="http://schemas.microsoft.com/office/drawing/2014/main" id="{D30E9031-182C-4EB3-9E1E-01B8D09CFF4A}"/>
               </a:ext>
             </a:extLst>
           </p:cNvPr>
@@ -36793,7 +36793,7 @@
           <p:cNvPr id="5" name="">
             <a:extLst xmlns:a="http://schemas.openxmlformats.org/drawingml/2006/main">
               <a:ext uri="{FF2B5EF4-FFF2-40B4-BE49-F238E27FC236}">
-                <a16:creationId xmlns:a16="http://schemas.microsoft.com/office/drawing/2014/main" id="{F543DDC0-BAC7-4E92-A2C6-54842184583D}"/>
+                <a16:creationId xmlns:a16="http://schemas.microsoft.com/office/drawing/2014/main" id="{C22A58C5-71D4-45E5-89AA-4BC299D8B2FA}"/>
               </a:ext>
             </a:extLst>
           </p:cNvPr>
@@ -36950,7 +36950,7 @@
           <p:cNvPr id="6" name="">
             <a:extLst xmlns:a="http://schemas.openxmlformats.org/drawingml/2006/main">
               <a:ext uri="{FF2B5EF4-FFF2-40B4-BE49-F238E27FC236}">
-                <a16:creationId xmlns:a16="http://schemas.microsoft.com/office/drawing/2014/main" id="{A506B1A3-AEDA-47C8-A7E8-69C917A5D504}"/>
+                <a16:creationId xmlns:a16="http://schemas.microsoft.com/office/drawing/2014/main" id="{0F64743D-9AED-431C-B5AD-A097FC2F945F}"/>
               </a:ext>
             </a:extLst>
           </p:cNvPr>
@@ -37105,7 +37105,7 @@
     </p:spTree>
     <p:extLst>
       <p:ext uri="{BB962C8B-B14F-4D97-AF65-F5344CB8AC3E}">
-        <p14:creationId xmlns:p14="http://schemas.microsoft.com/office/powerpoint/2010/main" val="1654157801"/>
+        <p14:creationId xmlns:p14="http://schemas.microsoft.com/office/powerpoint/2010/main" val="772053756"/>
       </p:ext>
     </p:extLst>
   </p:cSld>

</xml_diff>